<commit_message>
Poster: fold in source caveats and refit the columns
- Validation panel names the estimators that have no external reference
  and are checked only against inlined kernels and identities.
- Monte Carlo panel says the calibrated statistic is the shipped pipeline
  with its default drift removal, and states the Mod-Totvar / TotHvar
  R-squared margin as the code comment does.
- Fig. 1 regime labels follow the fixture's identified noise exponents
  (white / flicker PM at short tau, flicker FM at long tau).
- Fig. 5 caption says the timings are kernel-only.
- Drop the version tag from the byline: the MHTOTDEV coefficients belong
  to the unreleased L = 4m kernel, not to 0.5.0.
- Shrink the references strip and a few figure heights so all three
  columns end above it.

Co-Authored-By: Claude Fable 5.1 <noreply@anthropic.com>
Claude-Session: https://claude.ai/code/session_012uJVDqousov9TiLyrGUADf
</commit_message>
<xml_diff>
--- a/poster/SigmaTau_poster_draft.pptx
+++ b/poster/SigmaTau_poster_draft.pptx
@@ -1027,7 +1027,7 @@
                 <a:ea typeface="Calibri" pitchFamily="34" charset="-122"/>
                 <a:cs typeface="Calibri" pitchFamily="34" charset="-120"/>
               </a:rPr>
-              <a:t>     The University of Alabama   ·   github.com/ianlap/SigmaTau.jl   ·   v0.5.0, MIT license</a:t>
+              <a:t>     The University of Alabama   ·   github.com/ianlap/SigmaTau.jl   ·   MIT license</a:t>
             </a:r>
             <a:endParaRPr lang="en-US" sz="3000" dirty="0"/>
           </a:p>
@@ -1153,7 +1153,7 @@
                 <a:ea typeface="Calibri" pitchFamily="34" charset="-122"/>
                 <a:cs typeface="Calibri" pitchFamily="34" charset="-120"/>
               </a:rPr>
-              <a:t>A usable stability point therefore needs four quantities computed together: the deviation, the noise type at that τ, the equivalent degrees of freedom (EDF), and the χ² interval they imply.</a:t>
+              <a:t>A usable stability point therefore needs four quantities computed together: the deviation, the noise type at that τ, the equivalent degrees of freedom (EDF) and the χ² interval.</a:t>
             </a:r>
             <a:endParaRPr lang="en-US" sz="2400" dirty="0"/>
           </a:p>
@@ -1168,7 +1168,7 @@
         <p:spPr>
           <a:xfrm>
             <a:off x="914400" y="9097010"/>
-            <a:ext cx="11094720" cy="13530771"/>
+            <a:ext cx="11094720" cy="13606971"/>
           </a:xfrm>
           <a:prstGeom prst="rect">
             <a:avLst/>
@@ -1232,7 +1232,7 @@
         <p:spPr>
           <a:xfrm>
             <a:off x="1234440" y="10591292"/>
-            <a:ext cx="10454640" cy="4653280"/>
+            <a:ext cx="10454640" cy="5003800"/>
           </a:xfrm>
           <a:prstGeom prst="rect">
             <a:avLst/>
@@ -1274,7 +1274,7 @@
                 <a:ea typeface="Calibri" pitchFamily="34" charset="-122"/>
                 <a:cs typeface="Calibri" pitchFamily="34" charset="-120"/>
               </a:rPr>
-              <a:t>Allan, modified Allan and time deviations; Hadamard, modified Hadamard and Hadamard time; five totals; Thêo1/ThêoBR/ThêoH; MTIE, TIE rms, PDEV; time-resolved and real-time variants.</a:t>
+              <a:t>Allan, modified Allan, time; Hadamard, modified Hadamard, Hadamard time; five totals; Thêo1/ThêoBR/ThêoH; MTIE, TIE rms, PDEV; time-resolved and real-time variants.</a:t>
             </a:r>
             <a:endParaRPr lang="en-US" sz="2400" dirty="0"/>
           </a:p>
@@ -1344,7 +1344,7 @@
                 <a:ea typeface="Calibri" pitchFamily="34" charset="-122"/>
                 <a:cs typeface="Calibri" pitchFamily="34" charset="-120"/>
               </a:rPr>
-              <a:t>Greenhall–Riley 2003 for the difference families; the published total-variance tables (SP1065; Howe et al.) for TOTDEV, MTOTDEV and HTOTDEV; Monte Carlo for MHTOTDEV (column 2).</a:t>
+              <a:t>Greenhall–Riley 2003 for the difference families; the published total-variance tables (SP1065; Howe et al.) for TOTDEV, MTOTDEV and HTOTDEV, with documented fallbacks outside their ranges; Monte Carlo for MHTOTDEV (column 2).</a:t>
             </a:r>
             <a:endParaRPr lang="en-US" sz="2400" dirty="0"/>
           </a:p>
@@ -1436,8 +1436,8 @@
         </p:blipFill>
         <p:spPr>
           <a:xfrm>
-            <a:off x="2459603" y="15354300"/>
-            <a:ext cx="8004313" cy="5943600"/>
+            <a:off x="2644318" y="15704820"/>
+            <a:ext cx="7634883" cy="5669280"/>
           </a:xfrm>
           <a:prstGeom prst="rect">
             <a:avLst/>
@@ -1452,7 +1452,7 @@
         </p:nvSpPr>
         <p:spPr>
           <a:xfrm>
-            <a:off x="1234440" y="21407628"/>
+            <a:off x="1234440" y="21483828"/>
             <a:ext cx="10454640" cy="900112"/>
           </a:xfrm>
           <a:prstGeom prst="rect">
@@ -1477,7 +1477,7 @@
                 <a:ea typeface="Calibri" pitchFamily="34" charset="-122"/>
                 <a:cs typeface="Calibri" pitchFamily="34" charset="-120"/>
               </a:rPr>
-              <a:t>Fig. 1. Deviation suite on the shipped 8192-point validation record (τ₀ = 1 s) with 68.3 % χ² intervals. MDEV rolls white PM off as τ^−3/2; the totals reach τ = T/4 with tighter long-τ intervals.</a:t>
+              <a:t>Fig. 1. Deviation suite on the shipped 8192-point validation record (τ₀ = 1 s) with 68.3 % χ² intervals. MDEV rolls white PM off as τ^−3/2 and separates it from flicker PM; the totals reach τ = T/4 with tighter long-τ intervals.</a:t>
             </a:r>
             <a:endParaRPr lang="en-US" sz="1950" dirty="0"/>
           </a:p>
@@ -1491,7 +1491,7 @@
         </p:nvSpPr>
         <p:spPr>
           <a:xfrm>
-            <a:off x="914400" y="23039261"/>
+            <a:off x="914400" y="23115461"/>
             <a:ext cx="11094720" cy="3634105"/>
           </a:xfrm>
           <a:prstGeom prst="rect">
@@ -1516,7 +1516,7 @@
         </p:nvSpPr>
         <p:spPr>
           <a:xfrm>
-            <a:off x="1234440" y="23359301"/>
+            <a:off x="1234440" y="23435501"/>
             <a:ext cx="10454640" cy="527685"/>
           </a:xfrm>
           <a:prstGeom prst="rect">
@@ -1555,7 +1555,7 @@
         </p:nvSpPr>
         <p:spPr>
           <a:xfrm>
-            <a:off x="1234440" y="24051578"/>
+            <a:off x="1234440" y="24127778"/>
             <a:ext cx="10454640" cy="2283460"/>
           </a:xfrm>
           <a:prstGeom prst="rect">
@@ -1598,7 +1598,7 @@
                 <a:ea typeface="Calibri" pitchFamily="34" charset="-122"/>
                 <a:cs typeface="Calibri" pitchFamily="34" charset="-120"/>
               </a:rPr>
-              <a:t>ADEV, MDEV, HDEV and MHDEV accumulate in O(1) per sample per τ (Dobrogowski–Kasznia 2007, extended to third differences) from a ring buffer of at most 4·m_max + 1 samples; the running estimate equals the batch kernel on the samples seen so far.</a:t>
+              <a:t>ADEV, MDEV, HDEV and MHDEV accumulate in O(1) per sample per τ (Dobrogowski–Kasznia 2007, extended to third differences) from a ring buffer of at most 4·m_max + 1 samples; the running deviation equals the batch kernel on the samples seen so far.</a:t>
             </a:r>
             <a:endParaRPr lang="en-US" sz="2400" dirty="0"/>
           </a:p>
@@ -1633,7 +1633,7 @@
                 <a:ea typeface="Calibri" pitchFamily="34" charset="-122"/>
                 <a:cs typeface="Calibri" pitchFamily="34" charset="-120"/>
               </a:rPr>
-              <a:t>dynamic σ(t, τ) maps for non-stationary records; N-cornered hat for N ≥ 3 clocks.</a:t>
+              <a:t>dynamic σ(t, τ) maps for non-stationary records; N-cornered hat for N ≥ 3 clocks with independent noises.</a:t>
             </a:r>
             <a:endParaRPr lang="en-US" sz="2400" dirty="0"/>
           </a:p>
@@ -1648,7 +1648,7 @@
         <p:spPr>
           <a:xfrm>
             <a:off x="12740640" y="4206240"/>
-            <a:ext cx="11094720" cy="9370886"/>
+            <a:ext cx="11094720" cy="9096566"/>
           </a:xfrm>
           <a:prstGeom prst="rect">
             <a:avLst/>
@@ -1761,8 +1761,8 @@
         </p:blipFill>
         <p:spPr>
           <a:xfrm>
-            <a:off x="15547099" y="7654290"/>
-            <a:ext cx="5481802" cy="4023360"/>
+            <a:off x="15733979" y="7654290"/>
+            <a:ext cx="5108042" cy="3749040"/>
           </a:xfrm>
           <a:prstGeom prst="rect">
             <a:avLst/>
@@ -1777,7 +1777,7 @@
         </p:nvSpPr>
         <p:spPr>
           <a:xfrm>
-            <a:off x="13060680" y="11787378"/>
+            <a:off x="13060680" y="11513058"/>
             <a:ext cx="10454640" cy="1469708"/>
           </a:xfrm>
           <a:prstGeom prst="rect">
@@ -1802,7 +1802,7 @@
                 <a:ea typeface="Calibri" pitchFamily="34" charset="-122"/>
                 <a:cs typeface="Calibri" pitchFamily="34" charset="-120"/>
               </a:rPr>
-              <a:t>Fig. 2. Construction (Greenhall scheme, as for MTOTDEV and HTOTDEV): each of the N − 4m + 1 windows of length L = 4m has its half-mean slope removed and is extended by two time-reversed copies; the modified third difference is averaged over m positions, squared, normalised by 6m²τ², and averaged over all windows. The public call first removes the record's least-squares frequency drift.</a:t>
+              <a:t>Fig. 2. Construction (Greenhall scheme, as for MTOTDEV and HTOTDEV): each of the N − 4m + 1 windows of length L = 4m has its half-mean slope removed and is extended by two time-reversed copies; the third difference at lag m is averaged over m positions, squared, normalised by 6m²τ² and averaged over all windows. The public call first removes the record's least-squares frequency drift.</a:t>
             </a:r>
             <a:endParaRPr lang="en-US" sz="1950" dirty="0"/>
           </a:p>
@@ -1816,8 +1816,8 @@
         </p:nvSpPr>
         <p:spPr>
           <a:xfrm>
-            <a:off x="12740640" y="13988605"/>
-            <a:ext cx="11094720" cy="12673076"/>
+            <a:off x="12740640" y="13714285"/>
+            <a:ext cx="11094720" cy="13236956"/>
           </a:xfrm>
           <a:prstGeom prst="rect">
             <a:avLst/>
@@ -1841,7 +1841,7 @@
         </p:nvSpPr>
         <p:spPr>
           <a:xfrm>
-            <a:off x="13060680" y="14308645"/>
+            <a:off x="13060680" y="14034325"/>
             <a:ext cx="10454640" cy="1009650"/>
           </a:xfrm>
           <a:prstGeom prst="rect">
@@ -1880,8 +1880,8 @@
         </p:nvSpPr>
         <p:spPr>
           <a:xfrm>
-            <a:off x="13060680" y="15482887"/>
-            <a:ext cx="10454640" cy="3423920"/>
+            <a:off x="13060680" y="15208567"/>
+            <a:ext cx="10454640" cy="4124960"/>
           </a:xfrm>
           <a:prstGeom prst="rect">
             <a:avLst/>
@@ -1923,7 +1923,7 @@
                 <a:ea typeface="Calibri" pitchFamily="34" charset="-122"/>
                 <a:cs typeface="Calibri" pitchFamily="34" charset="-120"/>
               </a:rPr>
-              <a:t>α ∈ {+2, +1, 0, −1, −2}; N ∈ {1024, …, 32768}; octave m grid; R = 3000 realizations per cell; one independent random stream per (seed, α, N, r).</a:t>
+              <a:t>α ∈ {+2, +1, 0, −1, −2}; N ∈ {1024, …, 32768}; octave m grid; R = 3000 realizations per cell; one independent random stream per (seed, α, N, r). The statistic calibrated is the shipped pipeline, including its default drift removal.</a:t>
             </a:r>
             <a:endParaRPr lang="en-US" sz="2400" dirty="0"/>
           </a:p>
@@ -1993,7 +1993,7 @@
                 <a:ea typeface="Calibri" pitchFamily="34" charset="-122"/>
                 <a:cs typeface="Calibri" pitchFamily="34" charset="-120"/>
               </a:rPr>
-              <a:t>over τ/τ₀ ≥ 16, the validity window of the total-variance literature. EDF ν = b T/τ − c (Mod-Totvar; the TotHvar form fits no better than ΔR² = 8 × 10⁻⁴) and bias B = b₀ + b₁ τ/T, both by weighted least squares.</a:t>
+              <a:t>over τ/τ₀ ≥ 16, the validity window of the total-variance literature. EDF ν = b T/τ − c (Mod-Totvar; the TotHvar form is better by at most ΔR² = 8 × 10⁻⁴, at α = ±2) and bias B = b₀ + b₁ τ/T, both by weighted least squares.</a:t>
             </a:r>
             <a:endParaRPr lang="en-US" sz="2400" dirty="0"/>
           </a:p>
@@ -2015,8 +2015,8 @@
         </p:blipFill>
         <p:spPr>
           <a:xfrm>
-            <a:off x="13498188" y="19016535"/>
-            <a:ext cx="4215143" cy="3657600"/>
+            <a:off x="13577222" y="19443255"/>
+            <a:ext cx="4057075" cy="3520440"/>
           </a:xfrm>
           <a:prstGeom prst="rect">
             <a:avLst/>
@@ -2039,8 +2039,8 @@
         </p:blipFill>
         <p:spPr>
           <a:xfrm>
-            <a:off x="18864876" y="19016535"/>
-            <a:ext cx="4210729" cy="3657600"/>
+            <a:off x="18943827" y="19443255"/>
+            <a:ext cx="4052826" cy="3520440"/>
           </a:xfrm>
           <a:prstGeom prst="rect">
             <a:avLst/>
@@ -2055,7 +2055,7 @@
         </p:nvSpPr>
         <p:spPr>
           <a:xfrm>
-            <a:off x="13060680" y="22783864"/>
+            <a:off x="13060680" y="23073423"/>
             <a:ext cx="10454640" cy="1184910"/>
           </a:xfrm>
           <a:prstGeom prst="rect">
@@ -2101,7 +2101,7 @@
           </p:nvPr>
         </p:nvGraphicFramePr>
         <p:xfrm>
-          <a:off x="13060680" y="24060213"/>
+          <a:off x="13060680" y="24349773"/>
           <a:ext cx="10454640" cy="914400"/>
         </p:xfrm>
         <a:graphic>
@@ -4998,7 +4998,7 @@
         <p:spPr>
           <a:xfrm>
             <a:off x="24566880" y="4206240"/>
-            <a:ext cx="11094720" cy="9883331"/>
+            <a:ext cx="11094720" cy="10477690"/>
           </a:xfrm>
           <a:prstGeom prst="rect">
             <a:avLst/>
@@ -5062,7 +5062,7 @@
         <p:spPr>
           <a:xfrm>
             <a:off x="24886920" y="5700522"/>
-            <a:ext cx="10454640" cy="2194560"/>
+            <a:ext cx="10454640" cy="3246120"/>
           </a:xfrm>
           <a:prstGeom prst="rect">
             <a:avLst/>
@@ -5089,7 +5089,7 @@
                 <a:ea typeface="Calibri" pitchFamily="34" charset="-122"/>
                 <a:cs typeface="Calibri" pitchFamily="34" charset="-120"/>
               </a:rPr>
-              <a:t>On the shipped record, ADEV, MDEV, TDEV and HDEV match Stable32 to ≤ 0.005 % (its five-significant-figure output) and allantools to ≤ 1 × 10⁻¹³; the raw total kernels match allantools to ≤ 4.4 × 10⁻¹⁵. Confidence bounds agree with Stable32 to ≤ 0.05 % at 11 of 12 τ. The one recurring residual is a convention: at τ = 256 s Stable32 assigns α = +2 where the detrended identifier assigns α = 0; one keyword reproduces Stable32 at every τ.</a:t>
+              <a:t>On the shipped 8192-point record, ADEV, MDEV, TDEV and HDEV match Stable32 to ≤ 0.005 % (its five-significant-figure output) and allantools to ≤ 1 × 10⁻¹³; the raw total kernels match allantools to ≤ 4.4 × 10⁻¹⁵. Confidence bounds agree with Stable32 to ≤ 0.05 % at 11 of 12 τ. The one recurring residual is a convention: at τ = 256 s Stable32 assigns α = +2 where the detrended identifier assigns α = 0; one keyword reproduces Stable32 at every τ. Estimators neither reference implements (MHDEV, HTDEV, MHTOTDEV, ThêoH, nch, dynamic, streaming) are checked against inlined textbook kernels and algebraic identities.</a:t>
             </a:r>
             <a:endParaRPr lang="en-US" sz="2400" dirty="0"/>
           </a:p>
@@ -5111,8 +5111,8 @@
         </p:blipFill>
         <p:spPr>
           <a:xfrm>
-            <a:off x="25891351" y="8004810"/>
-            <a:ext cx="8445777" cy="4754880"/>
+            <a:off x="26297398" y="9056370"/>
+            <a:ext cx="7633683" cy="4297680"/>
           </a:xfrm>
           <a:prstGeom prst="rect">
             <a:avLst/>
@@ -5127,7 +5127,7 @@
         </p:nvSpPr>
         <p:spPr>
           <a:xfrm>
-            <a:off x="24886920" y="12869418"/>
+            <a:off x="24886920" y="13463778"/>
             <a:ext cx="10454640" cy="900112"/>
           </a:xfrm>
           <a:prstGeom prst="rect">
@@ -5166,8 +5166,8 @@
         </p:nvSpPr>
         <p:spPr>
           <a:xfrm>
-            <a:off x="24566880" y="14501051"/>
-            <a:ext cx="11094720" cy="8984171"/>
+            <a:off x="24566880" y="15095410"/>
+            <a:ext cx="11094720" cy="8618411"/>
           </a:xfrm>
           <a:prstGeom prst="rect">
             <a:avLst/>
@@ -5191,7 +5191,7 @@
         </p:nvSpPr>
         <p:spPr>
           <a:xfrm>
-            <a:off x="24886920" y="14821090"/>
+            <a:off x="24886920" y="15415450"/>
             <a:ext cx="10454640" cy="1009650"/>
           </a:xfrm>
           <a:prstGeom prst="rect">
@@ -5230,7 +5230,7 @@
         </p:nvSpPr>
         <p:spPr>
           <a:xfrm>
-            <a:off x="24886920" y="15995333"/>
+            <a:off x="24886920" y="16589692"/>
             <a:ext cx="10454640" cy="1844040"/>
           </a:xfrm>
           <a:prstGeom prst="rect">
@@ -5280,8 +5280,8 @@
         </p:blipFill>
         <p:spPr>
           <a:xfrm>
-            <a:off x="26361342" y="17949101"/>
-            <a:ext cx="7505795" cy="4206240"/>
+            <a:off x="26687681" y="18543461"/>
+            <a:ext cx="6853118" cy="3840480"/>
           </a:xfrm>
           <a:prstGeom prst="rect">
             <a:avLst/>
@@ -5296,7 +5296,7 @@
         </p:nvSpPr>
         <p:spPr>
           <a:xfrm>
-            <a:off x="24886920" y="22265069"/>
+            <a:off x="24886920" y="22493669"/>
             <a:ext cx="10454640" cy="900112"/>
           </a:xfrm>
           <a:prstGeom prst="rect">
@@ -5321,7 +5321,7 @@
                 <a:ea typeface="Calibri" pitchFamily="34" charset="-122"/>
                 <a:cs typeface="Calibri" pitchFamily="34" charset="-120"/>
               </a:rPr>
-              <a:t>Fig. 5. Speed-up per kernel on an N = 25 000 white-PM record (bench/, mean of 30 realizations, 12 cores; diamonds: independent 4-core re-run). Ratios are the portable result; absolute times depend on the machine.</a:t>
+              <a:t>Fig. 5. Kernel-only speed-up (no intervals, raw totals) on an N = 25 000 white-PM record (bench/, mean of 30 realizations, 12 cores; diamonds: independent 4-core re-run). Ratios are the portable result; absolute times depend on the machine.</a:t>
             </a:r>
             <a:endParaRPr lang="en-US" sz="1950" dirty="0"/>
           </a:p>
@@ -5335,7 +5335,7 @@
         </p:nvSpPr>
         <p:spPr>
           <a:xfrm>
-            <a:off x="24566880" y="23896701"/>
+            <a:off x="24566880" y="24125301"/>
             <a:ext cx="11094720" cy="2933065"/>
           </a:xfrm>
           <a:prstGeom prst="rect">
@@ -5360,7 +5360,7 @@
         </p:nvSpPr>
         <p:spPr>
           <a:xfrm>
-            <a:off x="24886920" y="24216741"/>
+            <a:off x="24886920" y="24445341"/>
             <a:ext cx="10454640" cy="527685"/>
           </a:xfrm>
           <a:prstGeom prst="rect">
@@ -5399,7 +5399,7 @@
         </p:nvSpPr>
         <p:spPr>
           <a:xfrm>
-            <a:off x="24886920" y="24909018"/>
+            <a:off x="24886920" y="25137618"/>
             <a:ext cx="10454640" cy="1582420"/>
           </a:xfrm>
           <a:prstGeom prst="rect">
@@ -5477,7 +5477,7 @@
                 <a:ea typeface="Calibri" pitchFamily="34" charset="-122"/>
                 <a:cs typeface="Calibri" pitchFamily="34" charset="-120"/>
               </a:rPr>
-              <a:t>extend the Monte Carlo method to the Thêo family and to gapped records.</a:t>
+              <a:t>extend the Monte Carlo method to the Thêo family and gapped records.</a:t>
             </a:r>
             <a:endParaRPr lang="en-US" sz="2400" dirty="0"/>
           </a:p>
@@ -5491,7 +5491,7 @@
         </p:nvSpPr>
         <p:spPr>
           <a:xfrm>
-            <a:off x="914400" y="26791920"/>
+            <a:off x="914400" y="27066240"/>
             <a:ext cx="34747200" cy="0"/>
           </a:xfrm>
           <a:prstGeom prst="line">
@@ -5514,8 +5514,8 @@
         </p:nvSpPr>
         <p:spPr>
           <a:xfrm>
-            <a:off x="914400" y="26929080"/>
-            <a:ext cx="12508992" cy="1600200"/>
+            <a:off x="914400" y="27203400"/>
+            <a:ext cx="12508992" cy="1325880"/>
           </a:xfrm>
           <a:prstGeom prst="rect">
             <a:avLst/>
@@ -5633,8 +5633,8 @@
         </p:nvSpPr>
         <p:spPr>
           <a:xfrm>
-            <a:off x="13697712" y="26929080"/>
-            <a:ext cx="12508992" cy="1600200"/>
+            <a:off x="13697712" y="27203400"/>
+            <a:ext cx="12508992" cy="1325880"/>
           </a:xfrm>
           <a:prstGeom prst="rect">
             <a:avLst/>
@@ -5732,8 +5732,8 @@
         </p:nvSpPr>
         <p:spPr>
           <a:xfrm>
-            <a:off x="26481024" y="26929080"/>
-            <a:ext cx="9180576" cy="1600200"/>
+            <a:off x="26481024" y="27203400"/>
+            <a:ext cx="9180576" cy="1325880"/>
           </a:xfrm>
           <a:prstGeom prst="rect">
             <a:avLst/>

</xml_diff>

<commit_message>
Poster: real subscript/superscript runs instead of S_y / τ^−3/2 markers
Co-Authored-By: Claude Fable 5.1 <noreply@anthropic.com>
Claude-Session: https://claude.ai/code/session_012uJVDqousov9TiLyrGUADf
</commit_message>
<xml_diff>
--- a/poster/SigmaTau_poster_draft.pptx
+++ b/poster/SigmaTau_poster_draft.pptx
@@ -1133,7 +1133,63 @@
                 <a:ea typeface="Calibri" pitchFamily="34" charset="-122"/>
                 <a:cs typeface="Calibri" pitchFamily="34" charset="-120"/>
               </a:rPr>
-              <a:t>Clock noise is power-law, S_y(f) ∝ f^α with α ∈ {+2, +1, 0, −1, −2} (white PM to random-walk FM). From N phase samples at spacing τ₀, the number of independent samples at averaging time τ = mτ₀ is not N/m: it depends on the noise type, on τ/T and on the estimator.</a:t>
+              <a:t>Clock noise is power-law, S</a:t>
+            </a:r>
+            <a:pPr indent="0" marL="0">
+              <a:buNone/>
+            </a:pPr>
+            <a:r>
+              <a:rPr lang="en-US" sz="2400" baseline="-40000" dirty="0">
+                <a:solidFill>
+                  <a:srgbClr val="0B0B0B"/>
+                </a:solidFill>
+                <a:latin typeface="Calibri" pitchFamily="34" charset="0"/>
+                <a:ea typeface="Calibri" pitchFamily="34" charset="-122"/>
+                <a:cs typeface="Calibri" pitchFamily="34" charset="-120"/>
+              </a:rPr>
+              <a:t>y</a:t>
+            </a:r>
+            <a:pPr indent="0" marL="0">
+              <a:buNone/>
+            </a:pPr>
+            <a:r>
+              <a:rPr lang="en-US" sz="2400" dirty="0">
+                <a:solidFill>
+                  <a:srgbClr val="0B0B0B"/>
+                </a:solidFill>
+                <a:latin typeface="Calibri" pitchFamily="34" charset="0"/>
+                <a:ea typeface="Calibri" pitchFamily="34" charset="-122"/>
+                <a:cs typeface="Calibri" pitchFamily="34" charset="-120"/>
+              </a:rPr>
+              <a:t>(f) ∝ f</a:t>
+            </a:r>
+            <a:pPr indent="0" marL="0">
+              <a:buNone/>
+            </a:pPr>
+            <a:r>
+              <a:rPr lang="en-US" sz="2400" baseline="30000" dirty="0">
+                <a:solidFill>
+                  <a:srgbClr val="0B0B0B"/>
+                </a:solidFill>
+                <a:latin typeface="Calibri" pitchFamily="34" charset="0"/>
+                <a:ea typeface="Calibri" pitchFamily="34" charset="-122"/>
+                <a:cs typeface="Calibri" pitchFamily="34" charset="-120"/>
+              </a:rPr>
+              <a:t>α</a:t>
+            </a:r>
+            <a:pPr indent="0" marL="0">
+              <a:buNone/>
+            </a:pPr>
+            <a:r>
+              <a:rPr lang="en-US" sz="2400" dirty="0">
+                <a:solidFill>
+                  <a:srgbClr val="0B0B0B"/>
+                </a:solidFill>
+                <a:latin typeface="Calibri" pitchFamily="34" charset="0"/>
+                <a:ea typeface="Calibri" pitchFamily="34" charset="-122"/>
+                <a:cs typeface="Calibri" pitchFamily="34" charset="-120"/>
+              </a:rPr>
+              <a:t> with α ∈ {+2, +1, 0, −1, −2} (white PM to random-walk FM). From N phase samples at spacing τ₀, the number of independent samples at averaging time τ = mτ₀ is not N/m: it depends on the noise type, on τ/T and on the estimator.</a:t>
             </a:r>
             <a:endParaRPr lang="en-US" sz="2400" dirty="0"/>
           </a:p>
@@ -1477,7 +1533,35 @@
                 <a:ea typeface="Calibri" pitchFamily="34" charset="-122"/>
                 <a:cs typeface="Calibri" pitchFamily="34" charset="-120"/>
               </a:rPr>
-              <a:t>Fig. 1. Deviation suite on the shipped 8192-point validation record (τ₀ = 1 s) with 68.3 % χ² intervals. MDEV rolls white PM off as τ^−3/2 and separates it from flicker PM; the totals reach τ = T/4 with tighter long-τ intervals.</a:t>
+              <a:t>Fig. 1. Deviation suite on the shipped 8192-point validation record (τ₀ = 1 s) with 68.3 % χ² intervals. MDEV rolls white PM off as τ</a:t>
+            </a:r>
+            <a:pPr indent="0" marL="0">
+              <a:buNone/>
+            </a:pPr>
+            <a:r>
+              <a:rPr lang="en-US" sz="1950" baseline="30000" dirty="0">
+                <a:solidFill>
+                  <a:srgbClr val="52514E"/>
+                </a:solidFill>
+                <a:latin typeface="Calibri" pitchFamily="34" charset="0"/>
+                <a:ea typeface="Calibri" pitchFamily="34" charset="-122"/>
+                <a:cs typeface="Calibri" pitchFamily="34" charset="-120"/>
+              </a:rPr>
+              <a:t>−3/2</a:t>
+            </a:r>
+            <a:pPr indent="0" marL="0">
+              <a:buNone/>
+            </a:pPr>
+            <a:r>
+              <a:rPr lang="en-US" sz="1950" dirty="0">
+                <a:solidFill>
+                  <a:srgbClr val="52514E"/>
+                </a:solidFill>
+                <a:latin typeface="Calibri" pitchFamily="34" charset="0"/>
+                <a:ea typeface="Calibri" pitchFamily="34" charset="-122"/>
+                <a:cs typeface="Calibri" pitchFamily="34" charset="-120"/>
+              </a:rPr>
+              <a:t> and separates it from flicker PM; the totals reach τ = T/4 with tighter long-τ intervals.</a:t>
             </a:r>
             <a:endParaRPr lang="en-US" sz="1950" dirty="0"/>
           </a:p>
@@ -1598,7 +1682,35 @@
                 <a:ea typeface="Calibri" pitchFamily="34" charset="-122"/>
                 <a:cs typeface="Calibri" pitchFamily="34" charset="-120"/>
               </a:rPr>
-              <a:t>ADEV, MDEV, HDEV and MHDEV accumulate in O(1) per sample per τ (Dobrogowski–Kasznia 2007, extended to third differences) from a ring buffer of at most 4·m_max + 1 samples; the running deviation equals the batch kernel on the samples seen so far.</a:t>
+              <a:t>ADEV, MDEV, HDEV and MHDEV accumulate in O(1) per sample per τ (Dobrogowski–Kasznia 2007, extended to third differences) from a ring buffer of at most 4·m</a:t>
+            </a:r>
+            <a:pPr indent="0" marL="0">
+              <a:buNone/>
+            </a:pPr>
+            <a:r>
+              <a:rPr lang="en-US" sz="2400" baseline="-40000" dirty="0">
+                <a:solidFill>
+                  <a:srgbClr val="0B0B0B"/>
+                </a:solidFill>
+                <a:latin typeface="Calibri" pitchFamily="34" charset="0"/>
+                <a:ea typeface="Calibri" pitchFamily="34" charset="-122"/>
+                <a:cs typeface="Calibri" pitchFamily="34" charset="-120"/>
+              </a:rPr>
+              <a:t>max</a:t>
+            </a:r>
+            <a:pPr indent="0" marL="0">
+              <a:buNone/>
+            </a:pPr>
+            <a:r>
+              <a:rPr lang="en-US" sz="2400" dirty="0">
+                <a:solidFill>
+                  <a:srgbClr val="0B0B0B"/>
+                </a:solidFill>
+                <a:latin typeface="Calibri" pitchFamily="34" charset="0"/>
+                <a:ea typeface="Calibri" pitchFamily="34" charset="-122"/>
+                <a:cs typeface="Calibri" pitchFamily="34" charset="-120"/>
+              </a:rPr>
+              <a:t> + 1 samples; the running deviation equals the batch kernel on the samples seen so far.</a:t>
             </a:r>
             <a:endParaRPr lang="en-US" sz="2400" dirty="0"/>
           </a:p>
@@ -1958,7 +2070,35 @@
                 <a:ea typeface="Calibri" pitchFamily="34" charset="-122"/>
                 <a:cs typeface="Calibri" pitchFamily="34" charset="-120"/>
               </a:rPr>
-              <a:t>MHDEV on the same realization (its EDF follows from the Greenhall–Riley spectral sum). Bias B = E[MHTOTVAR] / E[MHVAR]; EDF = 2 V̄² / s_V², bootstrap standard error ≈ √(2/R) = 2.6 %.</a:t>
+              <a:t>MHDEV on the same realization (its EDF follows from the Greenhall–Riley spectral sum). Bias B = E[MHTOTVAR] / E[MHVAR]; EDF = 2 mean(V)</a:t>
+            </a:r>
+            <a:pPr indent="0" marL="0">
+              <a:buNone/>
+            </a:pPr>
+            <a:r>
+              <a:rPr lang="en-US" sz="2400" baseline="30000" dirty="0">
+                <a:solidFill>
+                  <a:srgbClr val="0B0B0B"/>
+                </a:solidFill>
+                <a:latin typeface="Calibri" pitchFamily="34" charset="0"/>
+                <a:ea typeface="Calibri" pitchFamily="34" charset="-122"/>
+                <a:cs typeface="Calibri" pitchFamily="34" charset="-120"/>
+              </a:rPr>
+              <a:t>2</a:t>
+            </a:r>
+            <a:pPr indent="0" marL="0">
+              <a:buNone/>
+            </a:pPr>
+            <a:r>
+              <a:rPr lang="en-US" sz="2400" dirty="0">
+                <a:solidFill>
+                  <a:srgbClr val="0B0B0B"/>
+                </a:solidFill>
+                <a:latin typeface="Calibri" pitchFamily="34" charset="0"/>
+                <a:ea typeface="Calibri" pitchFamily="34" charset="-122"/>
+                <a:cs typeface="Calibri" pitchFamily="34" charset="-120"/>
+              </a:rPr>
+              <a:t> / var(V), bootstrap standard error ≈ √(2/R) = 2.6 %.</a:t>
             </a:r>
             <a:endParaRPr lang="en-US" sz="2400" dirty="0"/>
           </a:p>

</xml_diff>

<commit_message>
Poster: re-aim at expert partners; fix helper paths and module resolution
Lead with what the library offers and the evidence for it: the estimator
inventory and API, the feature comparison with Stable32 and allantools,
validation, the benchmark, then the MHTOTDEV calibration and
reproducibility. The background panel on finite records is gone.

Codex review: the two helper scripts derive the repository root from
their own location, build_poster.js resolves pptxgenjs through the
module path (poster/package.json declares it), and the Fig. 1 caption
states the plotted totals' actual reach limits.

Co-Authored-By: Claude Fable 5.1 <noreply@anthropic.com>
Claude-Session: https://claude.ai/code/session_012uJVDqousov9TiLyrGUADf
</commit_message>
<xml_diff>
--- a/poster/SigmaTau_poster_draft.pptx
+++ b/poster/SigmaTau_poster_draft.pptx
@@ -909,7 +909,7 @@
         <p:spPr>
           <a:xfrm>
             <a:off x="914400" y="320040"/>
-            <a:ext cx="34747200" cy="1920240"/>
+            <a:ext cx="34747200" cy="1234440"/>
           </a:xfrm>
           <a:prstGeom prst="rect">
             <a:avLst/>
@@ -935,7 +935,7 @@
                 <a:ea typeface="Calibri" pitchFamily="34" charset="-122"/>
                 <a:cs typeface="Calibri" pitchFamily="34" charset="-120"/>
               </a:rPr>
-              <a:t>Frequency stability with quantified uncertainty: per-τ noise identification, χ² intervals, and a calibrated modified-Hadamard total deviation</a:t>
+              <a:t>SigmaTau.jl: unified, validated and fast time-and-frequency stability analysis in Julia</a:t>
             </a:r>
             <a:endParaRPr lang="en-US" sz="6000" dirty="0"/>
           </a:p>
@@ -949,8 +949,8 @@
         </p:nvSpPr>
         <p:spPr>
           <a:xfrm>
-            <a:off x="914400" y="2286000"/>
-            <a:ext cx="34747200" cy="502920"/>
+            <a:off x="914400" y="1645920"/>
+            <a:ext cx="34747200" cy="1097280"/>
           </a:xfrm>
           <a:prstGeom prst="rect">
             <a:avLst/>
@@ -966,7 +966,7 @@
               <a:buNone/>
             </a:pPr>
             <a:r>
-              <a:rPr lang="en-US" sz="3000" i="1" dirty="0">
+              <a:rPr lang="en-US" sz="2800" dirty="0">
                 <a:solidFill>
                   <a:srgbClr val="FFFFFF"/>
                 </a:solidFill>
@@ -974,9 +974,9 @@
                 <a:ea typeface="Calibri" pitchFamily="34" charset="-122"/>
                 <a:cs typeface="Calibri" pitchFamily="34" charset="-120"/>
               </a:rPr>
-              <a:t>SigmaTau.jl, an open and validated time-and-frequency stability library in Julia</a:t>
+              <a:t>Every estimator family with per-τ noise identification, EDF and χ² intervals in one call · matches Stable32 and allantools · modified-total kernels 1,600 to 4,200× faster · a new Monte-Carlo-calibrated MHTOTDEV</a:t>
             </a:r>
-            <a:endParaRPr lang="en-US" sz="3000" dirty="0"/>
+            <a:endParaRPr lang="en-US" sz="2800" dirty="0"/>
           </a:p>
         </p:txBody>
       </p:sp>
@@ -1027,7 +1027,7 @@
                 <a:ea typeface="Calibri" pitchFamily="34" charset="-122"/>
                 <a:cs typeface="Calibri" pitchFamily="34" charset="-120"/>
               </a:rPr>
-              <a:t>     The University of Alabama   ·   github.com/ianlap/SigmaTau.jl   ·   MIT license</a:t>
+              <a:t>     The University of Alabama   ·   github.com/ianlap/SigmaTau.jl   ·   MIT license   ·   Julia ≥ 1.11</a:t>
             </a:r>
             <a:endParaRPr lang="en-US" sz="3000" dirty="0"/>
           </a:p>
@@ -1042,7 +1042,7 @@
         <p:spPr>
           <a:xfrm>
             <a:off x="914400" y="4206240"/>
-            <a:ext cx="11094720" cy="4479290"/>
+            <a:ext cx="11094720" cy="13876020"/>
           </a:xfrm>
           <a:prstGeom prst="rect">
             <a:avLst/>
@@ -1091,7 +1091,7 @@
                 <a:ea typeface="Calibri" pitchFamily="34" charset="-122"/>
                 <a:cs typeface="Calibri" pitchFamily="34" charset="-120"/>
               </a:rPr>
-              <a:t>A clock record is finite, so every σ(τ) point is an estimate with an interval</a:t>
+              <a:t>One API, every estimator, a χ² interval with every point</a:t>
             </a:r>
             <a:endParaRPr lang="en-US" sz="3300" dirty="0"/>
           </a:p>
@@ -1099,14 +1099,14 @@
       </p:sp>
       <p:sp>
         <p:nvSpPr>
-          <p:cNvPr id="8" name="Body"/>
+          <p:cNvPr id="8" name="Bullets"/>
           <p:cNvSpPr txBox="1"/>
           <p:nvPr/>
         </p:nvSpPr>
         <p:spPr>
           <a:xfrm>
             <a:off x="1234440" y="5700522"/>
-            <a:ext cx="10454640" cy="2646680"/>
+            <a:ext cx="10454640" cy="5615940"/>
           </a:xfrm>
           <a:prstGeom prst="rect">
             <a:avLst/>
@@ -1118,10 +1118,25 @@
           <a:bodyPr wrap="square" lIns="0" tIns="0" rIns="0" bIns="0" rtlCol="0" anchor="t"/>
           <a:lstStyle/>
           <a:p>
+            <a:pPr marL="279400" indent="-279400">
+              <a:spcAft>
+                <a:spcPts val="700"/>
+              </a:spcAft>
+              <a:buSzPct val="100000"/>
+              <a:buChar char="•"/>
+            </a:pPr>
+            <a:r>
+              <a:rPr lang="en-US" sz="2400" b="1" dirty="0">
+                <a:solidFill>
+                  <a:srgbClr val="0B0B0B"/>
+                </a:solidFill>
+                <a:latin typeface="Calibri" pitchFamily="34" charset="0"/>
+                <a:ea typeface="Calibri" pitchFamily="34" charset="-122"/>
+                <a:cs typeface="Calibri" pitchFamily="34" charset="-120"/>
+              </a:rPr>
+              <a:t>Allan: </a:t>
+            </a:r>
             <a:pPr indent="0" marL="0">
-              <a:spcAft>
-                <a:spcPts val="800"/>
-              </a:spcAft>
               <a:buNone/>
             </a:pPr>
             <a:r>
@@ -1133,7 +1148,7 @@
                 <a:ea typeface="Calibri" pitchFamily="34" charset="-122"/>
                 <a:cs typeface="Calibri" pitchFamily="34" charset="-120"/>
               </a:rPr>
-              <a:t>Clock noise is power-law, S</a:t>
+              <a:t>ADEV, MDEV, TDEV.  Hadamard: HDEV, MHDEV, HTDEV.  Total: TOTDEV, MTOTDEV, TTOTDEV, HTOTDEV, MHTOTDEV.  Thêo1 / ThêoBR / ThêoH.  MTIE, TIE rms, PDEV.  Time-resolved DADEV / DHDEV.  Real-time ADEV / MDEV / HDEV / MHDEV.  N-cornered hat.  S</a:t>
             </a:r>
             <a:pPr indent="0" marL="0">
               <a:buNone/>
@@ -1161,13 +1176,13 @@
                 <a:ea typeface="Calibri" pitchFamily="34" charset="-122"/>
                 <a:cs typeface="Calibri" pitchFamily="34" charset="-120"/>
               </a:rPr>
-              <a:t>(f) ∝ f</a:t>
+              <a:t>, S</a:t>
             </a:r>
             <a:pPr indent="0" marL="0">
               <a:buNone/>
             </a:pPr>
             <a:r>
-              <a:rPr lang="en-US" sz="2400" baseline="30000" dirty="0">
+              <a:rPr lang="en-US" sz="2400" baseline="-40000" dirty="0">
                 <a:solidFill>
                   <a:srgbClr val="0B0B0B"/>
                 </a:solidFill>
@@ -1175,7 +1190,7 @@
                 <a:ea typeface="Calibri" pitchFamily="34" charset="-122"/>
                 <a:cs typeface="Calibri" pitchFamily="34" charset="-120"/>
               </a:rPr>
-              <a:t>α</a:t>
+              <a:t>x</a:t>
             </a:r>
             <a:pPr indent="0" marL="0">
               <a:buNone/>
@@ -1189,148 +1204,7 @@
                 <a:ea typeface="Calibri" pitchFamily="34" charset="-122"/>
                 <a:cs typeface="Calibri" pitchFamily="34" charset="-120"/>
               </a:rPr>
-              <a:t> with α ∈ {+2, +1, 0, −1, −2} (white PM to random-walk FM). From N phase samples at spacing τ₀, the number of independent samples at averaging time τ = mτ₀ is not N/m: it depends on the noise type, on τ/T and on the estimator.</a:t>
-            </a:r>
-            <a:endParaRPr lang="en-US" sz="2400" dirty="0"/>
-          </a:p>
-          <a:p>
-            <a:pPr indent="0" marL="0">
-              <a:spcAft>
-                <a:spcPts val="800"/>
-              </a:spcAft>
-              <a:buNone/>
-            </a:pPr>
-            <a:r>
-              <a:rPr lang="en-US" sz="2400" dirty="0">
-                <a:solidFill>
-                  <a:srgbClr val="0B0B0B"/>
-                </a:solidFill>
-                <a:latin typeface="Calibri" pitchFamily="34" charset="0"/>
-                <a:ea typeface="Calibri" pitchFamily="34" charset="-122"/>
-                <a:cs typeface="Calibri" pitchFamily="34" charset="-120"/>
-              </a:rPr>
-              <a:t>A usable stability point therefore needs four quantities computed together: the deviation, the noise type at that τ, the equivalent degrees of freedom (EDF) and the χ² interval.</a:t>
-            </a:r>
-            <a:endParaRPr lang="en-US" sz="2400" dirty="0"/>
-          </a:p>
-        </p:txBody>
-      </p:sp>
-      <p:sp>
-        <p:nvSpPr>
-          <p:cNvPr id="9" name="Shape 7"/>
-          <p:cNvSpPr/>
-          <p:nvPr/>
-        </p:nvSpPr>
-        <p:spPr>
-          <a:xfrm>
-            <a:off x="914400" y="9097010"/>
-            <a:ext cx="11094720" cy="13606971"/>
-          </a:xfrm>
-          <a:prstGeom prst="rect">
-            <a:avLst/>
-          </a:prstGeom>
-          <a:solidFill>
-            <a:srgbClr val="FFFFFF"/>
-          </a:solidFill>
-          <a:ln w="12700">
-            <a:solidFill>
-              <a:srgbClr val="D9D4D0"/>
-            </a:solidFill>
-            <a:prstDash val="solid"/>
-          </a:ln>
-        </p:spPr>
-      </p:sp>
-      <p:sp>
-        <p:nvSpPr>
-          <p:cNvPr id="10" name="Heading"/>
-          <p:cNvSpPr txBox="1"/>
-          <p:nvPr/>
-        </p:nvSpPr>
-        <p:spPr>
-          <a:xfrm>
-            <a:off x="1234440" y="9417050"/>
-            <a:ext cx="10454640" cy="1009650"/>
-          </a:xfrm>
-          <a:prstGeom prst="rect">
-            <a:avLst/>
-          </a:prstGeom>
-          <a:noFill/>
-          <a:ln/>
-        </p:spPr>
-        <p:txBody>
-          <a:bodyPr wrap="square" lIns="0" tIns="0" rIns="0" bIns="0" rtlCol="0" anchor="t"/>
-          <a:lstStyle/>
-          <a:p>
-            <a:pPr indent="0" marL="0">
-              <a:buNone/>
-            </a:pPr>
-            <a:r>
-              <a:rPr lang="en-US" sz="3300" b="1" dirty="0">
-                <a:solidFill>
-                  <a:srgbClr val="9E1B32"/>
-                </a:solidFill>
-                <a:latin typeface="Calibri" pitchFamily="34" charset="0"/>
-                <a:ea typeface="Calibri" pitchFamily="34" charset="-122"/>
-                <a:cs typeface="Calibri" pitchFamily="34" charset="-120"/>
-              </a:rPr>
-              <a:t>One call returns deviation, noise type, EDF and interval at every τ</a:t>
-            </a:r>
-            <a:endParaRPr lang="en-US" sz="3300" dirty="0"/>
-          </a:p>
-        </p:txBody>
-      </p:sp>
-      <p:sp>
-        <p:nvSpPr>
-          <p:cNvPr id="11" name="Bullets"/>
-          <p:cNvSpPr txBox="1"/>
-          <p:nvPr/>
-        </p:nvSpPr>
-        <p:spPr>
-          <a:xfrm>
-            <a:off x="1234440" y="10591292"/>
-            <a:ext cx="10454640" cy="5003800"/>
-          </a:xfrm>
-          <a:prstGeom prst="rect">
-            <a:avLst/>
-          </a:prstGeom>
-          <a:noFill/>
-          <a:ln/>
-        </p:spPr>
-        <p:txBody>
-          <a:bodyPr wrap="square" lIns="0" tIns="0" rIns="0" bIns="0" rtlCol="0" anchor="t"/>
-          <a:lstStyle/>
-          <a:p>
-            <a:pPr marL="279400" indent="-279400">
-              <a:spcAft>
-                <a:spcPts val="700"/>
-              </a:spcAft>
-              <a:buSzPct val="100000"/>
-              <a:buChar char="•"/>
-            </a:pPr>
-            <a:r>
-              <a:rPr lang="en-US" sz="2400" b="1" dirty="0">
-                <a:solidFill>
-                  <a:srgbClr val="0B0B0B"/>
-                </a:solidFill>
-                <a:latin typeface="Calibri" pitchFamily="34" charset="0"/>
-                <a:ea typeface="Calibri" pitchFamily="34" charset="-122"/>
-                <a:cs typeface="Calibri" pitchFamily="34" charset="-120"/>
-              </a:rPr>
-              <a:t>Estimators: </a:t>
-            </a:r>
-            <a:pPr indent="0" marL="0">
-              <a:buNone/>
-            </a:pPr>
-            <a:r>
-              <a:rPr lang="en-US" sz="2400" dirty="0">
-                <a:solidFill>
-                  <a:srgbClr val="0B0B0B"/>
-                </a:solidFill>
-                <a:latin typeface="Calibri" pitchFamily="34" charset="0"/>
-                <a:ea typeface="Calibri" pitchFamily="34" charset="-122"/>
-                <a:cs typeface="Calibri" pitchFamily="34" charset="-120"/>
-              </a:rPr>
-              <a:t>Allan, modified Allan, time; Hadamard, modified Hadamard, Hadamard time; five totals; Thêo1/ThêoBR/ThêoH; MTIE, TIE rms, PDEV; time-resolved and real-time variants.</a:t>
+              <a:t>, ℒ(f), calibrated power-law synthesis.</a:t>
             </a:r>
             <a:endParaRPr lang="en-US" sz="2400" dirty="0"/>
           </a:p>
@@ -1351,7 +1225,7 @@
                 <a:ea typeface="Calibri" pitchFamily="34" charset="-122"/>
                 <a:cs typeface="Calibri" pitchFamily="34" charset="-120"/>
               </a:rPr>
-              <a:t>Noise type per τ: </a:t>
+              <a:t>Per τ, in the same call: </a:t>
             </a:r>
             <a:pPr indent="0" marL="0">
               <a:buNone/>
@@ -1365,7 +1239,7 @@
                 <a:ea typeface="Calibri" pitchFamily="34" charset="-122"/>
                 <a:cs typeface="Calibri" pitchFamily="34" charset="-120"/>
               </a:rPr>
-              <a:t>lag-1 autocorrelation of the m-decimated, quadratically detrended phase differences, with the B1 / R(n) ratio as fallback.</a:t>
+              <a:t>the deviation, the noise type (lag-1 autocorrelation with B1 / R(n) fallback), the Greenhall–Riley EDF, and the χ² bounds at 68.3 % (switchable). Total-family bias corrections are on by default and switchable.</a:t>
             </a:r>
             <a:endParaRPr lang="en-US" sz="2400" dirty="0"/>
           </a:p>
@@ -1386,7 +1260,7 @@
                 <a:ea typeface="Calibri" pitchFamily="34" charset="-122"/>
                 <a:cs typeface="Calibri" pitchFamily="34" charset="-120"/>
               </a:rPr>
-              <a:t>EDF: </a:t>
+              <a:t>Input: </a:t>
             </a:r>
             <a:pPr indent="0" marL="0">
               <a:buNone/>
@@ -1400,7 +1274,7 @@
                 <a:ea typeface="Calibri" pitchFamily="34" charset="-122"/>
                 <a:cs typeface="Calibri" pitchFamily="34" charset="-120"/>
               </a:rPr>
-              <a:t>Greenhall–Riley 2003 for the difference families; the published total-variance tables (SP1065; Howe et al.) for TOTDEV, MTOTDEV and HTOTDEV, with documented fallbacks outside their ranges; Monte Carlo for MHTOTDEV (column 2).</a:t>
+              <a:t>phase or frequency, any τ grid; read, detrend, gap-fill and outlier tools; plain-text round-trip of results.</a:t>
             </a:r>
             <a:endParaRPr lang="en-US" sz="2400" dirty="0"/>
           </a:p>
@@ -1421,7 +1295,7 @@
                 <a:ea typeface="Calibri" pitchFamily="34" charset="-122"/>
                 <a:cs typeface="Calibri" pitchFamily="34" charset="-120"/>
               </a:rPr>
-              <a:t>Interval: </a:t>
+              <a:t>Real-time and multi-clock: </a:t>
             </a:r>
             <a:pPr indent="0" marL="0">
               <a:buNone/>
@@ -1435,254 +1309,7 @@
                 <a:ea typeface="Calibri" pitchFamily="34" charset="-122"/>
                 <a:cs typeface="Calibri" pitchFamily="34" charset="-120"/>
               </a:rPr>
-              <a:t>χ² bounds on σ² with ν = EDF, 68.3 % by default. Total-family bias corrections are applied by default and switchable.</a:t>
-            </a:r>
-            <a:endParaRPr lang="en-US" sz="2400" dirty="0"/>
-          </a:p>
-          <a:p>
-            <a:pPr marL="279400" indent="-279400">
-              <a:spcAft>
-                <a:spcPts val="700"/>
-              </a:spcAft>
-              <a:buSzPct val="100000"/>
-              <a:buChar char="•"/>
-            </a:pPr>
-            <a:r>
-              <a:rPr lang="en-US" sz="2400" b="1" dirty="0">
-                <a:solidFill>
-                  <a:srgbClr val="0B0B0B"/>
-                </a:solidFill>
-                <a:latin typeface="Calibri" pitchFamily="34" charset="0"/>
-                <a:ea typeface="Calibri" pitchFamily="34" charset="-122"/>
-                <a:cs typeface="Calibri" pitchFamily="34" charset="-120"/>
-              </a:rPr>
-              <a:t>Definitions: </a:t>
-            </a:r>
-            <a:pPr indent="0" marL="0">
-              <a:buNone/>
-            </a:pPr>
-            <a:r>
-              <a:rPr lang="en-US" sz="2400" dirty="0">
-                <a:solidFill>
-                  <a:srgbClr val="0B0B0B"/>
-                </a:solidFill>
-                <a:latin typeface="Calibri" pitchFamily="34" charset="0"/>
-                <a:ea typeface="Calibri" pitchFamily="34" charset="-122"/>
-                <a:cs typeface="Calibri" pitchFamily="34" charset="-120"/>
-              </a:rPr>
-              <a:t>NIST SP1065 and IEEE Std 1139-2022; every departure from a reference is a named, documented switch.</a:t>
-            </a:r>
-            <a:endParaRPr lang="en-US" sz="2400" dirty="0"/>
-          </a:p>
-        </p:txBody>
-      </p:sp>
-      <p:pic>
-        <p:nvPicPr>
-          <p:cNvPr id="12" name="F1_suite" descr="/home/user/SigmaTau.jl/poster/figures/F1_suite.png">    </p:cNvPr>
-          <p:cNvPicPr>
-            <a:picLocks noChangeAspect="1"/>
-          </p:cNvPicPr>
-          <p:nvPr/>
-        </p:nvPicPr>
-        <p:blipFill>
-          <a:blip r:embed="rId1"/>
-          <a:stretch>
-            <a:fillRect/>
-          </a:stretch>
-        </p:blipFill>
-        <p:spPr>
-          <a:xfrm>
-            <a:off x="2644318" y="15704820"/>
-            <a:ext cx="7634883" cy="5669280"/>
-          </a:xfrm>
-          <a:prstGeom prst="rect">
-            <a:avLst/>
-          </a:prstGeom>
-        </p:spPr>
-      </p:pic>
-      <p:sp>
-        <p:nvSpPr>
-          <p:cNvPr id="13" name="Caption"/>
-          <p:cNvSpPr txBox="1"/>
-          <p:nvPr/>
-        </p:nvSpPr>
-        <p:spPr>
-          <a:xfrm>
-            <a:off x="1234440" y="21483828"/>
-            <a:ext cx="10454640" cy="900112"/>
-          </a:xfrm>
-          <a:prstGeom prst="rect">
-            <a:avLst/>
-          </a:prstGeom>
-          <a:noFill/>
-          <a:ln/>
-        </p:spPr>
-        <p:txBody>
-          <a:bodyPr wrap="square" lIns="0" tIns="0" rIns="0" bIns="0" rtlCol="0" anchor="t"/>
-          <a:lstStyle/>
-          <a:p>
-            <a:pPr indent="0" marL="0">
-              <a:buNone/>
-            </a:pPr>
-            <a:r>
-              <a:rPr lang="en-US" sz="1950" dirty="0">
-                <a:solidFill>
-                  <a:srgbClr val="52514E"/>
-                </a:solidFill>
-                <a:latin typeface="Calibri" pitchFamily="34" charset="0"/>
-                <a:ea typeface="Calibri" pitchFamily="34" charset="-122"/>
-                <a:cs typeface="Calibri" pitchFamily="34" charset="-120"/>
-              </a:rPr>
-              <a:t>Fig. 1. Deviation suite on the shipped 8192-point validation record (τ₀ = 1 s) with 68.3 % χ² intervals. MDEV rolls white PM off as τ</a:t>
-            </a:r>
-            <a:pPr indent="0" marL="0">
-              <a:buNone/>
-            </a:pPr>
-            <a:r>
-              <a:rPr lang="en-US" sz="1950" baseline="30000" dirty="0">
-                <a:solidFill>
-                  <a:srgbClr val="52514E"/>
-                </a:solidFill>
-                <a:latin typeface="Calibri" pitchFamily="34" charset="0"/>
-                <a:ea typeface="Calibri" pitchFamily="34" charset="-122"/>
-                <a:cs typeface="Calibri" pitchFamily="34" charset="-120"/>
-              </a:rPr>
-              <a:t>−3/2</a:t>
-            </a:r>
-            <a:pPr indent="0" marL="0">
-              <a:buNone/>
-            </a:pPr>
-            <a:r>
-              <a:rPr lang="en-US" sz="1950" dirty="0">
-                <a:solidFill>
-                  <a:srgbClr val="52514E"/>
-                </a:solidFill>
-                <a:latin typeface="Calibri" pitchFamily="34" charset="0"/>
-                <a:ea typeface="Calibri" pitchFamily="34" charset="-122"/>
-                <a:cs typeface="Calibri" pitchFamily="34" charset="-120"/>
-              </a:rPr>
-              <a:t> and separates it from flicker PM; the totals reach τ = T/4 with tighter long-τ intervals.</a:t>
-            </a:r>
-            <a:endParaRPr lang="en-US" sz="1950" dirty="0"/>
-          </a:p>
-        </p:txBody>
-      </p:sp>
-      <p:sp>
-        <p:nvSpPr>
-          <p:cNvPr id="14" name="Shape 11"/>
-          <p:cNvSpPr/>
-          <p:nvPr/>
-        </p:nvSpPr>
-        <p:spPr>
-          <a:xfrm>
-            <a:off x="914400" y="23115461"/>
-            <a:ext cx="11094720" cy="3634105"/>
-          </a:xfrm>
-          <a:prstGeom prst="rect">
-            <a:avLst/>
-          </a:prstGeom>
-          <a:solidFill>
-            <a:srgbClr val="FFFFFF"/>
-          </a:solidFill>
-          <a:ln w="12700">
-            <a:solidFill>
-              <a:srgbClr val="D9D4D0"/>
-            </a:solidFill>
-            <a:prstDash val="solid"/>
-          </a:ln>
-        </p:spPr>
-      </p:sp>
-      <p:sp>
-        <p:nvSpPr>
-          <p:cNvPr id="15" name="Heading"/>
-          <p:cNvSpPr txBox="1"/>
-          <p:nvPr/>
-        </p:nvSpPr>
-        <p:spPr>
-          <a:xfrm>
-            <a:off x="1234440" y="23435501"/>
-            <a:ext cx="10454640" cy="527685"/>
-          </a:xfrm>
-          <a:prstGeom prst="rect">
-            <a:avLst/>
-          </a:prstGeom>
-          <a:noFill/>
-          <a:ln/>
-        </p:spPr>
-        <p:txBody>
-          <a:bodyPr wrap="square" lIns="0" tIns="0" rIns="0" bIns="0" rtlCol="0" anchor="t"/>
-          <a:lstStyle/>
-          <a:p>
-            <a:pPr indent="0" marL="0">
-              <a:buNone/>
-            </a:pPr>
-            <a:r>
-              <a:rPr lang="en-US" sz="3300" b="1" dirty="0">
-                <a:solidFill>
-                  <a:srgbClr val="9E1B32"/>
-                </a:solidFill>
-                <a:latin typeface="Calibri" pitchFamily="34" charset="0"/>
-                <a:ea typeface="Calibri" pitchFamily="34" charset="-122"/>
-                <a:cs typeface="Calibri" pitchFamily="34" charset="-120"/>
-              </a:rPr>
-              <a:t>Real-time and multi-clock use</a:t>
-            </a:r>
-            <a:endParaRPr lang="en-US" sz="3300" dirty="0"/>
-          </a:p>
-        </p:txBody>
-      </p:sp>
-      <p:sp>
-        <p:nvSpPr>
-          <p:cNvPr id="16" name="Bullets"/>
-          <p:cNvSpPr txBox="1"/>
-          <p:nvPr/>
-        </p:nvSpPr>
-        <p:spPr>
-          <a:xfrm>
-            <a:off x="1234440" y="24127778"/>
-            <a:ext cx="10454640" cy="2283460"/>
-          </a:xfrm>
-          <a:prstGeom prst="rect">
-            <a:avLst/>
-          </a:prstGeom>
-          <a:noFill/>
-          <a:ln/>
-        </p:spPr>
-        <p:txBody>
-          <a:bodyPr wrap="square" lIns="0" tIns="0" rIns="0" bIns="0" rtlCol="0" anchor="t"/>
-          <a:lstStyle/>
-          <a:p>
-            <a:pPr marL="279400" indent="-279400">
-              <a:spcAft>
-                <a:spcPts val="700"/>
-              </a:spcAft>
-              <a:buSzPct val="100000"/>
-              <a:buChar char="•"/>
-            </a:pPr>
-            <a:r>
-              <a:rPr lang="en-US" sz="2400" b="1" dirty="0">
-                <a:solidFill>
-                  <a:srgbClr val="0B0B0B"/>
-                </a:solidFill>
-                <a:latin typeface="Calibri" pitchFamily="34" charset="0"/>
-                <a:ea typeface="Calibri" pitchFamily="34" charset="-122"/>
-                <a:cs typeface="Calibri" pitchFamily="34" charset="-120"/>
-              </a:rPr>
-              <a:t>Streaming: </a:t>
-            </a:r>
-            <a:pPr indent="0" marL="0">
-              <a:buNone/>
-            </a:pPr>
-            <a:r>
-              <a:rPr lang="en-US" sz="2400" dirty="0">
-                <a:solidFill>
-                  <a:srgbClr val="0B0B0B"/>
-                </a:solidFill>
-                <a:latin typeface="Calibri" pitchFamily="34" charset="0"/>
-                <a:ea typeface="Calibri" pitchFamily="34" charset="-122"/>
-                <a:cs typeface="Calibri" pitchFamily="34" charset="-120"/>
-              </a:rPr>
-              <a:t>ADEV, MDEV, HDEV and MHDEV accumulate in O(1) per sample per τ (Dobrogowski–Kasznia 2007, extended to third differences) from a ring buffer of at most 4·m</a:t>
+              <a:t>ADEV, MDEV, HDEV and MHDEV accumulate in O(1) per sample per τ from a ring buffer of at most 4·m</a:t>
             </a:r>
             <a:pPr indent="0" marL="0">
               <a:buNone/>
@@ -1710,42 +1337,7 @@
                 <a:ea typeface="Calibri" pitchFamily="34" charset="-122"/>
                 <a:cs typeface="Calibri" pitchFamily="34" charset="-120"/>
               </a:rPr>
-              <a:t> + 1 samples; the running deviation equals the batch kernel on the samples seen so far.</a:t>
-            </a:r>
-            <a:endParaRPr lang="en-US" sz="2400" dirty="0"/>
-          </a:p>
-          <a:p>
-            <a:pPr marL="279400" indent="-279400">
-              <a:spcAft>
-                <a:spcPts val="700"/>
-              </a:spcAft>
-              <a:buSzPct val="100000"/>
-              <a:buChar char="•"/>
-            </a:pPr>
-            <a:r>
-              <a:rPr lang="en-US" sz="2400" b="1" dirty="0">
-                <a:solidFill>
-                  <a:srgbClr val="0B0B0B"/>
-                </a:solidFill>
-                <a:latin typeface="Calibri" pitchFamily="34" charset="0"/>
-                <a:ea typeface="Calibri" pitchFamily="34" charset="-122"/>
-                <a:cs typeface="Calibri" pitchFamily="34" charset="-120"/>
-              </a:rPr>
-              <a:t>Time-resolved and ensemble: </a:t>
-            </a:r>
-            <a:pPr indent="0" marL="0">
-              <a:buNone/>
-            </a:pPr>
-            <a:r>
-              <a:rPr lang="en-US" sz="2400" dirty="0">
-                <a:solidFill>
-                  <a:srgbClr val="0B0B0B"/>
-                </a:solidFill>
-                <a:latin typeface="Calibri" pitchFamily="34" charset="0"/>
-                <a:ea typeface="Calibri" pitchFamily="34" charset="-122"/>
-                <a:cs typeface="Calibri" pitchFamily="34" charset="-120"/>
-              </a:rPr>
-              <a:t>dynamic σ(t, τ) maps for non-stationary records; N-cornered hat for N ≥ 3 clocks with independent noises.</a:t>
+              <a:t> + 1 samples and equal the batch kernels on the samples seen so far (Dobrogowski–Kasznia 2007, extended to third differences); dynamic σ(t, τ) maps; N-cornered hat for N ≥ 3 clocks.</a:t>
             </a:r>
             <a:endParaRPr lang="en-US" sz="2400" dirty="0"/>
           </a:p>
@@ -1753,14 +1345,2875 @@
       </p:sp>
       <p:sp>
         <p:nvSpPr>
-          <p:cNvPr id="17" name="Shape 14"/>
+          <p:cNvPr id="9" name="Shape 7"/>
           <p:cNvSpPr/>
           <p:nvPr/>
         </p:nvSpPr>
         <p:spPr>
           <a:xfrm>
-            <a:off x="12740640" y="4206240"/>
-            <a:ext cx="11094720" cy="9096566"/>
+            <a:off x="1234440" y="11426190"/>
+            <a:ext cx="10454640" cy="1215390"/>
+          </a:xfrm>
+          <a:prstGeom prst="roundRect">
+            <a:avLst>
+              <a:gd name="adj" fmla="val 6019"/>
+            </a:avLst>
+          </a:prstGeom>
+          <a:solidFill>
+            <a:srgbClr val="F4F4F2"/>
+          </a:solidFill>
+          <a:ln w="9525">
+            <a:solidFill>
+              <a:srgbClr val="D9D4D0"/>
+            </a:solidFill>
+            <a:prstDash val="solid"/>
+          </a:ln>
+        </p:spPr>
+      </p:sp>
+      <p:sp>
+        <p:nvSpPr>
+          <p:cNvPr id="10" name="Code"/>
+          <p:cNvSpPr txBox="1"/>
+          <p:nvPr/>
+        </p:nvSpPr>
+        <p:spPr>
+          <a:xfrm>
+            <a:off x="1417320" y="11535918"/>
+            <a:ext cx="10088880" cy="995934"/>
+          </a:xfrm>
+          <a:prstGeom prst="rect">
+            <a:avLst/>
+          </a:prstGeom>
+          <a:noFill/>
+          <a:ln/>
+        </p:spPr>
+        <p:txBody>
+          <a:bodyPr wrap="square" lIns="0" tIns="0" rIns="0" bIns="0" rtlCol="0" anchor="ctr"/>
+          <a:lstStyle/>
+          <a:p>
+            <a:pPr indent="0" marL="0">
+              <a:buNone/>
+            </a:pPr>
+            <a:r>
+              <a:rPr lang="en-US" sz="1900" dirty="0">
+                <a:solidFill>
+                  <a:srgbClr val="0B0B0B"/>
+                </a:solidFill>
+                <a:latin typeface="Courier New" pitchFamily="34" charset="0"/>
+                <a:ea typeface="Courier New" pitchFamily="34" charset="-122"/>
+                <a:cs typeface="Courier New" pitchFamily="34" charset="-120"/>
+              </a:rPr>
+              <a:t>p = read_phase("clock.DAT"; tau0 = 1.0)</a:t>
+            </a:r>
+            <a:endParaRPr lang="en-US" sz="1900" dirty="0"/>
+          </a:p>
+          <a:p>
+            <a:pPr indent="0" marL="0">
+              <a:buNone/>
+            </a:pPr>
+            <a:r>
+              <a:rPr lang="en-US" sz="1900" dirty="0">
+                <a:solidFill>
+                  <a:srgbClr val="0B0B0B"/>
+                </a:solidFill>
+                <a:latin typeface="Courier New" pitchFamily="34" charset="0"/>
+                <a:ea typeface="Courier New" pitchFamily="34" charset="-122"/>
+                <a:cs typeface="Courier New" pitchFamily="34" charset="-120"/>
+              </a:rPr>
+              <a:t>r = adev(p)            # τ grid, σ_y, noise type, EDF, CI</a:t>
+            </a:r>
+            <a:endParaRPr lang="en-US" sz="1900" dirty="0"/>
+          </a:p>
+          <a:p>
+            <a:pPr indent="0" marL="0">
+              <a:buNone/>
+            </a:pPr>
+            <a:r>
+              <a:rPr lang="en-US" sz="1900" dirty="0">
+                <a:solidFill>
+                  <a:srgbClr val="0B0B0B"/>
+                </a:solidFill>
+                <a:latin typeface="Courier New" pitchFamily="34" charset="0"/>
+                <a:ea typeface="Courier New" pitchFamily="34" charset="-122"/>
+                <a:cs typeface="Courier New" pitchFamily="34" charset="-120"/>
+              </a:rPr>
+              <a:t>suite = stability(p; devs = (:adev, :mdev, :hdev, :mhtotdev))</a:t>
+            </a:r>
+            <a:endParaRPr lang="en-US" sz="1900" dirty="0"/>
+          </a:p>
+        </p:txBody>
+      </p:sp>
+      <p:graphicFrame>
+        <p:nvGraphicFramePr>
+          <p:cNvPr id="2" name="Feature comparison"/>
+          <p:cNvGraphicFramePr>
+            <a:graphicFrameLocks noGrp="1"/>
+          </p:cNvGraphicFramePr>
+          <p:nvPr>
+            <p:extLst>
+              <p:ext uri="{D42A27DB-BD31-4B8C-83A1-F6EECF244321}">
+                <p14:modId xmlns:p14="http://schemas.microsoft.com/office/powerpoint/2010/main" val="1579011935"/>
+              </p:ext>
+            </p:extLst>
+          </p:nvPr>
+        </p:nvGraphicFramePr>
+        <p:xfrm>
+          <a:off x="1234440" y="12778740"/>
+          <a:ext cx="10454640" cy="914400"/>
+        </p:xfrm>
+        <a:graphic>
+          <a:graphicData uri="http://schemas.openxmlformats.org/drawingml/2006/table">
+            <a:tbl>
+              <a:tblPr/>
+              <a:tblGrid>
+                <a:gridCol w="3301465"/>
+                <a:gridCol w="2109269"/>
+                <a:gridCol w="2109269"/>
+                <a:gridCol w="2934636"/>
+              </a:tblGrid>
+              <a:tr h="384048">
+                <a:tc>
+                  <a:txBody>
+                    <a:bodyPr/>
+                    <a:lstStyle/>
+                    <a:p>
+                      <a:pPr algn="ctr" indent="0" marL="0">
+                        <a:buNone/>
+                      </a:pPr>
+                      <a:endParaRPr lang="en-US" sz="1800" dirty="0">
+                        <a:latin typeface="Calibri" charset="0"/>
+                        <a:ea typeface="Calibri" charset="0"/>
+                        <a:cs typeface="Calibri" charset="0"/>
+                      </a:endParaRPr>
+                    </a:p>
+                  </a:txBody>
+                  <a:tcPr marL="45720" marR="45720" marT="45720" marB="45720" anchor="ctr">
+                    <a:lnL w="9525" cap="flat" cmpd="sng" algn="ctr">
+                      <a:solidFill>
+                        <a:srgbClr val="D9D4D0"/>
+                      </a:solidFill>
+                      <a:prstDash val="solid"/>
+                      <a:round/>
+                      <a:headEnd type="none" w="med" len="med"/>
+                      <a:tailEnd type="none" w="med" len="med"/>
+                    </a:lnL>
+                    <a:lnR w="9525" cap="flat" cmpd="sng" algn="ctr">
+                      <a:solidFill>
+                        <a:srgbClr val="D9D4D0"/>
+                      </a:solidFill>
+                      <a:prstDash val="solid"/>
+                      <a:round/>
+                      <a:headEnd type="none" w="med" len="med"/>
+                      <a:tailEnd type="none" w="med" len="med"/>
+                    </a:lnR>
+                    <a:lnT w="9525" cap="flat" cmpd="sng" algn="ctr">
+                      <a:solidFill>
+                        <a:srgbClr val="D9D4D0"/>
+                      </a:solidFill>
+                      <a:prstDash val="solid"/>
+                      <a:round/>
+                      <a:headEnd type="none" w="med" len="med"/>
+                      <a:tailEnd type="none" w="med" len="med"/>
+                    </a:lnT>
+                    <a:lnB w="9525" cap="flat" cmpd="sng" algn="ctr">
+                      <a:solidFill>
+                        <a:srgbClr val="D9D4D0"/>
+                      </a:solidFill>
+                      <a:prstDash val="solid"/>
+                      <a:round/>
+                      <a:headEnd type="none" w="med" len="med"/>
+                      <a:tailEnd type="none" w="med" len="med"/>
+                    </a:lnB>
+                    <a:solidFill>
+                      <a:srgbClr val="9E1B32"/>
+                    </a:solidFill>
+                  </a:tcPr>
+                </a:tc>
+                <a:tc>
+                  <a:txBody>
+                    <a:bodyPr/>
+                    <a:lstStyle/>
+                    <a:p>
+                      <a:pPr algn="ctr" indent="0" marL="0">
+                        <a:buNone/>
+                      </a:pPr>
+                      <a:r>
+                        <a:rPr lang="en-US" sz="1800" b="1" dirty="0">
+                          <a:solidFill>
+                            <a:srgbClr val="FFFFFF"/>
+                          </a:solidFill>
+                          <a:latin typeface="Calibri" pitchFamily="34" charset="0"/>
+                          <a:ea typeface="Calibri" pitchFamily="34" charset="-122"/>
+                          <a:cs typeface="Calibri" pitchFamily="34" charset="-120"/>
+                        </a:rPr>
+                        <a:t>Stable32</a:t>
+                      </a:r>
+                      <a:endParaRPr lang="en-US" sz="1800" dirty="0">
+                        <a:latin typeface="Calibri" charset="0"/>
+                        <a:ea typeface="Calibri" charset="0"/>
+                        <a:cs typeface="Calibri" charset="0"/>
+                      </a:endParaRPr>
+                    </a:p>
+                  </a:txBody>
+                  <a:tcPr marL="45720" marR="45720" marT="45720" marB="45720" anchor="ctr">
+                    <a:lnL w="9525" cap="flat" cmpd="sng" algn="ctr">
+                      <a:solidFill>
+                        <a:srgbClr val="D9D4D0"/>
+                      </a:solidFill>
+                      <a:prstDash val="solid"/>
+                      <a:round/>
+                      <a:headEnd type="none" w="med" len="med"/>
+                      <a:tailEnd type="none" w="med" len="med"/>
+                    </a:lnL>
+                    <a:lnR w="9525" cap="flat" cmpd="sng" algn="ctr">
+                      <a:solidFill>
+                        <a:srgbClr val="D9D4D0"/>
+                      </a:solidFill>
+                      <a:prstDash val="solid"/>
+                      <a:round/>
+                      <a:headEnd type="none" w="med" len="med"/>
+                      <a:tailEnd type="none" w="med" len="med"/>
+                    </a:lnR>
+                    <a:lnT w="9525" cap="flat" cmpd="sng" algn="ctr">
+                      <a:solidFill>
+                        <a:srgbClr val="D9D4D0"/>
+                      </a:solidFill>
+                      <a:prstDash val="solid"/>
+                      <a:round/>
+                      <a:headEnd type="none" w="med" len="med"/>
+                      <a:tailEnd type="none" w="med" len="med"/>
+                    </a:lnT>
+                    <a:lnB w="9525" cap="flat" cmpd="sng" algn="ctr">
+                      <a:solidFill>
+                        <a:srgbClr val="D9D4D0"/>
+                      </a:solidFill>
+                      <a:prstDash val="solid"/>
+                      <a:round/>
+                      <a:headEnd type="none" w="med" len="med"/>
+                      <a:tailEnd type="none" w="med" len="med"/>
+                    </a:lnB>
+                    <a:solidFill>
+                      <a:srgbClr val="9E1B32"/>
+                    </a:solidFill>
+                  </a:tcPr>
+                </a:tc>
+                <a:tc>
+                  <a:txBody>
+                    <a:bodyPr/>
+                    <a:lstStyle/>
+                    <a:p>
+                      <a:pPr algn="ctr" indent="0" marL="0">
+                        <a:buNone/>
+                      </a:pPr>
+                      <a:r>
+                        <a:rPr lang="en-US" sz="1800" b="1" dirty="0">
+                          <a:solidFill>
+                            <a:srgbClr val="FFFFFF"/>
+                          </a:solidFill>
+                          <a:latin typeface="Calibri" pitchFamily="34" charset="0"/>
+                          <a:ea typeface="Calibri" pitchFamily="34" charset="-122"/>
+                          <a:cs typeface="Calibri" pitchFamily="34" charset="-120"/>
+                        </a:rPr>
+                        <a:t>allantools</a:t>
+                      </a:r>
+                      <a:endParaRPr lang="en-US" sz="1800" dirty="0">
+                        <a:latin typeface="Calibri" charset="0"/>
+                        <a:ea typeface="Calibri" charset="0"/>
+                        <a:cs typeface="Calibri" charset="0"/>
+                      </a:endParaRPr>
+                    </a:p>
+                  </a:txBody>
+                  <a:tcPr marL="45720" marR="45720" marT="45720" marB="45720" anchor="ctr">
+                    <a:lnL w="9525" cap="flat" cmpd="sng" algn="ctr">
+                      <a:solidFill>
+                        <a:srgbClr val="D9D4D0"/>
+                      </a:solidFill>
+                      <a:prstDash val="solid"/>
+                      <a:round/>
+                      <a:headEnd type="none" w="med" len="med"/>
+                      <a:tailEnd type="none" w="med" len="med"/>
+                    </a:lnL>
+                    <a:lnR w="9525" cap="flat" cmpd="sng" algn="ctr">
+                      <a:solidFill>
+                        <a:srgbClr val="D9D4D0"/>
+                      </a:solidFill>
+                      <a:prstDash val="solid"/>
+                      <a:round/>
+                      <a:headEnd type="none" w="med" len="med"/>
+                      <a:tailEnd type="none" w="med" len="med"/>
+                    </a:lnR>
+                    <a:lnT w="9525" cap="flat" cmpd="sng" algn="ctr">
+                      <a:solidFill>
+                        <a:srgbClr val="D9D4D0"/>
+                      </a:solidFill>
+                      <a:prstDash val="solid"/>
+                      <a:round/>
+                      <a:headEnd type="none" w="med" len="med"/>
+                      <a:tailEnd type="none" w="med" len="med"/>
+                    </a:lnT>
+                    <a:lnB w="9525" cap="flat" cmpd="sng" algn="ctr">
+                      <a:solidFill>
+                        <a:srgbClr val="D9D4D0"/>
+                      </a:solidFill>
+                      <a:prstDash val="solid"/>
+                      <a:round/>
+                      <a:headEnd type="none" w="med" len="med"/>
+                      <a:tailEnd type="none" w="med" len="med"/>
+                    </a:lnB>
+                    <a:solidFill>
+                      <a:srgbClr val="9E1B32"/>
+                    </a:solidFill>
+                  </a:tcPr>
+                </a:tc>
+                <a:tc>
+                  <a:txBody>
+                    <a:bodyPr/>
+                    <a:lstStyle/>
+                    <a:p>
+                      <a:pPr algn="ctr" indent="0" marL="0">
+                        <a:buNone/>
+                      </a:pPr>
+                      <a:r>
+                        <a:rPr lang="en-US" sz="1800" b="1" dirty="0">
+                          <a:solidFill>
+                            <a:srgbClr val="FFFFFF"/>
+                          </a:solidFill>
+                          <a:latin typeface="Calibri" pitchFamily="34" charset="0"/>
+                          <a:ea typeface="Calibri" pitchFamily="34" charset="-122"/>
+                          <a:cs typeface="Calibri" pitchFamily="34" charset="-120"/>
+                        </a:rPr>
+                        <a:t>SigmaTau</a:t>
+                      </a:r>
+                      <a:endParaRPr lang="en-US" sz="1800" dirty="0">
+                        <a:latin typeface="Calibri" charset="0"/>
+                        <a:ea typeface="Calibri" charset="0"/>
+                        <a:cs typeface="Calibri" charset="0"/>
+                      </a:endParaRPr>
+                    </a:p>
+                  </a:txBody>
+                  <a:tcPr marL="45720" marR="45720" marT="45720" marB="45720" anchor="ctr">
+                    <a:lnL w="9525" cap="flat" cmpd="sng" algn="ctr">
+                      <a:solidFill>
+                        <a:srgbClr val="D9D4D0"/>
+                      </a:solidFill>
+                      <a:prstDash val="solid"/>
+                      <a:round/>
+                      <a:headEnd type="none" w="med" len="med"/>
+                      <a:tailEnd type="none" w="med" len="med"/>
+                    </a:lnL>
+                    <a:lnR w="9525" cap="flat" cmpd="sng" algn="ctr">
+                      <a:solidFill>
+                        <a:srgbClr val="D9D4D0"/>
+                      </a:solidFill>
+                      <a:prstDash val="solid"/>
+                      <a:round/>
+                      <a:headEnd type="none" w="med" len="med"/>
+                      <a:tailEnd type="none" w="med" len="med"/>
+                    </a:lnR>
+                    <a:lnT w="9525" cap="flat" cmpd="sng" algn="ctr">
+                      <a:solidFill>
+                        <a:srgbClr val="D9D4D0"/>
+                      </a:solidFill>
+                      <a:prstDash val="solid"/>
+                      <a:round/>
+                      <a:headEnd type="none" w="med" len="med"/>
+                      <a:tailEnd type="none" w="med" len="med"/>
+                    </a:lnT>
+                    <a:lnB w="9525" cap="flat" cmpd="sng" algn="ctr">
+                      <a:solidFill>
+                        <a:srgbClr val="D9D4D0"/>
+                      </a:solidFill>
+                      <a:prstDash val="solid"/>
+                      <a:round/>
+                      <a:headEnd type="none" w="med" len="med"/>
+                      <a:tailEnd type="none" w="med" len="med"/>
+                    </a:lnB>
+                    <a:solidFill>
+                      <a:srgbClr val="9E1B32"/>
+                    </a:solidFill>
+                  </a:tcPr>
+                </a:tc>
+              </a:tr>
+              <a:tr h="658368">
+                <a:tc>
+                  <a:txBody>
+                    <a:bodyPr/>
+                    <a:lstStyle/>
+                    <a:p>
+                      <a:pPr algn="l" indent="0" marL="0">
+                        <a:buNone/>
+                      </a:pPr>
+                      <a:r>
+                        <a:rPr lang="en-US" sz="1800" dirty="0">
+                          <a:solidFill>
+                            <a:srgbClr val="0B0B0B"/>
+                          </a:solidFill>
+                          <a:latin typeface="Calibri" pitchFamily="34" charset="0"/>
+                          <a:ea typeface="Calibri" pitchFamily="34" charset="-122"/>
+                          <a:cs typeface="Calibri" pitchFamily="34" charset="-120"/>
+                        </a:rPr>
+                        <a:t>Platform</a:t>
+                      </a:r>
+                      <a:endParaRPr lang="en-US" sz="1800" dirty="0">
+                        <a:latin typeface="Calibri" charset="0"/>
+                        <a:ea typeface="Calibri" charset="0"/>
+                        <a:cs typeface="Calibri" charset="0"/>
+                      </a:endParaRPr>
+                    </a:p>
+                  </a:txBody>
+                  <a:tcPr marL="45720" marR="45720" marT="45720" marB="45720" anchor="ctr">
+                    <a:lnL w="9525" cap="flat" cmpd="sng" algn="ctr">
+                      <a:solidFill>
+                        <a:srgbClr val="D9D4D0"/>
+                      </a:solidFill>
+                      <a:prstDash val="solid"/>
+                      <a:round/>
+                      <a:headEnd type="none" w="med" len="med"/>
+                      <a:tailEnd type="none" w="med" len="med"/>
+                    </a:lnL>
+                    <a:lnR w="9525" cap="flat" cmpd="sng" algn="ctr">
+                      <a:solidFill>
+                        <a:srgbClr val="D9D4D0"/>
+                      </a:solidFill>
+                      <a:prstDash val="solid"/>
+                      <a:round/>
+                      <a:headEnd type="none" w="med" len="med"/>
+                      <a:tailEnd type="none" w="med" len="med"/>
+                    </a:lnR>
+                    <a:lnT w="9525" cap="flat" cmpd="sng" algn="ctr">
+                      <a:solidFill>
+                        <a:srgbClr val="D9D4D0"/>
+                      </a:solidFill>
+                      <a:prstDash val="solid"/>
+                      <a:round/>
+                      <a:headEnd type="none" w="med" len="med"/>
+                      <a:tailEnd type="none" w="med" len="med"/>
+                    </a:lnT>
+                    <a:lnB w="9525" cap="flat" cmpd="sng" algn="ctr">
+                      <a:solidFill>
+                        <a:srgbClr val="D9D4D0"/>
+                      </a:solidFill>
+                      <a:prstDash val="solid"/>
+                      <a:round/>
+                      <a:headEnd type="none" w="med" len="med"/>
+                      <a:tailEnd type="none" w="med" len="med"/>
+                    </a:lnB>
+                    <a:solidFill>
+                      <a:srgbClr val="FFFFFF"/>
+                    </a:solidFill>
+                  </a:tcPr>
+                </a:tc>
+                <a:tc>
+                  <a:txBody>
+                    <a:bodyPr/>
+                    <a:lstStyle/>
+                    <a:p>
+                      <a:pPr algn="ctr" indent="0" marL="0">
+                        <a:buNone/>
+                      </a:pPr>
+                      <a:r>
+                        <a:rPr lang="en-US" sz="1800" dirty="0">
+                          <a:solidFill>
+                            <a:srgbClr val="0B0B0B"/>
+                          </a:solidFill>
+                          <a:latin typeface="Calibri" pitchFamily="34" charset="0"/>
+                          <a:ea typeface="Calibri" pitchFamily="34" charset="-122"/>
+                          <a:cs typeface="Calibri" pitchFamily="34" charset="-120"/>
+                        </a:rPr>
+                        <a:t>Windows GUI, closed</a:t>
+                      </a:r>
+                      <a:endParaRPr lang="en-US" sz="1800" dirty="0">
+                        <a:latin typeface="Calibri" charset="0"/>
+                        <a:ea typeface="Calibri" charset="0"/>
+                        <a:cs typeface="Calibri" charset="0"/>
+                      </a:endParaRPr>
+                    </a:p>
+                  </a:txBody>
+                  <a:tcPr marL="45720" marR="45720" marT="45720" marB="45720" anchor="ctr">
+                    <a:lnL w="9525" cap="flat" cmpd="sng" algn="ctr">
+                      <a:solidFill>
+                        <a:srgbClr val="D9D4D0"/>
+                      </a:solidFill>
+                      <a:prstDash val="solid"/>
+                      <a:round/>
+                      <a:headEnd type="none" w="med" len="med"/>
+                      <a:tailEnd type="none" w="med" len="med"/>
+                    </a:lnL>
+                    <a:lnR w="9525" cap="flat" cmpd="sng" algn="ctr">
+                      <a:solidFill>
+                        <a:srgbClr val="D9D4D0"/>
+                      </a:solidFill>
+                      <a:prstDash val="solid"/>
+                      <a:round/>
+                      <a:headEnd type="none" w="med" len="med"/>
+                      <a:tailEnd type="none" w="med" len="med"/>
+                    </a:lnR>
+                    <a:lnT w="9525" cap="flat" cmpd="sng" algn="ctr">
+                      <a:solidFill>
+                        <a:srgbClr val="D9D4D0"/>
+                      </a:solidFill>
+                      <a:prstDash val="solid"/>
+                      <a:round/>
+                      <a:headEnd type="none" w="med" len="med"/>
+                      <a:tailEnd type="none" w="med" len="med"/>
+                    </a:lnT>
+                    <a:lnB w="9525" cap="flat" cmpd="sng" algn="ctr">
+                      <a:solidFill>
+                        <a:srgbClr val="D9D4D0"/>
+                      </a:solidFill>
+                      <a:prstDash val="solid"/>
+                      <a:round/>
+                      <a:headEnd type="none" w="med" len="med"/>
+                      <a:tailEnd type="none" w="med" len="med"/>
+                    </a:lnB>
+                    <a:solidFill>
+                      <a:srgbClr val="FFFFFF"/>
+                    </a:solidFill>
+                  </a:tcPr>
+                </a:tc>
+                <a:tc>
+                  <a:txBody>
+                    <a:bodyPr/>
+                    <a:lstStyle/>
+                    <a:p>
+                      <a:pPr algn="ctr" indent="0" marL="0">
+                        <a:buNone/>
+                      </a:pPr>
+                      <a:r>
+                        <a:rPr lang="en-US" sz="1800" dirty="0">
+                          <a:solidFill>
+                            <a:srgbClr val="0B0B0B"/>
+                          </a:solidFill>
+                          <a:latin typeface="Calibri" pitchFamily="34" charset="0"/>
+                          <a:ea typeface="Calibri" pitchFamily="34" charset="-122"/>
+                          <a:cs typeface="Calibri" pitchFamily="34" charset="-120"/>
+                        </a:rPr>
+                        <a:t>Python library</a:t>
+                      </a:r>
+                      <a:endParaRPr lang="en-US" sz="1800" dirty="0">
+                        <a:latin typeface="Calibri" charset="0"/>
+                        <a:ea typeface="Calibri" charset="0"/>
+                        <a:cs typeface="Calibri" charset="0"/>
+                      </a:endParaRPr>
+                    </a:p>
+                  </a:txBody>
+                  <a:tcPr marL="45720" marR="45720" marT="45720" marB="45720" anchor="ctr">
+                    <a:lnL w="9525" cap="flat" cmpd="sng" algn="ctr">
+                      <a:solidFill>
+                        <a:srgbClr val="D9D4D0"/>
+                      </a:solidFill>
+                      <a:prstDash val="solid"/>
+                      <a:round/>
+                      <a:headEnd type="none" w="med" len="med"/>
+                      <a:tailEnd type="none" w="med" len="med"/>
+                    </a:lnL>
+                    <a:lnR w="9525" cap="flat" cmpd="sng" algn="ctr">
+                      <a:solidFill>
+                        <a:srgbClr val="D9D4D0"/>
+                      </a:solidFill>
+                      <a:prstDash val="solid"/>
+                      <a:round/>
+                      <a:headEnd type="none" w="med" len="med"/>
+                      <a:tailEnd type="none" w="med" len="med"/>
+                    </a:lnR>
+                    <a:lnT w="9525" cap="flat" cmpd="sng" algn="ctr">
+                      <a:solidFill>
+                        <a:srgbClr val="D9D4D0"/>
+                      </a:solidFill>
+                      <a:prstDash val="solid"/>
+                      <a:round/>
+                      <a:headEnd type="none" w="med" len="med"/>
+                      <a:tailEnd type="none" w="med" len="med"/>
+                    </a:lnT>
+                    <a:lnB w="9525" cap="flat" cmpd="sng" algn="ctr">
+                      <a:solidFill>
+                        <a:srgbClr val="D9D4D0"/>
+                      </a:solidFill>
+                      <a:prstDash val="solid"/>
+                      <a:round/>
+                      <a:headEnd type="none" w="med" len="med"/>
+                      <a:tailEnd type="none" w="med" len="med"/>
+                    </a:lnB>
+                    <a:solidFill>
+                      <a:srgbClr val="FFFFFF"/>
+                    </a:solidFill>
+                  </a:tcPr>
+                </a:tc>
+                <a:tc>
+                  <a:txBody>
+                    <a:bodyPr/>
+                    <a:lstStyle/>
+                    <a:p>
+                      <a:pPr algn="ctr" indent="0" marL="0">
+                        <a:buNone/>
+                      </a:pPr>
+                      <a:r>
+                        <a:rPr lang="en-US" sz="1800" dirty="0">
+                          <a:solidFill>
+                            <a:srgbClr val="0B0B0B"/>
+                          </a:solidFill>
+                          <a:latin typeface="Calibri" pitchFamily="34" charset="0"/>
+                          <a:ea typeface="Calibri" pitchFamily="34" charset="-122"/>
+                          <a:cs typeface="Calibri" pitchFamily="34" charset="-120"/>
+                        </a:rPr>
+                        <a:t>Julia library + desktop app</a:t>
+                      </a:r>
+                      <a:endParaRPr lang="en-US" sz="1800" dirty="0">
+                        <a:latin typeface="Calibri" charset="0"/>
+                        <a:ea typeface="Calibri" charset="0"/>
+                        <a:cs typeface="Calibri" charset="0"/>
+                      </a:endParaRPr>
+                    </a:p>
+                  </a:txBody>
+                  <a:tcPr marL="45720" marR="45720" marT="45720" marB="45720" anchor="ctr">
+                    <a:lnL w="9525" cap="flat" cmpd="sng" algn="ctr">
+                      <a:solidFill>
+                        <a:srgbClr val="D9D4D0"/>
+                      </a:solidFill>
+                      <a:prstDash val="solid"/>
+                      <a:round/>
+                      <a:headEnd type="none" w="med" len="med"/>
+                      <a:tailEnd type="none" w="med" len="med"/>
+                    </a:lnL>
+                    <a:lnR w="9525" cap="flat" cmpd="sng" algn="ctr">
+                      <a:solidFill>
+                        <a:srgbClr val="D9D4D0"/>
+                      </a:solidFill>
+                      <a:prstDash val="solid"/>
+                      <a:round/>
+                      <a:headEnd type="none" w="med" len="med"/>
+                      <a:tailEnd type="none" w="med" len="med"/>
+                    </a:lnR>
+                    <a:lnT w="9525" cap="flat" cmpd="sng" algn="ctr">
+                      <a:solidFill>
+                        <a:srgbClr val="D9D4D0"/>
+                      </a:solidFill>
+                      <a:prstDash val="solid"/>
+                      <a:round/>
+                      <a:headEnd type="none" w="med" len="med"/>
+                      <a:tailEnd type="none" w="med" len="med"/>
+                    </a:lnT>
+                    <a:lnB w="9525" cap="flat" cmpd="sng" algn="ctr">
+                      <a:solidFill>
+                        <a:srgbClr val="D9D4D0"/>
+                      </a:solidFill>
+                      <a:prstDash val="solid"/>
+                      <a:round/>
+                      <a:headEnd type="none" w="med" len="med"/>
+                      <a:tailEnd type="none" w="med" len="med"/>
+                    </a:lnB>
+                    <a:solidFill>
+                      <a:srgbClr val="FFFFFF"/>
+                    </a:solidFill>
+                  </a:tcPr>
+                </a:tc>
+              </a:tr>
+              <a:tr h="658368">
+                <a:tc>
+                  <a:txBody>
+                    <a:bodyPr/>
+                    <a:lstStyle/>
+                    <a:p>
+                      <a:pPr algn="l" indent="0" marL="0">
+                        <a:buNone/>
+                      </a:pPr>
+                      <a:r>
+                        <a:rPr lang="en-US" sz="1800" dirty="0">
+                          <a:solidFill>
+                            <a:srgbClr val="0B0B0B"/>
+                          </a:solidFill>
+                          <a:latin typeface="Calibri" pitchFamily="34" charset="0"/>
+                          <a:ea typeface="Calibri" pitchFamily="34" charset="-122"/>
+                          <a:cs typeface="Calibri" pitchFamily="34" charset="-120"/>
+                        </a:rPr>
+                        <a:t>χ² intervals with per-τ noise ID</a:t>
+                      </a:r>
+                      <a:endParaRPr lang="en-US" sz="1800" dirty="0">
+                        <a:latin typeface="Calibri" charset="0"/>
+                        <a:ea typeface="Calibri" charset="0"/>
+                        <a:cs typeface="Calibri" charset="0"/>
+                      </a:endParaRPr>
+                    </a:p>
+                  </a:txBody>
+                  <a:tcPr marL="45720" marR="45720" marT="45720" marB="45720" anchor="ctr">
+                    <a:lnL w="9525" cap="flat" cmpd="sng" algn="ctr">
+                      <a:solidFill>
+                        <a:srgbClr val="D9D4D0"/>
+                      </a:solidFill>
+                      <a:prstDash val="solid"/>
+                      <a:round/>
+                      <a:headEnd type="none" w="med" len="med"/>
+                      <a:tailEnd type="none" w="med" len="med"/>
+                    </a:lnL>
+                    <a:lnR w="9525" cap="flat" cmpd="sng" algn="ctr">
+                      <a:solidFill>
+                        <a:srgbClr val="D9D4D0"/>
+                      </a:solidFill>
+                      <a:prstDash val="solid"/>
+                      <a:round/>
+                      <a:headEnd type="none" w="med" len="med"/>
+                      <a:tailEnd type="none" w="med" len="med"/>
+                    </a:lnR>
+                    <a:lnT w="9525" cap="flat" cmpd="sng" algn="ctr">
+                      <a:solidFill>
+                        <a:srgbClr val="D9D4D0"/>
+                      </a:solidFill>
+                      <a:prstDash val="solid"/>
+                      <a:round/>
+                      <a:headEnd type="none" w="med" len="med"/>
+                      <a:tailEnd type="none" w="med" len="med"/>
+                    </a:lnT>
+                    <a:lnB w="9525" cap="flat" cmpd="sng" algn="ctr">
+                      <a:solidFill>
+                        <a:srgbClr val="D9D4D0"/>
+                      </a:solidFill>
+                      <a:prstDash val="solid"/>
+                      <a:round/>
+                      <a:headEnd type="none" w="med" len="med"/>
+                      <a:tailEnd type="none" w="med" len="med"/>
+                    </a:lnB>
+                    <a:solidFill>
+                      <a:srgbClr val="F7F2F3"/>
+                    </a:solidFill>
+                  </a:tcPr>
+                </a:tc>
+                <a:tc>
+                  <a:txBody>
+                    <a:bodyPr/>
+                    <a:lstStyle/>
+                    <a:p>
+                      <a:pPr algn="ctr" indent="0" marL="0">
+                        <a:buNone/>
+                      </a:pPr>
+                      <a:r>
+                        <a:rPr lang="en-US" sz="1800" dirty="0">
+                          <a:solidFill>
+                            <a:srgbClr val="0B0B0B"/>
+                          </a:solidFill>
+                          <a:latin typeface="Calibri" pitchFamily="34" charset="0"/>
+                          <a:ea typeface="Calibri" pitchFamily="34" charset="-122"/>
+                          <a:cs typeface="Calibri" pitchFamily="34" charset="-120"/>
+                        </a:rPr>
+                        <a:t>yes</a:t>
+                      </a:r>
+                      <a:endParaRPr lang="en-US" sz="1800" dirty="0">
+                        <a:latin typeface="Calibri" charset="0"/>
+                        <a:ea typeface="Calibri" charset="0"/>
+                        <a:cs typeface="Calibri" charset="0"/>
+                      </a:endParaRPr>
+                    </a:p>
+                  </a:txBody>
+                  <a:tcPr marL="45720" marR="45720" marT="45720" marB="45720" anchor="ctr">
+                    <a:lnL w="9525" cap="flat" cmpd="sng" algn="ctr">
+                      <a:solidFill>
+                        <a:srgbClr val="D9D4D0"/>
+                      </a:solidFill>
+                      <a:prstDash val="solid"/>
+                      <a:round/>
+                      <a:headEnd type="none" w="med" len="med"/>
+                      <a:tailEnd type="none" w="med" len="med"/>
+                    </a:lnL>
+                    <a:lnR w="9525" cap="flat" cmpd="sng" algn="ctr">
+                      <a:solidFill>
+                        <a:srgbClr val="D9D4D0"/>
+                      </a:solidFill>
+                      <a:prstDash val="solid"/>
+                      <a:round/>
+                      <a:headEnd type="none" w="med" len="med"/>
+                      <a:tailEnd type="none" w="med" len="med"/>
+                    </a:lnR>
+                    <a:lnT w="9525" cap="flat" cmpd="sng" algn="ctr">
+                      <a:solidFill>
+                        <a:srgbClr val="D9D4D0"/>
+                      </a:solidFill>
+                      <a:prstDash val="solid"/>
+                      <a:round/>
+                      <a:headEnd type="none" w="med" len="med"/>
+                      <a:tailEnd type="none" w="med" len="med"/>
+                    </a:lnT>
+                    <a:lnB w="9525" cap="flat" cmpd="sng" algn="ctr">
+                      <a:solidFill>
+                        <a:srgbClr val="D9D4D0"/>
+                      </a:solidFill>
+                      <a:prstDash val="solid"/>
+                      <a:round/>
+                      <a:headEnd type="none" w="med" len="med"/>
+                      <a:tailEnd type="none" w="med" len="med"/>
+                    </a:lnB>
+                    <a:solidFill>
+                      <a:srgbClr val="F7F2F3"/>
+                    </a:solidFill>
+                  </a:tcPr>
+                </a:tc>
+                <a:tc>
+                  <a:txBody>
+                    <a:bodyPr/>
+                    <a:lstStyle/>
+                    <a:p>
+                      <a:pPr algn="ctr" indent="0" marL="0">
+                        <a:buNone/>
+                      </a:pPr>
+                      <a:r>
+                        <a:rPr lang="en-US" sz="1800" dirty="0">
+                          <a:solidFill>
+                            <a:srgbClr val="0B0B0B"/>
+                          </a:solidFill>
+                          <a:latin typeface="Calibri" pitchFamily="34" charset="0"/>
+                          <a:ea typeface="Calibri" pitchFamily="34" charset="-122"/>
+                          <a:cs typeface="Calibri" pitchFamily="34" charset="-120"/>
+                        </a:rPr>
+                        <a:t>manual</a:t>
+                      </a:r>
+                      <a:endParaRPr lang="en-US" sz="1800" dirty="0">
+                        <a:latin typeface="Calibri" charset="0"/>
+                        <a:ea typeface="Calibri" charset="0"/>
+                        <a:cs typeface="Calibri" charset="0"/>
+                      </a:endParaRPr>
+                    </a:p>
+                  </a:txBody>
+                  <a:tcPr marL="45720" marR="45720" marT="45720" marB="45720" anchor="ctr">
+                    <a:lnL w="9525" cap="flat" cmpd="sng" algn="ctr">
+                      <a:solidFill>
+                        <a:srgbClr val="D9D4D0"/>
+                      </a:solidFill>
+                      <a:prstDash val="solid"/>
+                      <a:round/>
+                      <a:headEnd type="none" w="med" len="med"/>
+                      <a:tailEnd type="none" w="med" len="med"/>
+                    </a:lnL>
+                    <a:lnR w="9525" cap="flat" cmpd="sng" algn="ctr">
+                      <a:solidFill>
+                        <a:srgbClr val="D9D4D0"/>
+                      </a:solidFill>
+                      <a:prstDash val="solid"/>
+                      <a:round/>
+                      <a:headEnd type="none" w="med" len="med"/>
+                      <a:tailEnd type="none" w="med" len="med"/>
+                    </a:lnR>
+                    <a:lnT w="9525" cap="flat" cmpd="sng" algn="ctr">
+                      <a:solidFill>
+                        <a:srgbClr val="D9D4D0"/>
+                      </a:solidFill>
+                      <a:prstDash val="solid"/>
+                      <a:round/>
+                      <a:headEnd type="none" w="med" len="med"/>
+                      <a:tailEnd type="none" w="med" len="med"/>
+                    </a:lnT>
+                    <a:lnB w="9525" cap="flat" cmpd="sng" algn="ctr">
+                      <a:solidFill>
+                        <a:srgbClr val="D9D4D0"/>
+                      </a:solidFill>
+                      <a:prstDash val="solid"/>
+                      <a:round/>
+                      <a:headEnd type="none" w="med" len="med"/>
+                      <a:tailEnd type="none" w="med" len="med"/>
+                    </a:lnB>
+                    <a:solidFill>
+                      <a:srgbClr val="F7F2F3"/>
+                    </a:solidFill>
+                  </a:tcPr>
+                </a:tc>
+                <a:tc>
+                  <a:txBody>
+                    <a:bodyPr/>
+                    <a:lstStyle/>
+                    <a:p>
+                      <a:pPr algn="ctr" indent="0" marL="0">
+                        <a:buNone/>
+                      </a:pPr>
+                      <a:r>
+                        <a:rPr lang="en-US" sz="1800" dirty="0">
+                          <a:solidFill>
+                            <a:srgbClr val="0B0B0B"/>
+                          </a:solidFill>
+                          <a:latin typeface="Calibri" pitchFamily="34" charset="0"/>
+                          <a:ea typeface="Calibri" pitchFamily="34" charset="-122"/>
+                          <a:cs typeface="Calibri" pitchFamily="34" charset="-120"/>
+                        </a:rPr>
+                        <a:t>every call</a:t>
+                      </a:r>
+                      <a:endParaRPr lang="en-US" sz="1800" dirty="0">
+                        <a:latin typeface="Calibri" charset="0"/>
+                        <a:ea typeface="Calibri" charset="0"/>
+                        <a:cs typeface="Calibri" charset="0"/>
+                      </a:endParaRPr>
+                    </a:p>
+                  </a:txBody>
+                  <a:tcPr marL="45720" marR="45720" marT="45720" marB="45720" anchor="ctr">
+                    <a:lnL w="9525" cap="flat" cmpd="sng" algn="ctr">
+                      <a:solidFill>
+                        <a:srgbClr val="D9D4D0"/>
+                      </a:solidFill>
+                      <a:prstDash val="solid"/>
+                      <a:round/>
+                      <a:headEnd type="none" w="med" len="med"/>
+                      <a:tailEnd type="none" w="med" len="med"/>
+                    </a:lnL>
+                    <a:lnR w="9525" cap="flat" cmpd="sng" algn="ctr">
+                      <a:solidFill>
+                        <a:srgbClr val="D9D4D0"/>
+                      </a:solidFill>
+                      <a:prstDash val="solid"/>
+                      <a:round/>
+                      <a:headEnd type="none" w="med" len="med"/>
+                      <a:tailEnd type="none" w="med" len="med"/>
+                    </a:lnR>
+                    <a:lnT w="9525" cap="flat" cmpd="sng" algn="ctr">
+                      <a:solidFill>
+                        <a:srgbClr val="D9D4D0"/>
+                      </a:solidFill>
+                      <a:prstDash val="solid"/>
+                      <a:round/>
+                      <a:headEnd type="none" w="med" len="med"/>
+                      <a:tailEnd type="none" w="med" len="med"/>
+                    </a:lnT>
+                    <a:lnB w="9525" cap="flat" cmpd="sng" algn="ctr">
+                      <a:solidFill>
+                        <a:srgbClr val="D9D4D0"/>
+                      </a:solidFill>
+                      <a:prstDash val="solid"/>
+                      <a:round/>
+                      <a:headEnd type="none" w="med" len="med"/>
+                      <a:tailEnd type="none" w="med" len="med"/>
+                    </a:lnB>
+                    <a:solidFill>
+                      <a:srgbClr val="F7F2F3"/>
+                    </a:solidFill>
+                  </a:tcPr>
+                </a:tc>
+              </a:tr>
+              <a:tr h="384048">
+                <a:tc>
+                  <a:txBody>
+                    <a:bodyPr/>
+                    <a:lstStyle/>
+                    <a:p>
+                      <a:pPr algn="l" indent="0" marL="0">
+                        <a:buNone/>
+                      </a:pPr>
+                      <a:r>
+                        <a:rPr lang="en-US" sz="1800" dirty="0">
+                          <a:solidFill>
+                            <a:srgbClr val="0B0B0B"/>
+                          </a:solidFill>
+                          <a:latin typeface="Calibri" pitchFamily="34" charset="0"/>
+                          <a:ea typeface="Calibri" pitchFamily="34" charset="-122"/>
+                          <a:cs typeface="Calibri" pitchFamily="34" charset="-120"/>
+                        </a:rPr>
+                        <a:t>Total-family bias correction</a:t>
+                      </a:r>
+                      <a:endParaRPr lang="en-US" sz="1800" dirty="0">
+                        <a:latin typeface="Calibri" charset="0"/>
+                        <a:ea typeface="Calibri" charset="0"/>
+                        <a:cs typeface="Calibri" charset="0"/>
+                      </a:endParaRPr>
+                    </a:p>
+                  </a:txBody>
+                  <a:tcPr marL="45720" marR="45720" marT="45720" marB="45720" anchor="ctr">
+                    <a:lnL w="9525" cap="flat" cmpd="sng" algn="ctr">
+                      <a:solidFill>
+                        <a:srgbClr val="D9D4D0"/>
+                      </a:solidFill>
+                      <a:prstDash val="solid"/>
+                      <a:round/>
+                      <a:headEnd type="none" w="med" len="med"/>
+                      <a:tailEnd type="none" w="med" len="med"/>
+                    </a:lnL>
+                    <a:lnR w="9525" cap="flat" cmpd="sng" algn="ctr">
+                      <a:solidFill>
+                        <a:srgbClr val="D9D4D0"/>
+                      </a:solidFill>
+                      <a:prstDash val="solid"/>
+                      <a:round/>
+                      <a:headEnd type="none" w="med" len="med"/>
+                      <a:tailEnd type="none" w="med" len="med"/>
+                    </a:lnR>
+                    <a:lnT w="9525" cap="flat" cmpd="sng" algn="ctr">
+                      <a:solidFill>
+                        <a:srgbClr val="D9D4D0"/>
+                      </a:solidFill>
+                      <a:prstDash val="solid"/>
+                      <a:round/>
+                      <a:headEnd type="none" w="med" len="med"/>
+                      <a:tailEnd type="none" w="med" len="med"/>
+                    </a:lnT>
+                    <a:lnB w="9525" cap="flat" cmpd="sng" algn="ctr">
+                      <a:solidFill>
+                        <a:srgbClr val="D9D4D0"/>
+                      </a:solidFill>
+                      <a:prstDash val="solid"/>
+                      <a:round/>
+                      <a:headEnd type="none" w="med" len="med"/>
+                      <a:tailEnd type="none" w="med" len="med"/>
+                    </a:lnB>
+                    <a:solidFill>
+                      <a:srgbClr val="FFFFFF"/>
+                    </a:solidFill>
+                  </a:tcPr>
+                </a:tc>
+                <a:tc>
+                  <a:txBody>
+                    <a:bodyPr/>
+                    <a:lstStyle/>
+                    <a:p>
+                      <a:pPr algn="ctr" indent="0" marL="0">
+                        <a:buNone/>
+                      </a:pPr>
+                      <a:r>
+                        <a:rPr lang="en-US" sz="1800" dirty="0">
+                          <a:solidFill>
+                            <a:srgbClr val="0B0B0B"/>
+                          </a:solidFill>
+                          <a:latin typeface="Calibri" pitchFamily="34" charset="0"/>
+                          <a:ea typeface="Calibri" pitchFamily="34" charset="-122"/>
+                          <a:cs typeface="Calibri" pitchFamily="34" charset="-120"/>
+                        </a:rPr>
+                        <a:t>TOTDEV, HTOTDEV</a:t>
+                      </a:r>
+                      <a:endParaRPr lang="en-US" sz="1800" dirty="0">
+                        <a:latin typeface="Calibri" charset="0"/>
+                        <a:ea typeface="Calibri" charset="0"/>
+                        <a:cs typeface="Calibri" charset="0"/>
+                      </a:endParaRPr>
+                    </a:p>
+                  </a:txBody>
+                  <a:tcPr marL="45720" marR="45720" marT="45720" marB="45720" anchor="ctr">
+                    <a:lnL w="9525" cap="flat" cmpd="sng" algn="ctr">
+                      <a:solidFill>
+                        <a:srgbClr val="D9D4D0"/>
+                      </a:solidFill>
+                      <a:prstDash val="solid"/>
+                      <a:round/>
+                      <a:headEnd type="none" w="med" len="med"/>
+                      <a:tailEnd type="none" w="med" len="med"/>
+                    </a:lnL>
+                    <a:lnR w="9525" cap="flat" cmpd="sng" algn="ctr">
+                      <a:solidFill>
+                        <a:srgbClr val="D9D4D0"/>
+                      </a:solidFill>
+                      <a:prstDash val="solid"/>
+                      <a:round/>
+                      <a:headEnd type="none" w="med" len="med"/>
+                      <a:tailEnd type="none" w="med" len="med"/>
+                    </a:lnR>
+                    <a:lnT w="9525" cap="flat" cmpd="sng" algn="ctr">
+                      <a:solidFill>
+                        <a:srgbClr val="D9D4D0"/>
+                      </a:solidFill>
+                      <a:prstDash val="solid"/>
+                      <a:round/>
+                      <a:headEnd type="none" w="med" len="med"/>
+                      <a:tailEnd type="none" w="med" len="med"/>
+                    </a:lnT>
+                    <a:lnB w="9525" cap="flat" cmpd="sng" algn="ctr">
+                      <a:solidFill>
+                        <a:srgbClr val="D9D4D0"/>
+                      </a:solidFill>
+                      <a:prstDash val="solid"/>
+                      <a:round/>
+                      <a:headEnd type="none" w="med" len="med"/>
+                      <a:tailEnd type="none" w="med" len="med"/>
+                    </a:lnB>
+                    <a:solidFill>
+                      <a:srgbClr val="FFFFFF"/>
+                    </a:solidFill>
+                  </a:tcPr>
+                </a:tc>
+                <a:tc>
+                  <a:txBody>
+                    <a:bodyPr/>
+                    <a:lstStyle/>
+                    <a:p>
+                      <a:pPr algn="ctr" indent="0" marL="0">
+                        <a:buNone/>
+                      </a:pPr>
+                      <a:r>
+                        <a:rPr lang="en-US" sz="1800" dirty="0">
+                          <a:solidFill>
+                            <a:srgbClr val="0B0B0B"/>
+                          </a:solidFill>
+                          <a:latin typeface="Calibri" pitchFamily="34" charset="0"/>
+                          <a:ea typeface="Calibri" pitchFamily="34" charset="-122"/>
+                          <a:cs typeface="Calibri" pitchFamily="34" charset="-120"/>
+                        </a:rPr>
+                        <a:t>none</a:t>
+                      </a:r>
+                      <a:endParaRPr lang="en-US" sz="1800" dirty="0">
+                        <a:latin typeface="Calibri" charset="0"/>
+                        <a:ea typeface="Calibri" charset="0"/>
+                        <a:cs typeface="Calibri" charset="0"/>
+                      </a:endParaRPr>
+                    </a:p>
+                  </a:txBody>
+                  <a:tcPr marL="45720" marR="45720" marT="45720" marB="45720" anchor="ctr">
+                    <a:lnL w="9525" cap="flat" cmpd="sng" algn="ctr">
+                      <a:solidFill>
+                        <a:srgbClr val="D9D4D0"/>
+                      </a:solidFill>
+                      <a:prstDash val="solid"/>
+                      <a:round/>
+                      <a:headEnd type="none" w="med" len="med"/>
+                      <a:tailEnd type="none" w="med" len="med"/>
+                    </a:lnL>
+                    <a:lnR w="9525" cap="flat" cmpd="sng" algn="ctr">
+                      <a:solidFill>
+                        <a:srgbClr val="D9D4D0"/>
+                      </a:solidFill>
+                      <a:prstDash val="solid"/>
+                      <a:round/>
+                      <a:headEnd type="none" w="med" len="med"/>
+                      <a:tailEnd type="none" w="med" len="med"/>
+                    </a:lnR>
+                    <a:lnT w="9525" cap="flat" cmpd="sng" algn="ctr">
+                      <a:solidFill>
+                        <a:srgbClr val="D9D4D0"/>
+                      </a:solidFill>
+                      <a:prstDash val="solid"/>
+                      <a:round/>
+                      <a:headEnd type="none" w="med" len="med"/>
+                      <a:tailEnd type="none" w="med" len="med"/>
+                    </a:lnT>
+                    <a:lnB w="9525" cap="flat" cmpd="sng" algn="ctr">
+                      <a:solidFill>
+                        <a:srgbClr val="D9D4D0"/>
+                      </a:solidFill>
+                      <a:prstDash val="solid"/>
+                      <a:round/>
+                      <a:headEnd type="none" w="med" len="med"/>
+                      <a:tailEnd type="none" w="med" len="med"/>
+                    </a:lnB>
+                    <a:solidFill>
+                      <a:srgbClr val="FFFFFF"/>
+                    </a:solidFill>
+                  </a:tcPr>
+                </a:tc>
+                <a:tc>
+                  <a:txBody>
+                    <a:bodyPr/>
+                    <a:lstStyle/>
+                    <a:p>
+                      <a:pPr algn="ctr" indent="0" marL="0">
+                        <a:buNone/>
+                      </a:pPr>
+                      <a:r>
+                        <a:rPr lang="en-US" sz="1800" dirty="0">
+                          <a:solidFill>
+                            <a:srgbClr val="0B0B0B"/>
+                          </a:solidFill>
+                          <a:latin typeface="Calibri" pitchFamily="34" charset="0"/>
+                          <a:ea typeface="Calibri" pitchFamily="34" charset="-122"/>
+                          <a:cs typeface="Calibri" pitchFamily="34" charset="-120"/>
+                        </a:rPr>
+                        <a:t>all five, switchable</a:t>
+                      </a:r>
+                      <a:endParaRPr lang="en-US" sz="1800" dirty="0">
+                        <a:latin typeface="Calibri" charset="0"/>
+                        <a:ea typeface="Calibri" charset="0"/>
+                        <a:cs typeface="Calibri" charset="0"/>
+                      </a:endParaRPr>
+                    </a:p>
+                  </a:txBody>
+                  <a:tcPr marL="45720" marR="45720" marT="45720" marB="45720" anchor="ctr">
+                    <a:lnL w="9525" cap="flat" cmpd="sng" algn="ctr">
+                      <a:solidFill>
+                        <a:srgbClr val="D9D4D0"/>
+                      </a:solidFill>
+                      <a:prstDash val="solid"/>
+                      <a:round/>
+                      <a:headEnd type="none" w="med" len="med"/>
+                      <a:tailEnd type="none" w="med" len="med"/>
+                    </a:lnL>
+                    <a:lnR w="9525" cap="flat" cmpd="sng" algn="ctr">
+                      <a:solidFill>
+                        <a:srgbClr val="D9D4D0"/>
+                      </a:solidFill>
+                      <a:prstDash val="solid"/>
+                      <a:round/>
+                      <a:headEnd type="none" w="med" len="med"/>
+                      <a:tailEnd type="none" w="med" len="med"/>
+                    </a:lnR>
+                    <a:lnT w="9525" cap="flat" cmpd="sng" algn="ctr">
+                      <a:solidFill>
+                        <a:srgbClr val="D9D4D0"/>
+                      </a:solidFill>
+                      <a:prstDash val="solid"/>
+                      <a:round/>
+                      <a:headEnd type="none" w="med" len="med"/>
+                      <a:tailEnd type="none" w="med" len="med"/>
+                    </a:lnT>
+                    <a:lnB w="9525" cap="flat" cmpd="sng" algn="ctr">
+                      <a:solidFill>
+                        <a:srgbClr val="D9D4D0"/>
+                      </a:solidFill>
+                      <a:prstDash val="solid"/>
+                      <a:round/>
+                      <a:headEnd type="none" w="med" len="med"/>
+                      <a:tailEnd type="none" w="med" len="med"/>
+                    </a:lnB>
+                    <a:solidFill>
+                      <a:srgbClr val="FFFFFF"/>
+                    </a:solidFill>
+                  </a:tcPr>
+                </a:tc>
+              </a:tr>
+              <a:tr h="658368">
+                <a:tc>
+                  <a:txBody>
+                    <a:bodyPr/>
+                    <a:lstStyle/>
+                    <a:p>
+                      <a:pPr algn="l" indent="0" marL="0">
+                        <a:buNone/>
+                      </a:pPr>
+                      <a:r>
+                        <a:rPr lang="en-US" sz="1800" dirty="0">
+                          <a:solidFill>
+                            <a:srgbClr val="0B0B0B"/>
+                          </a:solidFill>
+                          <a:latin typeface="Calibri" pitchFamily="34" charset="0"/>
+                          <a:ea typeface="Calibri" pitchFamily="34" charset="-122"/>
+                          <a:cs typeface="Calibri" pitchFamily="34" charset="-120"/>
+                        </a:rPr>
+                        <a:t>MDEV-class Hadamard (MHDEV, HTDEV, MHTOTDEV)</a:t>
+                      </a:r>
+                      <a:endParaRPr lang="en-US" sz="1800" dirty="0">
+                        <a:latin typeface="Calibri" charset="0"/>
+                        <a:ea typeface="Calibri" charset="0"/>
+                        <a:cs typeface="Calibri" charset="0"/>
+                      </a:endParaRPr>
+                    </a:p>
+                  </a:txBody>
+                  <a:tcPr marL="45720" marR="45720" marT="45720" marB="45720" anchor="ctr">
+                    <a:lnL w="9525" cap="flat" cmpd="sng" algn="ctr">
+                      <a:solidFill>
+                        <a:srgbClr val="D9D4D0"/>
+                      </a:solidFill>
+                      <a:prstDash val="solid"/>
+                      <a:round/>
+                      <a:headEnd type="none" w="med" len="med"/>
+                      <a:tailEnd type="none" w="med" len="med"/>
+                    </a:lnL>
+                    <a:lnR w="9525" cap="flat" cmpd="sng" algn="ctr">
+                      <a:solidFill>
+                        <a:srgbClr val="D9D4D0"/>
+                      </a:solidFill>
+                      <a:prstDash val="solid"/>
+                      <a:round/>
+                      <a:headEnd type="none" w="med" len="med"/>
+                      <a:tailEnd type="none" w="med" len="med"/>
+                    </a:lnR>
+                    <a:lnT w="9525" cap="flat" cmpd="sng" algn="ctr">
+                      <a:solidFill>
+                        <a:srgbClr val="D9D4D0"/>
+                      </a:solidFill>
+                      <a:prstDash val="solid"/>
+                      <a:round/>
+                      <a:headEnd type="none" w="med" len="med"/>
+                      <a:tailEnd type="none" w="med" len="med"/>
+                    </a:lnT>
+                    <a:lnB w="9525" cap="flat" cmpd="sng" algn="ctr">
+                      <a:solidFill>
+                        <a:srgbClr val="D9D4D0"/>
+                      </a:solidFill>
+                      <a:prstDash val="solid"/>
+                      <a:round/>
+                      <a:headEnd type="none" w="med" len="med"/>
+                      <a:tailEnd type="none" w="med" len="med"/>
+                    </a:lnB>
+                    <a:solidFill>
+                      <a:srgbClr val="F7F2F3"/>
+                    </a:solidFill>
+                  </a:tcPr>
+                </a:tc>
+                <a:tc>
+                  <a:txBody>
+                    <a:bodyPr/>
+                    <a:lstStyle/>
+                    <a:p>
+                      <a:pPr algn="ctr" indent="0" marL="0">
+                        <a:buNone/>
+                      </a:pPr>
+                      <a:r>
+                        <a:rPr lang="en-US" sz="1800" dirty="0">
+                          <a:solidFill>
+                            <a:srgbClr val="0B0B0B"/>
+                          </a:solidFill>
+                          <a:latin typeface="Calibri" pitchFamily="34" charset="0"/>
+                          <a:ea typeface="Calibri" pitchFamily="34" charset="-122"/>
+                          <a:cs typeface="Calibri" pitchFamily="34" charset="-120"/>
+                        </a:rPr>
+                        <a:t>no</a:t>
+                      </a:r>
+                      <a:endParaRPr lang="en-US" sz="1800" dirty="0">
+                        <a:latin typeface="Calibri" charset="0"/>
+                        <a:ea typeface="Calibri" charset="0"/>
+                        <a:cs typeface="Calibri" charset="0"/>
+                      </a:endParaRPr>
+                    </a:p>
+                  </a:txBody>
+                  <a:tcPr marL="45720" marR="45720" marT="45720" marB="45720" anchor="ctr">
+                    <a:lnL w="9525" cap="flat" cmpd="sng" algn="ctr">
+                      <a:solidFill>
+                        <a:srgbClr val="D9D4D0"/>
+                      </a:solidFill>
+                      <a:prstDash val="solid"/>
+                      <a:round/>
+                      <a:headEnd type="none" w="med" len="med"/>
+                      <a:tailEnd type="none" w="med" len="med"/>
+                    </a:lnL>
+                    <a:lnR w="9525" cap="flat" cmpd="sng" algn="ctr">
+                      <a:solidFill>
+                        <a:srgbClr val="D9D4D0"/>
+                      </a:solidFill>
+                      <a:prstDash val="solid"/>
+                      <a:round/>
+                      <a:headEnd type="none" w="med" len="med"/>
+                      <a:tailEnd type="none" w="med" len="med"/>
+                    </a:lnR>
+                    <a:lnT w="9525" cap="flat" cmpd="sng" algn="ctr">
+                      <a:solidFill>
+                        <a:srgbClr val="D9D4D0"/>
+                      </a:solidFill>
+                      <a:prstDash val="solid"/>
+                      <a:round/>
+                      <a:headEnd type="none" w="med" len="med"/>
+                      <a:tailEnd type="none" w="med" len="med"/>
+                    </a:lnT>
+                    <a:lnB w="9525" cap="flat" cmpd="sng" algn="ctr">
+                      <a:solidFill>
+                        <a:srgbClr val="D9D4D0"/>
+                      </a:solidFill>
+                      <a:prstDash val="solid"/>
+                      <a:round/>
+                      <a:headEnd type="none" w="med" len="med"/>
+                      <a:tailEnd type="none" w="med" len="med"/>
+                    </a:lnB>
+                    <a:solidFill>
+                      <a:srgbClr val="F7F2F3"/>
+                    </a:solidFill>
+                  </a:tcPr>
+                </a:tc>
+                <a:tc>
+                  <a:txBody>
+                    <a:bodyPr/>
+                    <a:lstStyle/>
+                    <a:p>
+                      <a:pPr algn="ctr" indent="0" marL="0">
+                        <a:buNone/>
+                      </a:pPr>
+                      <a:r>
+                        <a:rPr lang="en-US" sz="1800" dirty="0">
+                          <a:solidFill>
+                            <a:srgbClr val="0B0B0B"/>
+                          </a:solidFill>
+                          <a:latin typeface="Calibri" pitchFamily="34" charset="0"/>
+                          <a:ea typeface="Calibri" pitchFamily="34" charset="-122"/>
+                          <a:cs typeface="Calibri" pitchFamily="34" charset="-120"/>
+                        </a:rPr>
+                        <a:t>no</a:t>
+                      </a:r>
+                      <a:endParaRPr lang="en-US" sz="1800" dirty="0">
+                        <a:latin typeface="Calibri" charset="0"/>
+                        <a:ea typeface="Calibri" charset="0"/>
+                        <a:cs typeface="Calibri" charset="0"/>
+                      </a:endParaRPr>
+                    </a:p>
+                  </a:txBody>
+                  <a:tcPr marL="45720" marR="45720" marT="45720" marB="45720" anchor="ctr">
+                    <a:lnL w="9525" cap="flat" cmpd="sng" algn="ctr">
+                      <a:solidFill>
+                        <a:srgbClr val="D9D4D0"/>
+                      </a:solidFill>
+                      <a:prstDash val="solid"/>
+                      <a:round/>
+                      <a:headEnd type="none" w="med" len="med"/>
+                      <a:tailEnd type="none" w="med" len="med"/>
+                    </a:lnL>
+                    <a:lnR w="9525" cap="flat" cmpd="sng" algn="ctr">
+                      <a:solidFill>
+                        <a:srgbClr val="D9D4D0"/>
+                      </a:solidFill>
+                      <a:prstDash val="solid"/>
+                      <a:round/>
+                      <a:headEnd type="none" w="med" len="med"/>
+                      <a:tailEnd type="none" w="med" len="med"/>
+                    </a:lnR>
+                    <a:lnT w="9525" cap="flat" cmpd="sng" algn="ctr">
+                      <a:solidFill>
+                        <a:srgbClr val="D9D4D0"/>
+                      </a:solidFill>
+                      <a:prstDash val="solid"/>
+                      <a:round/>
+                      <a:headEnd type="none" w="med" len="med"/>
+                      <a:tailEnd type="none" w="med" len="med"/>
+                    </a:lnT>
+                    <a:lnB w="9525" cap="flat" cmpd="sng" algn="ctr">
+                      <a:solidFill>
+                        <a:srgbClr val="D9D4D0"/>
+                      </a:solidFill>
+                      <a:prstDash val="solid"/>
+                      <a:round/>
+                      <a:headEnd type="none" w="med" len="med"/>
+                      <a:tailEnd type="none" w="med" len="med"/>
+                    </a:lnB>
+                    <a:solidFill>
+                      <a:srgbClr val="F7F2F3"/>
+                    </a:solidFill>
+                  </a:tcPr>
+                </a:tc>
+                <a:tc>
+                  <a:txBody>
+                    <a:bodyPr/>
+                    <a:lstStyle/>
+                    <a:p>
+                      <a:pPr algn="ctr" indent="0" marL="0">
+                        <a:buNone/>
+                      </a:pPr>
+                      <a:r>
+                        <a:rPr lang="en-US" sz="1800" dirty="0">
+                          <a:solidFill>
+                            <a:srgbClr val="0B0B0B"/>
+                          </a:solidFill>
+                          <a:latin typeface="Calibri" pitchFamily="34" charset="0"/>
+                          <a:ea typeface="Calibri" pitchFamily="34" charset="-122"/>
+                          <a:cs typeface="Calibri" pitchFamily="34" charset="-120"/>
+                        </a:rPr>
+                        <a:t>yes</a:t>
+                      </a:r>
+                      <a:endParaRPr lang="en-US" sz="1800" dirty="0">
+                        <a:latin typeface="Calibri" charset="0"/>
+                        <a:ea typeface="Calibri" charset="0"/>
+                        <a:cs typeface="Calibri" charset="0"/>
+                      </a:endParaRPr>
+                    </a:p>
+                  </a:txBody>
+                  <a:tcPr marL="45720" marR="45720" marT="45720" marB="45720" anchor="ctr">
+                    <a:lnL w="9525" cap="flat" cmpd="sng" algn="ctr">
+                      <a:solidFill>
+                        <a:srgbClr val="D9D4D0"/>
+                      </a:solidFill>
+                      <a:prstDash val="solid"/>
+                      <a:round/>
+                      <a:headEnd type="none" w="med" len="med"/>
+                      <a:tailEnd type="none" w="med" len="med"/>
+                    </a:lnL>
+                    <a:lnR w="9525" cap="flat" cmpd="sng" algn="ctr">
+                      <a:solidFill>
+                        <a:srgbClr val="D9D4D0"/>
+                      </a:solidFill>
+                      <a:prstDash val="solid"/>
+                      <a:round/>
+                      <a:headEnd type="none" w="med" len="med"/>
+                      <a:tailEnd type="none" w="med" len="med"/>
+                    </a:lnR>
+                    <a:lnT w="9525" cap="flat" cmpd="sng" algn="ctr">
+                      <a:solidFill>
+                        <a:srgbClr val="D9D4D0"/>
+                      </a:solidFill>
+                      <a:prstDash val="solid"/>
+                      <a:round/>
+                      <a:headEnd type="none" w="med" len="med"/>
+                      <a:tailEnd type="none" w="med" len="med"/>
+                    </a:lnT>
+                    <a:lnB w="9525" cap="flat" cmpd="sng" algn="ctr">
+                      <a:solidFill>
+                        <a:srgbClr val="D9D4D0"/>
+                      </a:solidFill>
+                      <a:prstDash val="solid"/>
+                      <a:round/>
+                      <a:headEnd type="none" w="med" len="med"/>
+                      <a:tailEnd type="none" w="med" len="med"/>
+                    </a:lnB>
+                    <a:solidFill>
+                      <a:srgbClr val="F7F2F3"/>
+                    </a:solidFill>
+                  </a:tcPr>
+                </a:tc>
+              </a:tr>
+              <a:tr h="384048">
+                <a:tc>
+                  <a:txBody>
+                    <a:bodyPr/>
+                    <a:lstStyle/>
+                    <a:p>
+                      <a:pPr algn="l" indent="0" marL="0">
+                        <a:buNone/>
+                      </a:pPr>
+                      <a:r>
+                        <a:rPr lang="en-US" sz="1800" dirty="0">
+                          <a:solidFill>
+                            <a:srgbClr val="0B0B0B"/>
+                          </a:solidFill>
+                          <a:latin typeface="Calibri" pitchFamily="34" charset="0"/>
+                          <a:ea typeface="Calibri" pitchFamily="34" charset="-122"/>
+                          <a:cs typeface="Calibri" pitchFamily="34" charset="-120"/>
+                        </a:rPr>
+                        <a:t>Thêo1 / ThêoBR / ThêoH</a:t>
+                      </a:r>
+                      <a:endParaRPr lang="en-US" sz="1800" dirty="0">
+                        <a:latin typeface="Calibri" charset="0"/>
+                        <a:ea typeface="Calibri" charset="0"/>
+                        <a:cs typeface="Calibri" charset="0"/>
+                      </a:endParaRPr>
+                    </a:p>
+                  </a:txBody>
+                  <a:tcPr marL="45720" marR="45720" marT="45720" marB="45720" anchor="ctr">
+                    <a:lnL w="9525" cap="flat" cmpd="sng" algn="ctr">
+                      <a:solidFill>
+                        <a:srgbClr val="D9D4D0"/>
+                      </a:solidFill>
+                      <a:prstDash val="solid"/>
+                      <a:round/>
+                      <a:headEnd type="none" w="med" len="med"/>
+                      <a:tailEnd type="none" w="med" len="med"/>
+                    </a:lnL>
+                    <a:lnR w="9525" cap="flat" cmpd="sng" algn="ctr">
+                      <a:solidFill>
+                        <a:srgbClr val="D9D4D0"/>
+                      </a:solidFill>
+                      <a:prstDash val="solid"/>
+                      <a:round/>
+                      <a:headEnd type="none" w="med" len="med"/>
+                      <a:tailEnd type="none" w="med" len="med"/>
+                    </a:lnR>
+                    <a:lnT w="9525" cap="flat" cmpd="sng" algn="ctr">
+                      <a:solidFill>
+                        <a:srgbClr val="D9D4D0"/>
+                      </a:solidFill>
+                      <a:prstDash val="solid"/>
+                      <a:round/>
+                      <a:headEnd type="none" w="med" len="med"/>
+                      <a:tailEnd type="none" w="med" len="med"/>
+                    </a:lnT>
+                    <a:lnB w="9525" cap="flat" cmpd="sng" algn="ctr">
+                      <a:solidFill>
+                        <a:srgbClr val="D9D4D0"/>
+                      </a:solidFill>
+                      <a:prstDash val="solid"/>
+                      <a:round/>
+                      <a:headEnd type="none" w="med" len="med"/>
+                      <a:tailEnd type="none" w="med" len="med"/>
+                    </a:lnB>
+                    <a:solidFill>
+                      <a:srgbClr val="FFFFFF"/>
+                    </a:solidFill>
+                  </a:tcPr>
+                </a:tc>
+                <a:tc>
+                  <a:txBody>
+                    <a:bodyPr/>
+                    <a:lstStyle/>
+                    <a:p>
+                      <a:pPr algn="ctr" indent="0" marL="0">
+                        <a:buNone/>
+                      </a:pPr>
+                      <a:r>
+                        <a:rPr lang="en-US" sz="1800" dirty="0">
+                          <a:solidFill>
+                            <a:srgbClr val="0B0B0B"/>
+                          </a:solidFill>
+                          <a:latin typeface="Calibri" pitchFamily="34" charset="0"/>
+                          <a:ea typeface="Calibri" pitchFamily="34" charset="-122"/>
+                          <a:cs typeface="Calibri" pitchFamily="34" charset="-120"/>
+                        </a:rPr>
+                        <a:t>yes</a:t>
+                      </a:r>
+                      <a:endParaRPr lang="en-US" sz="1800" dirty="0">
+                        <a:latin typeface="Calibri" charset="0"/>
+                        <a:ea typeface="Calibri" charset="0"/>
+                        <a:cs typeface="Calibri" charset="0"/>
+                      </a:endParaRPr>
+                    </a:p>
+                  </a:txBody>
+                  <a:tcPr marL="45720" marR="45720" marT="45720" marB="45720" anchor="ctr">
+                    <a:lnL w="9525" cap="flat" cmpd="sng" algn="ctr">
+                      <a:solidFill>
+                        <a:srgbClr val="D9D4D0"/>
+                      </a:solidFill>
+                      <a:prstDash val="solid"/>
+                      <a:round/>
+                      <a:headEnd type="none" w="med" len="med"/>
+                      <a:tailEnd type="none" w="med" len="med"/>
+                    </a:lnL>
+                    <a:lnR w="9525" cap="flat" cmpd="sng" algn="ctr">
+                      <a:solidFill>
+                        <a:srgbClr val="D9D4D0"/>
+                      </a:solidFill>
+                      <a:prstDash val="solid"/>
+                      <a:round/>
+                      <a:headEnd type="none" w="med" len="med"/>
+                      <a:tailEnd type="none" w="med" len="med"/>
+                    </a:lnR>
+                    <a:lnT w="9525" cap="flat" cmpd="sng" algn="ctr">
+                      <a:solidFill>
+                        <a:srgbClr val="D9D4D0"/>
+                      </a:solidFill>
+                      <a:prstDash val="solid"/>
+                      <a:round/>
+                      <a:headEnd type="none" w="med" len="med"/>
+                      <a:tailEnd type="none" w="med" len="med"/>
+                    </a:lnT>
+                    <a:lnB w="9525" cap="flat" cmpd="sng" algn="ctr">
+                      <a:solidFill>
+                        <a:srgbClr val="D9D4D0"/>
+                      </a:solidFill>
+                      <a:prstDash val="solid"/>
+                      <a:round/>
+                      <a:headEnd type="none" w="med" len="med"/>
+                      <a:tailEnd type="none" w="med" len="med"/>
+                    </a:lnB>
+                    <a:solidFill>
+                      <a:srgbClr val="FFFFFF"/>
+                    </a:solidFill>
+                  </a:tcPr>
+                </a:tc>
+                <a:tc>
+                  <a:txBody>
+                    <a:bodyPr/>
+                    <a:lstStyle/>
+                    <a:p>
+                      <a:pPr algn="ctr" indent="0" marL="0">
+                        <a:buNone/>
+                      </a:pPr>
+                      <a:r>
+                        <a:rPr lang="en-US" sz="1800" dirty="0">
+                          <a:solidFill>
+                            <a:srgbClr val="0B0B0B"/>
+                          </a:solidFill>
+                          <a:latin typeface="Calibri" pitchFamily="34" charset="0"/>
+                          <a:ea typeface="Calibri" pitchFamily="34" charset="-122"/>
+                          <a:cs typeface="Calibri" pitchFamily="34" charset="-120"/>
+                        </a:rPr>
+                        <a:t>Thêo1 only</a:t>
+                      </a:r>
+                      <a:endParaRPr lang="en-US" sz="1800" dirty="0">
+                        <a:latin typeface="Calibri" charset="0"/>
+                        <a:ea typeface="Calibri" charset="0"/>
+                        <a:cs typeface="Calibri" charset="0"/>
+                      </a:endParaRPr>
+                    </a:p>
+                  </a:txBody>
+                  <a:tcPr marL="45720" marR="45720" marT="45720" marB="45720" anchor="ctr">
+                    <a:lnL w="9525" cap="flat" cmpd="sng" algn="ctr">
+                      <a:solidFill>
+                        <a:srgbClr val="D9D4D0"/>
+                      </a:solidFill>
+                      <a:prstDash val="solid"/>
+                      <a:round/>
+                      <a:headEnd type="none" w="med" len="med"/>
+                      <a:tailEnd type="none" w="med" len="med"/>
+                    </a:lnL>
+                    <a:lnR w="9525" cap="flat" cmpd="sng" algn="ctr">
+                      <a:solidFill>
+                        <a:srgbClr val="D9D4D0"/>
+                      </a:solidFill>
+                      <a:prstDash val="solid"/>
+                      <a:round/>
+                      <a:headEnd type="none" w="med" len="med"/>
+                      <a:tailEnd type="none" w="med" len="med"/>
+                    </a:lnR>
+                    <a:lnT w="9525" cap="flat" cmpd="sng" algn="ctr">
+                      <a:solidFill>
+                        <a:srgbClr val="D9D4D0"/>
+                      </a:solidFill>
+                      <a:prstDash val="solid"/>
+                      <a:round/>
+                      <a:headEnd type="none" w="med" len="med"/>
+                      <a:tailEnd type="none" w="med" len="med"/>
+                    </a:lnT>
+                    <a:lnB w="9525" cap="flat" cmpd="sng" algn="ctr">
+                      <a:solidFill>
+                        <a:srgbClr val="D9D4D0"/>
+                      </a:solidFill>
+                      <a:prstDash val="solid"/>
+                      <a:round/>
+                      <a:headEnd type="none" w="med" len="med"/>
+                      <a:tailEnd type="none" w="med" len="med"/>
+                    </a:lnB>
+                    <a:solidFill>
+                      <a:srgbClr val="FFFFFF"/>
+                    </a:solidFill>
+                  </a:tcPr>
+                </a:tc>
+                <a:tc>
+                  <a:txBody>
+                    <a:bodyPr/>
+                    <a:lstStyle/>
+                    <a:p>
+                      <a:pPr algn="ctr" indent="0" marL="0">
+                        <a:buNone/>
+                      </a:pPr>
+                      <a:r>
+                        <a:rPr lang="en-US" sz="1800" dirty="0">
+                          <a:solidFill>
+                            <a:srgbClr val="0B0B0B"/>
+                          </a:solidFill>
+                          <a:latin typeface="Calibri" pitchFamily="34" charset="0"/>
+                          <a:ea typeface="Calibri" pitchFamily="34" charset="-122"/>
+                          <a:cs typeface="Calibri" pitchFamily="34" charset="-120"/>
+                        </a:rPr>
+                        <a:t>yes</a:t>
+                      </a:r>
+                      <a:endParaRPr lang="en-US" sz="1800" dirty="0">
+                        <a:latin typeface="Calibri" charset="0"/>
+                        <a:ea typeface="Calibri" charset="0"/>
+                        <a:cs typeface="Calibri" charset="0"/>
+                      </a:endParaRPr>
+                    </a:p>
+                  </a:txBody>
+                  <a:tcPr marL="45720" marR="45720" marT="45720" marB="45720" anchor="ctr">
+                    <a:lnL w="9525" cap="flat" cmpd="sng" algn="ctr">
+                      <a:solidFill>
+                        <a:srgbClr val="D9D4D0"/>
+                      </a:solidFill>
+                      <a:prstDash val="solid"/>
+                      <a:round/>
+                      <a:headEnd type="none" w="med" len="med"/>
+                      <a:tailEnd type="none" w="med" len="med"/>
+                    </a:lnL>
+                    <a:lnR w="9525" cap="flat" cmpd="sng" algn="ctr">
+                      <a:solidFill>
+                        <a:srgbClr val="D9D4D0"/>
+                      </a:solidFill>
+                      <a:prstDash val="solid"/>
+                      <a:round/>
+                      <a:headEnd type="none" w="med" len="med"/>
+                      <a:tailEnd type="none" w="med" len="med"/>
+                    </a:lnR>
+                    <a:lnT w="9525" cap="flat" cmpd="sng" algn="ctr">
+                      <a:solidFill>
+                        <a:srgbClr val="D9D4D0"/>
+                      </a:solidFill>
+                      <a:prstDash val="solid"/>
+                      <a:round/>
+                      <a:headEnd type="none" w="med" len="med"/>
+                      <a:tailEnd type="none" w="med" len="med"/>
+                    </a:lnT>
+                    <a:lnB w="9525" cap="flat" cmpd="sng" algn="ctr">
+                      <a:solidFill>
+                        <a:srgbClr val="D9D4D0"/>
+                      </a:solidFill>
+                      <a:prstDash val="solid"/>
+                      <a:round/>
+                      <a:headEnd type="none" w="med" len="med"/>
+                      <a:tailEnd type="none" w="med" len="med"/>
+                    </a:lnB>
+                    <a:solidFill>
+                      <a:srgbClr val="FFFFFF"/>
+                    </a:solidFill>
+                  </a:tcPr>
+                </a:tc>
+              </a:tr>
+              <a:tr h="658368">
+                <a:tc>
+                  <a:txBody>
+                    <a:bodyPr/>
+                    <a:lstStyle/>
+                    <a:p>
+                      <a:pPr algn="l" indent="0" marL="0">
+                        <a:buNone/>
+                      </a:pPr>
+                      <a:r>
+                        <a:rPr lang="en-US" sz="1800" dirty="0">
+                          <a:solidFill>
+                            <a:srgbClr val="0B0B0B"/>
+                          </a:solidFill>
+                          <a:latin typeface="Calibri" pitchFamily="34" charset="0"/>
+                          <a:ea typeface="Calibri" pitchFamily="34" charset="-122"/>
+                          <a:cs typeface="Calibri" pitchFamily="34" charset="-120"/>
+                        </a:rPr>
+                        <a:t>Dynamic (time-resolved) deviation</a:t>
+                      </a:r>
+                      <a:endParaRPr lang="en-US" sz="1800" dirty="0">
+                        <a:latin typeface="Calibri" charset="0"/>
+                        <a:ea typeface="Calibri" charset="0"/>
+                        <a:cs typeface="Calibri" charset="0"/>
+                      </a:endParaRPr>
+                    </a:p>
+                  </a:txBody>
+                  <a:tcPr marL="45720" marR="45720" marT="45720" marB="45720" anchor="ctr">
+                    <a:lnL w="9525" cap="flat" cmpd="sng" algn="ctr">
+                      <a:solidFill>
+                        <a:srgbClr val="D9D4D0"/>
+                      </a:solidFill>
+                      <a:prstDash val="solid"/>
+                      <a:round/>
+                      <a:headEnd type="none" w="med" len="med"/>
+                      <a:tailEnd type="none" w="med" len="med"/>
+                    </a:lnL>
+                    <a:lnR w="9525" cap="flat" cmpd="sng" algn="ctr">
+                      <a:solidFill>
+                        <a:srgbClr val="D9D4D0"/>
+                      </a:solidFill>
+                      <a:prstDash val="solid"/>
+                      <a:round/>
+                      <a:headEnd type="none" w="med" len="med"/>
+                      <a:tailEnd type="none" w="med" len="med"/>
+                    </a:lnR>
+                    <a:lnT w="9525" cap="flat" cmpd="sng" algn="ctr">
+                      <a:solidFill>
+                        <a:srgbClr val="D9D4D0"/>
+                      </a:solidFill>
+                      <a:prstDash val="solid"/>
+                      <a:round/>
+                      <a:headEnd type="none" w="med" len="med"/>
+                      <a:tailEnd type="none" w="med" len="med"/>
+                    </a:lnT>
+                    <a:lnB w="9525" cap="flat" cmpd="sng" algn="ctr">
+                      <a:solidFill>
+                        <a:srgbClr val="D9D4D0"/>
+                      </a:solidFill>
+                      <a:prstDash val="solid"/>
+                      <a:round/>
+                      <a:headEnd type="none" w="med" len="med"/>
+                      <a:tailEnd type="none" w="med" len="med"/>
+                    </a:lnB>
+                    <a:solidFill>
+                      <a:srgbClr val="F7F2F3"/>
+                    </a:solidFill>
+                  </a:tcPr>
+                </a:tc>
+                <a:tc>
+                  <a:txBody>
+                    <a:bodyPr/>
+                    <a:lstStyle/>
+                    <a:p>
+                      <a:pPr algn="ctr" indent="0" marL="0">
+                        <a:buNone/>
+                      </a:pPr>
+                      <a:r>
+                        <a:rPr lang="en-US" sz="1800" dirty="0">
+                          <a:solidFill>
+                            <a:srgbClr val="0B0B0B"/>
+                          </a:solidFill>
+                          <a:latin typeface="Calibri" pitchFamily="34" charset="0"/>
+                          <a:ea typeface="Calibri" pitchFamily="34" charset="-122"/>
+                          <a:cs typeface="Calibri" pitchFamily="34" charset="-120"/>
+                        </a:rPr>
+                        <a:t>yes</a:t>
+                      </a:r>
+                      <a:endParaRPr lang="en-US" sz="1800" dirty="0">
+                        <a:latin typeface="Calibri" charset="0"/>
+                        <a:ea typeface="Calibri" charset="0"/>
+                        <a:cs typeface="Calibri" charset="0"/>
+                      </a:endParaRPr>
+                    </a:p>
+                  </a:txBody>
+                  <a:tcPr marL="45720" marR="45720" marT="45720" marB="45720" anchor="ctr">
+                    <a:lnL w="9525" cap="flat" cmpd="sng" algn="ctr">
+                      <a:solidFill>
+                        <a:srgbClr val="D9D4D0"/>
+                      </a:solidFill>
+                      <a:prstDash val="solid"/>
+                      <a:round/>
+                      <a:headEnd type="none" w="med" len="med"/>
+                      <a:tailEnd type="none" w="med" len="med"/>
+                    </a:lnL>
+                    <a:lnR w="9525" cap="flat" cmpd="sng" algn="ctr">
+                      <a:solidFill>
+                        <a:srgbClr val="D9D4D0"/>
+                      </a:solidFill>
+                      <a:prstDash val="solid"/>
+                      <a:round/>
+                      <a:headEnd type="none" w="med" len="med"/>
+                      <a:tailEnd type="none" w="med" len="med"/>
+                    </a:lnR>
+                    <a:lnT w="9525" cap="flat" cmpd="sng" algn="ctr">
+                      <a:solidFill>
+                        <a:srgbClr val="D9D4D0"/>
+                      </a:solidFill>
+                      <a:prstDash val="solid"/>
+                      <a:round/>
+                      <a:headEnd type="none" w="med" len="med"/>
+                      <a:tailEnd type="none" w="med" len="med"/>
+                    </a:lnT>
+                    <a:lnB w="9525" cap="flat" cmpd="sng" algn="ctr">
+                      <a:solidFill>
+                        <a:srgbClr val="D9D4D0"/>
+                      </a:solidFill>
+                      <a:prstDash val="solid"/>
+                      <a:round/>
+                      <a:headEnd type="none" w="med" len="med"/>
+                      <a:tailEnd type="none" w="med" len="med"/>
+                    </a:lnB>
+                    <a:solidFill>
+                      <a:srgbClr val="F7F2F3"/>
+                    </a:solidFill>
+                  </a:tcPr>
+                </a:tc>
+                <a:tc>
+                  <a:txBody>
+                    <a:bodyPr/>
+                    <a:lstStyle/>
+                    <a:p>
+                      <a:pPr algn="ctr" indent="0" marL="0">
+                        <a:buNone/>
+                      </a:pPr>
+                      <a:r>
+                        <a:rPr lang="en-US" sz="1800" dirty="0">
+                          <a:solidFill>
+                            <a:srgbClr val="0B0B0B"/>
+                          </a:solidFill>
+                          <a:latin typeface="Calibri" pitchFamily="34" charset="0"/>
+                          <a:ea typeface="Calibri" pitchFamily="34" charset="-122"/>
+                          <a:cs typeface="Calibri" pitchFamily="34" charset="-120"/>
+                        </a:rPr>
+                        <a:t>no</a:t>
+                      </a:r>
+                      <a:endParaRPr lang="en-US" sz="1800" dirty="0">
+                        <a:latin typeface="Calibri" charset="0"/>
+                        <a:ea typeface="Calibri" charset="0"/>
+                        <a:cs typeface="Calibri" charset="0"/>
+                      </a:endParaRPr>
+                    </a:p>
+                  </a:txBody>
+                  <a:tcPr marL="45720" marR="45720" marT="45720" marB="45720" anchor="ctr">
+                    <a:lnL w="9525" cap="flat" cmpd="sng" algn="ctr">
+                      <a:solidFill>
+                        <a:srgbClr val="D9D4D0"/>
+                      </a:solidFill>
+                      <a:prstDash val="solid"/>
+                      <a:round/>
+                      <a:headEnd type="none" w="med" len="med"/>
+                      <a:tailEnd type="none" w="med" len="med"/>
+                    </a:lnL>
+                    <a:lnR w="9525" cap="flat" cmpd="sng" algn="ctr">
+                      <a:solidFill>
+                        <a:srgbClr val="D9D4D0"/>
+                      </a:solidFill>
+                      <a:prstDash val="solid"/>
+                      <a:round/>
+                      <a:headEnd type="none" w="med" len="med"/>
+                      <a:tailEnd type="none" w="med" len="med"/>
+                    </a:lnR>
+                    <a:lnT w="9525" cap="flat" cmpd="sng" algn="ctr">
+                      <a:solidFill>
+                        <a:srgbClr val="D9D4D0"/>
+                      </a:solidFill>
+                      <a:prstDash val="solid"/>
+                      <a:round/>
+                      <a:headEnd type="none" w="med" len="med"/>
+                      <a:tailEnd type="none" w="med" len="med"/>
+                    </a:lnT>
+                    <a:lnB w="9525" cap="flat" cmpd="sng" algn="ctr">
+                      <a:solidFill>
+                        <a:srgbClr val="D9D4D0"/>
+                      </a:solidFill>
+                      <a:prstDash val="solid"/>
+                      <a:round/>
+                      <a:headEnd type="none" w="med" len="med"/>
+                      <a:tailEnd type="none" w="med" len="med"/>
+                    </a:lnB>
+                    <a:solidFill>
+                      <a:srgbClr val="F7F2F3"/>
+                    </a:solidFill>
+                  </a:tcPr>
+                </a:tc>
+                <a:tc>
+                  <a:txBody>
+                    <a:bodyPr/>
+                    <a:lstStyle/>
+                    <a:p>
+                      <a:pPr algn="ctr" indent="0" marL="0">
+                        <a:buNone/>
+                      </a:pPr>
+                      <a:r>
+                        <a:rPr lang="en-US" sz="1800" dirty="0">
+                          <a:solidFill>
+                            <a:srgbClr val="0B0B0B"/>
+                          </a:solidFill>
+                          <a:latin typeface="Calibri" pitchFamily="34" charset="0"/>
+                          <a:ea typeface="Calibri" pitchFamily="34" charset="-122"/>
+                          <a:cs typeface="Calibri" pitchFamily="34" charset="-120"/>
+                        </a:rPr>
+                        <a:t>yes</a:t>
+                      </a:r>
+                      <a:endParaRPr lang="en-US" sz="1800" dirty="0">
+                        <a:latin typeface="Calibri" charset="0"/>
+                        <a:ea typeface="Calibri" charset="0"/>
+                        <a:cs typeface="Calibri" charset="0"/>
+                      </a:endParaRPr>
+                    </a:p>
+                  </a:txBody>
+                  <a:tcPr marL="45720" marR="45720" marT="45720" marB="45720" anchor="ctr">
+                    <a:lnL w="9525" cap="flat" cmpd="sng" algn="ctr">
+                      <a:solidFill>
+                        <a:srgbClr val="D9D4D0"/>
+                      </a:solidFill>
+                      <a:prstDash val="solid"/>
+                      <a:round/>
+                      <a:headEnd type="none" w="med" len="med"/>
+                      <a:tailEnd type="none" w="med" len="med"/>
+                    </a:lnL>
+                    <a:lnR w="9525" cap="flat" cmpd="sng" algn="ctr">
+                      <a:solidFill>
+                        <a:srgbClr val="D9D4D0"/>
+                      </a:solidFill>
+                      <a:prstDash val="solid"/>
+                      <a:round/>
+                      <a:headEnd type="none" w="med" len="med"/>
+                      <a:tailEnd type="none" w="med" len="med"/>
+                    </a:lnR>
+                    <a:lnT w="9525" cap="flat" cmpd="sng" algn="ctr">
+                      <a:solidFill>
+                        <a:srgbClr val="D9D4D0"/>
+                      </a:solidFill>
+                      <a:prstDash val="solid"/>
+                      <a:round/>
+                      <a:headEnd type="none" w="med" len="med"/>
+                      <a:tailEnd type="none" w="med" len="med"/>
+                    </a:lnT>
+                    <a:lnB w="9525" cap="flat" cmpd="sng" algn="ctr">
+                      <a:solidFill>
+                        <a:srgbClr val="D9D4D0"/>
+                      </a:solidFill>
+                      <a:prstDash val="solid"/>
+                      <a:round/>
+                      <a:headEnd type="none" w="med" len="med"/>
+                      <a:tailEnd type="none" w="med" len="med"/>
+                    </a:lnB>
+                    <a:solidFill>
+                      <a:srgbClr val="F7F2F3"/>
+                    </a:solidFill>
+                  </a:tcPr>
+                </a:tc>
+              </a:tr>
+              <a:tr h="384048">
+                <a:tc>
+                  <a:txBody>
+                    <a:bodyPr/>
+                    <a:lstStyle/>
+                    <a:p>
+                      <a:pPr algn="l" indent="0" marL="0">
+                        <a:buNone/>
+                      </a:pPr>
+                      <a:r>
+                        <a:rPr lang="en-US" sz="1800" dirty="0">
+                          <a:solidFill>
+                            <a:srgbClr val="0B0B0B"/>
+                          </a:solidFill>
+                          <a:latin typeface="Calibri" pitchFamily="34" charset="0"/>
+                          <a:ea typeface="Calibri" pitchFamily="34" charset="-122"/>
+                          <a:cs typeface="Calibri" pitchFamily="34" charset="-120"/>
+                        </a:rPr>
+                        <a:t>Real-time accumulators</a:t>
+                      </a:r>
+                      <a:endParaRPr lang="en-US" sz="1800" dirty="0">
+                        <a:latin typeface="Calibri" charset="0"/>
+                        <a:ea typeface="Calibri" charset="0"/>
+                        <a:cs typeface="Calibri" charset="0"/>
+                      </a:endParaRPr>
+                    </a:p>
+                  </a:txBody>
+                  <a:tcPr marL="45720" marR="45720" marT="45720" marB="45720" anchor="ctr">
+                    <a:lnL w="9525" cap="flat" cmpd="sng" algn="ctr">
+                      <a:solidFill>
+                        <a:srgbClr val="D9D4D0"/>
+                      </a:solidFill>
+                      <a:prstDash val="solid"/>
+                      <a:round/>
+                      <a:headEnd type="none" w="med" len="med"/>
+                      <a:tailEnd type="none" w="med" len="med"/>
+                    </a:lnL>
+                    <a:lnR w="9525" cap="flat" cmpd="sng" algn="ctr">
+                      <a:solidFill>
+                        <a:srgbClr val="D9D4D0"/>
+                      </a:solidFill>
+                      <a:prstDash val="solid"/>
+                      <a:round/>
+                      <a:headEnd type="none" w="med" len="med"/>
+                      <a:tailEnd type="none" w="med" len="med"/>
+                    </a:lnR>
+                    <a:lnT w="9525" cap="flat" cmpd="sng" algn="ctr">
+                      <a:solidFill>
+                        <a:srgbClr val="D9D4D0"/>
+                      </a:solidFill>
+                      <a:prstDash val="solid"/>
+                      <a:round/>
+                      <a:headEnd type="none" w="med" len="med"/>
+                      <a:tailEnd type="none" w="med" len="med"/>
+                    </a:lnT>
+                    <a:lnB w="9525" cap="flat" cmpd="sng" algn="ctr">
+                      <a:solidFill>
+                        <a:srgbClr val="D9D4D0"/>
+                      </a:solidFill>
+                      <a:prstDash val="solid"/>
+                      <a:round/>
+                      <a:headEnd type="none" w="med" len="med"/>
+                      <a:tailEnd type="none" w="med" len="med"/>
+                    </a:lnB>
+                    <a:solidFill>
+                      <a:srgbClr val="FFFFFF"/>
+                    </a:solidFill>
+                  </a:tcPr>
+                </a:tc>
+                <a:tc>
+                  <a:txBody>
+                    <a:bodyPr/>
+                    <a:lstStyle/>
+                    <a:p>
+                      <a:pPr algn="ctr" indent="0" marL="0">
+                        <a:buNone/>
+                      </a:pPr>
+                      <a:r>
+                        <a:rPr lang="en-US" sz="1800" dirty="0">
+                          <a:solidFill>
+                            <a:srgbClr val="0B0B0B"/>
+                          </a:solidFill>
+                          <a:latin typeface="Calibri" pitchFamily="34" charset="0"/>
+                          <a:ea typeface="Calibri" pitchFamily="34" charset="-122"/>
+                          <a:cs typeface="Calibri" pitchFamily="34" charset="-120"/>
+                        </a:rPr>
+                        <a:t>no</a:t>
+                      </a:r>
+                      <a:endParaRPr lang="en-US" sz="1800" dirty="0">
+                        <a:latin typeface="Calibri" charset="0"/>
+                        <a:ea typeface="Calibri" charset="0"/>
+                        <a:cs typeface="Calibri" charset="0"/>
+                      </a:endParaRPr>
+                    </a:p>
+                  </a:txBody>
+                  <a:tcPr marL="45720" marR="45720" marT="45720" marB="45720" anchor="ctr">
+                    <a:lnL w="9525" cap="flat" cmpd="sng" algn="ctr">
+                      <a:solidFill>
+                        <a:srgbClr val="D9D4D0"/>
+                      </a:solidFill>
+                      <a:prstDash val="solid"/>
+                      <a:round/>
+                      <a:headEnd type="none" w="med" len="med"/>
+                      <a:tailEnd type="none" w="med" len="med"/>
+                    </a:lnL>
+                    <a:lnR w="9525" cap="flat" cmpd="sng" algn="ctr">
+                      <a:solidFill>
+                        <a:srgbClr val="D9D4D0"/>
+                      </a:solidFill>
+                      <a:prstDash val="solid"/>
+                      <a:round/>
+                      <a:headEnd type="none" w="med" len="med"/>
+                      <a:tailEnd type="none" w="med" len="med"/>
+                    </a:lnR>
+                    <a:lnT w="9525" cap="flat" cmpd="sng" algn="ctr">
+                      <a:solidFill>
+                        <a:srgbClr val="D9D4D0"/>
+                      </a:solidFill>
+                      <a:prstDash val="solid"/>
+                      <a:round/>
+                      <a:headEnd type="none" w="med" len="med"/>
+                      <a:tailEnd type="none" w="med" len="med"/>
+                    </a:lnT>
+                    <a:lnB w="9525" cap="flat" cmpd="sng" algn="ctr">
+                      <a:solidFill>
+                        <a:srgbClr val="D9D4D0"/>
+                      </a:solidFill>
+                      <a:prstDash val="solid"/>
+                      <a:round/>
+                      <a:headEnd type="none" w="med" len="med"/>
+                      <a:tailEnd type="none" w="med" len="med"/>
+                    </a:lnB>
+                    <a:solidFill>
+                      <a:srgbClr val="FFFFFF"/>
+                    </a:solidFill>
+                  </a:tcPr>
+                </a:tc>
+                <a:tc>
+                  <a:txBody>
+                    <a:bodyPr/>
+                    <a:lstStyle/>
+                    <a:p>
+                      <a:pPr algn="ctr" indent="0" marL="0">
+                        <a:buNone/>
+                      </a:pPr>
+                      <a:r>
+                        <a:rPr lang="en-US" sz="1800" dirty="0">
+                          <a:solidFill>
+                            <a:srgbClr val="0B0B0B"/>
+                          </a:solidFill>
+                          <a:latin typeface="Calibri" pitchFamily="34" charset="0"/>
+                          <a:ea typeface="Calibri" pitchFamily="34" charset="-122"/>
+                          <a:cs typeface="Calibri" pitchFamily="34" charset="-120"/>
+                        </a:rPr>
+                        <a:t>ADEV, HDEV, TDEV</a:t>
+                      </a:r>
+                      <a:endParaRPr lang="en-US" sz="1800" dirty="0">
+                        <a:latin typeface="Calibri" charset="0"/>
+                        <a:ea typeface="Calibri" charset="0"/>
+                        <a:cs typeface="Calibri" charset="0"/>
+                      </a:endParaRPr>
+                    </a:p>
+                  </a:txBody>
+                  <a:tcPr marL="45720" marR="45720" marT="45720" marB="45720" anchor="ctr">
+                    <a:lnL w="9525" cap="flat" cmpd="sng" algn="ctr">
+                      <a:solidFill>
+                        <a:srgbClr val="D9D4D0"/>
+                      </a:solidFill>
+                      <a:prstDash val="solid"/>
+                      <a:round/>
+                      <a:headEnd type="none" w="med" len="med"/>
+                      <a:tailEnd type="none" w="med" len="med"/>
+                    </a:lnL>
+                    <a:lnR w="9525" cap="flat" cmpd="sng" algn="ctr">
+                      <a:solidFill>
+                        <a:srgbClr val="D9D4D0"/>
+                      </a:solidFill>
+                      <a:prstDash val="solid"/>
+                      <a:round/>
+                      <a:headEnd type="none" w="med" len="med"/>
+                      <a:tailEnd type="none" w="med" len="med"/>
+                    </a:lnR>
+                    <a:lnT w="9525" cap="flat" cmpd="sng" algn="ctr">
+                      <a:solidFill>
+                        <a:srgbClr val="D9D4D0"/>
+                      </a:solidFill>
+                      <a:prstDash val="solid"/>
+                      <a:round/>
+                      <a:headEnd type="none" w="med" len="med"/>
+                      <a:tailEnd type="none" w="med" len="med"/>
+                    </a:lnT>
+                    <a:lnB w="9525" cap="flat" cmpd="sng" algn="ctr">
+                      <a:solidFill>
+                        <a:srgbClr val="D9D4D0"/>
+                      </a:solidFill>
+                      <a:prstDash val="solid"/>
+                      <a:round/>
+                      <a:headEnd type="none" w="med" len="med"/>
+                      <a:tailEnd type="none" w="med" len="med"/>
+                    </a:lnB>
+                    <a:solidFill>
+                      <a:srgbClr val="FFFFFF"/>
+                    </a:solidFill>
+                  </a:tcPr>
+                </a:tc>
+                <a:tc>
+                  <a:txBody>
+                    <a:bodyPr/>
+                    <a:lstStyle/>
+                    <a:p>
+                      <a:pPr algn="ctr" indent="0" marL="0">
+                        <a:buNone/>
+                      </a:pPr>
+                      <a:r>
+                        <a:rPr lang="en-US" sz="1800" dirty="0">
+                          <a:solidFill>
+                            <a:srgbClr val="0B0B0B"/>
+                          </a:solidFill>
+                          <a:latin typeface="Calibri" pitchFamily="34" charset="0"/>
+                          <a:ea typeface="Calibri" pitchFamily="34" charset="-122"/>
+                          <a:cs typeface="Calibri" pitchFamily="34" charset="-120"/>
+                        </a:rPr>
+                        <a:t>ADEV, MDEV, HDEV, MHDEV</a:t>
+                      </a:r>
+                      <a:endParaRPr lang="en-US" sz="1800" dirty="0">
+                        <a:latin typeface="Calibri" charset="0"/>
+                        <a:ea typeface="Calibri" charset="0"/>
+                        <a:cs typeface="Calibri" charset="0"/>
+                      </a:endParaRPr>
+                    </a:p>
+                  </a:txBody>
+                  <a:tcPr marL="45720" marR="45720" marT="45720" marB="45720" anchor="ctr">
+                    <a:lnL w="9525" cap="flat" cmpd="sng" algn="ctr">
+                      <a:solidFill>
+                        <a:srgbClr val="D9D4D0"/>
+                      </a:solidFill>
+                      <a:prstDash val="solid"/>
+                      <a:round/>
+                      <a:headEnd type="none" w="med" len="med"/>
+                      <a:tailEnd type="none" w="med" len="med"/>
+                    </a:lnL>
+                    <a:lnR w="9525" cap="flat" cmpd="sng" algn="ctr">
+                      <a:solidFill>
+                        <a:srgbClr val="D9D4D0"/>
+                      </a:solidFill>
+                      <a:prstDash val="solid"/>
+                      <a:round/>
+                      <a:headEnd type="none" w="med" len="med"/>
+                      <a:tailEnd type="none" w="med" len="med"/>
+                    </a:lnR>
+                    <a:lnT w="9525" cap="flat" cmpd="sng" algn="ctr">
+                      <a:solidFill>
+                        <a:srgbClr val="D9D4D0"/>
+                      </a:solidFill>
+                      <a:prstDash val="solid"/>
+                      <a:round/>
+                      <a:headEnd type="none" w="med" len="med"/>
+                      <a:tailEnd type="none" w="med" len="med"/>
+                    </a:lnT>
+                    <a:lnB w="9525" cap="flat" cmpd="sng" algn="ctr">
+                      <a:solidFill>
+                        <a:srgbClr val="D9D4D0"/>
+                      </a:solidFill>
+                      <a:prstDash val="solid"/>
+                      <a:round/>
+                      <a:headEnd type="none" w="med" len="med"/>
+                      <a:tailEnd type="none" w="med" len="med"/>
+                    </a:lnB>
+                    <a:solidFill>
+                      <a:srgbClr val="FFFFFF"/>
+                    </a:solidFill>
+                  </a:tcPr>
+                </a:tc>
+              </a:tr>
+              <a:tr h="384048">
+                <a:tc>
+                  <a:txBody>
+                    <a:bodyPr/>
+                    <a:lstStyle/>
+                    <a:p>
+                      <a:pPr algn="l" indent="0" marL="0">
+                        <a:buNone/>
+                      </a:pPr>
+                      <a:r>
+                        <a:rPr lang="en-US" sz="1800" dirty="0">
+                          <a:solidFill>
+                            <a:srgbClr val="0B0B0B"/>
+                          </a:solidFill>
+                          <a:latin typeface="Calibri" pitchFamily="34" charset="0"/>
+                          <a:ea typeface="Calibri" pitchFamily="34" charset="-122"/>
+                          <a:cs typeface="Calibri" pitchFamily="34" charset="-120"/>
+                        </a:rPr>
+                        <a:t>N-cornered hat</a:t>
+                      </a:r>
+                      <a:endParaRPr lang="en-US" sz="1800" dirty="0">
+                        <a:latin typeface="Calibri" charset="0"/>
+                        <a:ea typeface="Calibri" charset="0"/>
+                        <a:cs typeface="Calibri" charset="0"/>
+                      </a:endParaRPr>
+                    </a:p>
+                  </a:txBody>
+                  <a:tcPr marL="45720" marR="45720" marT="45720" marB="45720" anchor="ctr">
+                    <a:lnL w="9525" cap="flat" cmpd="sng" algn="ctr">
+                      <a:solidFill>
+                        <a:srgbClr val="D9D4D0"/>
+                      </a:solidFill>
+                      <a:prstDash val="solid"/>
+                      <a:round/>
+                      <a:headEnd type="none" w="med" len="med"/>
+                      <a:tailEnd type="none" w="med" len="med"/>
+                    </a:lnL>
+                    <a:lnR w="9525" cap="flat" cmpd="sng" algn="ctr">
+                      <a:solidFill>
+                        <a:srgbClr val="D9D4D0"/>
+                      </a:solidFill>
+                      <a:prstDash val="solid"/>
+                      <a:round/>
+                      <a:headEnd type="none" w="med" len="med"/>
+                      <a:tailEnd type="none" w="med" len="med"/>
+                    </a:lnR>
+                    <a:lnT w="9525" cap="flat" cmpd="sng" algn="ctr">
+                      <a:solidFill>
+                        <a:srgbClr val="D9D4D0"/>
+                      </a:solidFill>
+                      <a:prstDash val="solid"/>
+                      <a:round/>
+                      <a:headEnd type="none" w="med" len="med"/>
+                      <a:tailEnd type="none" w="med" len="med"/>
+                    </a:lnT>
+                    <a:lnB w="9525" cap="flat" cmpd="sng" algn="ctr">
+                      <a:solidFill>
+                        <a:srgbClr val="D9D4D0"/>
+                      </a:solidFill>
+                      <a:prstDash val="solid"/>
+                      <a:round/>
+                      <a:headEnd type="none" w="med" len="med"/>
+                      <a:tailEnd type="none" w="med" len="med"/>
+                    </a:lnB>
+                    <a:solidFill>
+                      <a:srgbClr val="F7F2F3"/>
+                    </a:solidFill>
+                  </a:tcPr>
+                </a:tc>
+                <a:tc>
+                  <a:txBody>
+                    <a:bodyPr/>
+                    <a:lstStyle/>
+                    <a:p>
+                      <a:pPr algn="ctr" indent="0" marL="0">
+                        <a:buNone/>
+                      </a:pPr>
+                      <a:r>
+                        <a:rPr lang="en-US" sz="1800" dirty="0">
+                          <a:solidFill>
+                            <a:srgbClr val="0B0B0B"/>
+                          </a:solidFill>
+                          <a:latin typeface="Calibri" pitchFamily="34" charset="0"/>
+                          <a:ea typeface="Calibri" pitchFamily="34" charset="-122"/>
+                          <a:cs typeface="Calibri" pitchFamily="34" charset="-120"/>
+                        </a:rPr>
+                        <a:t>three clocks</a:t>
+                      </a:r>
+                      <a:endParaRPr lang="en-US" sz="1800" dirty="0">
+                        <a:latin typeface="Calibri" charset="0"/>
+                        <a:ea typeface="Calibri" charset="0"/>
+                        <a:cs typeface="Calibri" charset="0"/>
+                      </a:endParaRPr>
+                    </a:p>
+                  </a:txBody>
+                  <a:tcPr marL="45720" marR="45720" marT="45720" marB="45720" anchor="ctr">
+                    <a:lnL w="9525" cap="flat" cmpd="sng" algn="ctr">
+                      <a:solidFill>
+                        <a:srgbClr val="D9D4D0"/>
+                      </a:solidFill>
+                      <a:prstDash val="solid"/>
+                      <a:round/>
+                      <a:headEnd type="none" w="med" len="med"/>
+                      <a:tailEnd type="none" w="med" len="med"/>
+                    </a:lnL>
+                    <a:lnR w="9525" cap="flat" cmpd="sng" algn="ctr">
+                      <a:solidFill>
+                        <a:srgbClr val="D9D4D0"/>
+                      </a:solidFill>
+                      <a:prstDash val="solid"/>
+                      <a:round/>
+                      <a:headEnd type="none" w="med" len="med"/>
+                      <a:tailEnd type="none" w="med" len="med"/>
+                    </a:lnR>
+                    <a:lnT w="9525" cap="flat" cmpd="sng" algn="ctr">
+                      <a:solidFill>
+                        <a:srgbClr val="D9D4D0"/>
+                      </a:solidFill>
+                      <a:prstDash val="solid"/>
+                      <a:round/>
+                      <a:headEnd type="none" w="med" len="med"/>
+                      <a:tailEnd type="none" w="med" len="med"/>
+                    </a:lnT>
+                    <a:lnB w="9525" cap="flat" cmpd="sng" algn="ctr">
+                      <a:solidFill>
+                        <a:srgbClr val="D9D4D0"/>
+                      </a:solidFill>
+                      <a:prstDash val="solid"/>
+                      <a:round/>
+                      <a:headEnd type="none" w="med" len="med"/>
+                      <a:tailEnd type="none" w="med" len="med"/>
+                    </a:lnB>
+                    <a:solidFill>
+                      <a:srgbClr val="F7F2F3"/>
+                    </a:solidFill>
+                  </a:tcPr>
+                </a:tc>
+                <a:tc>
+                  <a:txBody>
+                    <a:bodyPr/>
+                    <a:lstStyle/>
+                    <a:p>
+                      <a:pPr algn="ctr" indent="0" marL="0">
+                        <a:buNone/>
+                      </a:pPr>
+                      <a:r>
+                        <a:rPr lang="en-US" sz="1800" dirty="0">
+                          <a:solidFill>
+                            <a:srgbClr val="0B0B0B"/>
+                          </a:solidFill>
+                          <a:latin typeface="Calibri" pitchFamily="34" charset="0"/>
+                          <a:ea typeface="Calibri" pitchFamily="34" charset="-122"/>
+                          <a:cs typeface="Calibri" pitchFamily="34" charset="-120"/>
+                        </a:rPr>
+                        <a:t>three clocks</a:t>
+                      </a:r>
+                      <a:endParaRPr lang="en-US" sz="1800" dirty="0">
+                        <a:latin typeface="Calibri" charset="0"/>
+                        <a:ea typeface="Calibri" charset="0"/>
+                        <a:cs typeface="Calibri" charset="0"/>
+                      </a:endParaRPr>
+                    </a:p>
+                  </a:txBody>
+                  <a:tcPr marL="45720" marR="45720" marT="45720" marB="45720" anchor="ctr">
+                    <a:lnL w="9525" cap="flat" cmpd="sng" algn="ctr">
+                      <a:solidFill>
+                        <a:srgbClr val="D9D4D0"/>
+                      </a:solidFill>
+                      <a:prstDash val="solid"/>
+                      <a:round/>
+                      <a:headEnd type="none" w="med" len="med"/>
+                      <a:tailEnd type="none" w="med" len="med"/>
+                    </a:lnL>
+                    <a:lnR w="9525" cap="flat" cmpd="sng" algn="ctr">
+                      <a:solidFill>
+                        <a:srgbClr val="D9D4D0"/>
+                      </a:solidFill>
+                      <a:prstDash val="solid"/>
+                      <a:round/>
+                      <a:headEnd type="none" w="med" len="med"/>
+                      <a:tailEnd type="none" w="med" len="med"/>
+                    </a:lnR>
+                    <a:lnT w="9525" cap="flat" cmpd="sng" algn="ctr">
+                      <a:solidFill>
+                        <a:srgbClr val="D9D4D0"/>
+                      </a:solidFill>
+                      <a:prstDash val="solid"/>
+                      <a:round/>
+                      <a:headEnd type="none" w="med" len="med"/>
+                      <a:tailEnd type="none" w="med" len="med"/>
+                    </a:lnT>
+                    <a:lnB w="9525" cap="flat" cmpd="sng" algn="ctr">
+                      <a:solidFill>
+                        <a:srgbClr val="D9D4D0"/>
+                      </a:solidFill>
+                      <a:prstDash val="solid"/>
+                      <a:round/>
+                      <a:headEnd type="none" w="med" len="med"/>
+                      <a:tailEnd type="none" w="med" len="med"/>
+                    </a:lnB>
+                    <a:solidFill>
+                      <a:srgbClr val="F7F2F3"/>
+                    </a:solidFill>
+                  </a:tcPr>
+                </a:tc>
+                <a:tc>
+                  <a:txBody>
+                    <a:bodyPr/>
+                    <a:lstStyle/>
+                    <a:p>
+                      <a:pPr algn="ctr" indent="0" marL="0">
+                        <a:buNone/>
+                      </a:pPr>
+                      <a:r>
+                        <a:rPr lang="en-US" sz="1800" dirty="0">
+                          <a:solidFill>
+                            <a:srgbClr val="0B0B0B"/>
+                          </a:solidFill>
+                          <a:latin typeface="Calibri" pitchFamily="34" charset="0"/>
+                          <a:ea typeface="Calibri" pitchFamily="34" charset="-122"/>
+                          <a:cs typeface="Calibri" pitchFamily="34" charset="-120"/>
+                        </a:rPr>
+                        <a:t>N ≥ 3</a:t>
+                      </a:r>
+                      <a:endParaRPr lang="en-US" sz="1800" dirty="0">
+                        <a:latin typeface="Calibri" charset="0"/>
+                        <a:ea typeface="Calibri" charset="0"/>
+                        <a:cs typeface="Calibri" charset="0"/>
+                      </a:endParaRPr>
+                    </a:p>
+                  </a:txBody>
+                  <a:tcPr marL="45720" marR="45720" marT="45720" marB="45720" anchor="ctr">
+                    <a:lnL w="9525" cap="flat" cmpd="sng" algn="ctr">
+                      <a:solidFill>
+                        <a:srgbClr val="D9D4D0"/>
+                      </a:solidFill>
+                      <a:prstDash val="solid"/>
+                      <a:round/>
+                      <a:headEnd type="none" w="med" len="med"/>
+                      <a:tailEnd type="none" w="med" len="med"/>
+                    </a:lnL>
+                    <a:lnR w="9525" cap="flat" cmpd="sng" algn="ctr">
+                      <a:solidFill>
+                        <a:srgbClr val="D9D4D0"/>
+                      </a:solidFill>
+                      <a:prstDash val="solid"/>
+                      <a:round/>
+                      <a:headEnd type="none" w="med" len="med"/>
+                      <a:tailEnd type="none" w="med" len="med"/>
+                    </a:lnR>
+                    <a:lnT w="9525" cap="flat" cmpd="sng" algn="ctr">
+                      <a:solidFill>
+                        <a:srgbClr val="D9D4D0"/>
+                      </a:solidFill>
+                      <a:prstDash val="solid"/>
+                      <a:round/>
+                      <a:headEnd type="none" w="med" len="med"/>
+                      <a:tailEnd type="none" w="med" len="med"/>
+                    </a:lnT>
+                    <a:lnB w="9525" cap="flat" cmpd="sng" algn="ctr">
+                      <a:solidFill>
+                        <a:srgbClr val="D9D4D0"/>
+                      </a:solidFill>
+                      <a:prstDash val="solid"/>
+                      <a:round/>
+                      <a:headEnd type="none" w="med" len="med"/>
+                      <a:tailEnd type="none" w="med" len="med"/>
+                    </a:lnB>
+                    <a:solidFill>
+                      <a:srgbClr val="F7F2F3"/>
+                    </a:solidFill>
+                  </a:tcPr>
+                </a:tc>
+              </a:tr>
+              <a:tr h="384048">
+                <a:tc>
+                  <a:txBody>
+                    <a:bodyPr/>
+                    <a:lstStyle/>
+                    <a:p>
+                      <a:pPr algn="l" indent="0" marL="0">
+                        <a:buNone/>
+                      </a:pPr>
+                      <a:r>
+                        <a:rPr lang="en-US" sz="1800" dirty="0">
+                          <a:solidFill>
+                            <a:srgbClr val="0B0B0B"/>
+                          </a:solidFill>
+                          <a:latin typeface="Calibri" pitchFamily="34" charset="0"/>
+                          <a:ea typeface="Calibri" pitchFamily="34" charset="-122"/>
+                          <a:cs typeface="Calibri" pitchFamily="34" charset="-120"/>
+                        </a:rPr>
+                        <a:t>Multithreaded kernels</a:t>
+                      </a:r>
+                      <a:endParaRPr lang="en-US" sz="1800" dirty="0">
+                        <a:latin typeface="Calibri" charset="0"/>
+                        <a:ea typeface="Calibri" charset="0"/>
+                        <a:cs typeface="Calibri" charset="0"/>
+                      </a:endParaRPr>
+                    </a:p>
+                  </a:txBody>
+                  <a:tcPr marL="45720" marR="45720" marT="45720" marB="45720" anchor="ctr">
+                    <a:lnL w="9525" cap="flat" cmpd="sng" algn="ctr">
+                      <a:solidFill>
+                        <a:srgbClr val="D9D4D0"/>
+                      </a:solidFill>
+                      <a:prstDash val="solid"/>
+                      <a:round/>
+                      <a:headEnd type="none" w="med" len="med"/>
+                      <a:tailEnd type="none" w="med" len="med"/>
+                    </a:lnL>
+                    <a:lnR w="9525" cap="flat" cmpd="sng" algn="ctr">
+                      <a:solidFill>
+                        <a:srgbClr val="D9D4D0"/>
+                      </a:solidFill>
+                      <a:prstDash val="solid"/>
+                      <a:round/>
+                      <a:headEnd type="none" w="med" len="med"/>
+                      <a:tailEnd type="none" w="med" len="med"/>
+                    </a:lnR>
+                    <a:lnT w="9525" cap="flat" cmpd="sng" algn="ctr">
+                      <a:solidFill>
+                        <a:srgbClr val="D9D4D0"/>
+                      </a:solidFill>
+                      <a:prstDash val="solid"/>
+                      <a:round/>
+                      <a:headEnd type="none" w="med" len="med"/>
+                      <a:tailEnd type="none" w="med" len="med"/>
+                    </a:lnT>
+                    <a:lnB w="9525" cap="flat" cmpd="sng" algn="ctr">
+                      <a:solidFill>
+                        <a:srgbClr val="D9D4D0"/>
+                      </a:solidFill>
+                      <a:prstDash val="solid"/>
+                      <a:round/>
+                      <a:headEnd type="none" w="med" len="med"/>
+                      <a:tailEnd type="none" w="med" len="med"/>
+                    </a:lnB>
+                    <a:solidFill>
+                      <a:srgbClr val="FFFFFF"/>
+                    </a:solidFill>
+                  </a:tcPr>
+                </a:tc>
+                <a:tc>
+                  <a:txBody>
+                    <a:bodyPr/>
+                    <a:lstStyle/>
+                    <a:p>
+                      <a:pPr algn="ctr" indent="0" marL="0">
+                        <a:buNone/>
+                      </a:pPr>
+                      <a:r>
+                        <a:rPr lang="en-US" sz="1800" dirty="0">
+                          <a:solidFill>
+                            <a:srgbClr val="0B0B0B"/>
+                          </a:solidFill>
+                          <a:latin typeface="Calibri" pitchFamily="34" charset="0"/>
+                          <a:ea typeface="Calibri" pitchFamily="34" charset="-122"/>
+                          <a:cs typeface="Calibri" pitchFamily="34" charset="-120"/>
+                        </a:rPr>
+                        <a:t>n/a</a:t>
+                      </a:r>
+                      <a:endParaRPr lang="en-US" sz="1800" dirty="0">
+                        <a:latin typeface="Calibri" charset="0"/>
+                        <a:ea typeface="Calibri" charset="0"/>
+                        <a:cs typeface="Calibri" charset="0"/>
+                      </a:endParaRPr>
+                    </a:p>
+                  </a:txBody>
+                  <a:tcPr marL="45720" marR="45720" marT="45720" marB="45720" anchor="ctr">
+                    <a:lnL w="9525" cap="flat" cmpd="sng" algn="ctr">
+                      <a:solidFill>
+                        <a:srgbClr val="D9D4D0"/>
+                      </a:solidFill>
+                      <a:prstDash val="solid"/>
+                      <a:round/>
+                      <a:headEnd type="none" w="med" len="med"/>
+                      <a:tailEnd type="none" w="med" len="med"/>
+                    </a:lnL>
+                    <a:lnR w="9525" cap="flat" cmpd="sng" algn="ctr">
+                      <a:solidFill>
+                        <a:srgbClr val="D9D4D0"/>
+                      </a:solidFill>
+                      <a:prstDash val="solid"/>
+                      <a:round/>
+                      <a:headEnd type="none" w="med" len="med"/>
+                      <a:tailEnd type="none" w="med" len="med"/>
+                    </a:lnR>
+                    <a:lnT w="9525" cap="flat" cmpd="sng" algn="ctr">
+                      <a:solidFill>
+                        <a:srgbClr val="D9D4D0"/>
+                      </a:solidFill>
+                      <a:prstDash val="solid"/>
+                      <a:round/>
+                      <a:headEnd type="none" w="med" len="med"/>
+                      <a:tailEnd type="none" w="med" len="med"/>
+                    </a:lnT>
+                    <a:lnB w="9525" cap="flat" cmpd="sng" algn="ctr">
+                      <a:solidFill>
+                        <a:srgbClr val="D9D4D0"/>
+                      </a:solidFill>
+                      <a:prstDash val="solid"/>
+                      <a:round/>
+                      <a:headEnd type="none" w="med" len="med"/>
+                      <a:tailEnd type="none" w="med" len="med"/>
+                    </a:lnB>
+                    <a:solidFill>
+                      <a:srgbClr val="FFFFFF"/>
+                    </a:solidFill>
+                  </a:tcPr>
+                </a:tc>
+                <a:tc>
+                  <a:txBody>
+                    <a:bodyPr/>
+                    <a:lstStyle/>
+                    <a:p>
+                      <a:pPr algn="ctr" indent="0" marL="0">
+                        <a:buNone/>
+                      </a:pPr>
+                      <a:r>
+                        <a:rPr lang="en-US" sz="1800" dirty="0">
+                          <a:solidFill>
+                            <a:srgbClr val="0B0B0B"/>
+                          </a:solidFill>
+                          <a:latin typeface="Calibri" pitchFamily="34" charset="0"/>
+                          <a:ea typeface="Calibri" pitchFamily="34" charset="-122"/>
+                          <a:cs typeface="Calibri" pitchFamily="34" charset="-120"/>
+                        </a:rPr>
+                        <a:t>no</a:t>
+                      </a:r>
+                      <a:endParaRPr lang="en-US" sz="1800" dirty="0">
+                        <a:latin typeface="Calibri" charset="0"/>
+                        <a:ea typeface="Calibri" charset="0"/>
+                        <a:cs typeface="Calibri" charset="0"/>
+                      </a:endParaRPr>
+                    </a:p>
+                  </a:txBody>
+                  <a:tcPr marL="45720" marR="45720" marT="45720" marB="45720" anchor="ctr">
+                    <a:lnL w="9525" cap="flat" cmpd="sng" algn="ctr">
+                      <a:solidFill>
+                        <a:srgbClr val="D9D4D0"/>
+                      </a:solidFill>
+                      <a:prstDash val="solid"/>
+                      <a:round/>
+                      <a:headEnd type="none" w="med" len="med"/>
+                      <a:tailEnd type="none" w="med" len="med"/>
+                    </a:lnL>
+                    <a:lnR w="9525" cap="flat" cmpd="sng" algn="ctr">
+                      <a:solidFill>
+                        <a:srgbClr val="D9D4D0"/>
+                      </a:solidFill>
+                      <a:prstDash val="solid"/>
+                      <a:round/>
+                      <a:headEnd type="none" w="med" len="med"/>
+                      <a:tailEnd type="none" w="med" len="med"/>
+                    </a:lnR>
+                    <a:lnT w="9525" cap="flat" cmpd="sng" algn="ctr">
+                      <a:solidFill>
+                        <a:srgbClr val="D9D4D0"/>
+                      </a:solidFill>
+                      <a:prstDash val="solid"/>
+                      <a:round/>
+                      <a:headEnd type="none" w="med" len="med"/>
+                      <a:tailEnd type="none" w="med" len="med"/>
+                    </a:lnT>
+                    <a:lnB w="9525" cap="flat" cmpd="sng" algn="ctr">
+                      <a:solidFill>
+                        <a:srgbClr val="D9D4D0"/>
+                      </a:solidFill>
+                      <a:prstDash val="solid"/>
+                      <a:round/>
+                      <a:headEnd type="none" w="med" len="med"/>
+                      <a:tailEnd type="none" w="med" len="med"/>
+                    </a:lnB>
+                    <a:solidFill>
+                      <a:srgbClr val="FFFFFF"/>
+                    </a:solidFill>
+                  </a:tcPr>
+                </a:tc>
+                <a:tc>
+                  <a:txBody>
+                    <a:bodyPr/>
+                    <a:lstStyle/>
+                    <a:p>
+                      <a:pPr algn="ctr" indent="0" marL="0">
+                        <a:buNone/>
+                      </a:pPr>
+                      <a:r>
+                        <a:rPr lang="en-US" sz="1800" dirty="0">
+                          <a:solidFill>
+                            <a:srgbClr val="0B0B0B"/>
+                          </a:solidFill>
+                          <a:latin typeface="Calibri" pitchFamily="34" charset="0"/>
+                          <a:ea typeface="Calibri" pitchFamily="34" charset="-122"/>
+                          <a:cs typeface="Calibri" pitchFamily="34" charset="-120"/>
+                        </a:rPr>
+                        <a:t>yes</a:t>
+                      </a:r>
+                      <a:endParaRPr lang="en-US" sz="1800" dirty="0">
+                        <a:latin typeface="Calibri" charset="0"/>
+                        <a:ea typeface="Calibri" charset="0"/>
+                        <a:cs typeface="Calibri" charset="0"/>
+                      </a:endParaRPr>
+                    </a:p>
+                  </a:txBody>
+                  <a:tcPr marL="45720" marR="45720" marT="45720" marB="45720" anchor="ctr">
+                    <a:lnL w="9525" cap="flat" cmpd="sng" algn="ctr">
+                      <a:solidFill>
+                        <a:srgbClr val="D9D4D0"/>
+                      </a:solidFill>
+                      <a:prstDash val="solid"/>
+                      <a:round/>
+                      <a:headEnd type="none" w="med" len="med"/>
+                      <a:tailEnd type="none" w="med" len="med"/>
+                    </a:lnL>
+                    <a:lnR w="9525" cap="flat" cmpd="sng" algn="ctr">
+                      <a:solidFill>
+                        <a:srgbClr val="D9D4D0"/>
+                      </a:solidFill>
+                      <a:prstDash val="solid"/>
+                      <a:round/>
+                      <a:headEnd type="none" w="med" len="med"/>
+                      <a:tailEnd type="none" w="med" len="med"/>
+                    </a:lnR>
+                    <a:lnT w="9525" cap="flat" cmpd="sng" algn="ctr">
+                      <a:solidFill>
+                        <a:srgbClr val="D9D4D0"/>
+                      </a:solidFill>
+                      <a:prstDash val="solid"/>
+                      <a:round/>
+                      <a:headEnd type="none" w="med" len="med"/>
+                      <a:tailEnd type="none" w="med" len="med"/>
+                    </a:lnT>
+                    <a:lnB w="9525" cap="flat" cmpd="sng" algn="ctr">
+                      <a:solidFill>
+                        <a:srgbClr val="D9D4D0"/>
+                      </a:solidFill>
+                      <a:prstDash val="solid"/>
+                      <a:round/>
+                      <a:headEnd type="none" w="med" len="med"/>
+                      <a:tailEnd type="none" w="med" len="med"/>
+                    </a:lnB>
+                    <a:solidFill>
+                      <a:srgbClr val="FFFFFF"/>
+                    </a:solidFill>
+                  </a:tcPr>
+                </a:tc>
+              </a:tr>
+            </a:tbl>
+          </a:graphicData>
+        </a:graphic>
+      </p:graphicFrame>
+      <p:sp>
+        <p:nvSpPr>
+          <p:cNvPr id="12" name="Shape 9"/>
+          <p:cNvSpPr/>
+          <p:nvPr/>
+        </p:nvSpPr>
+        <p:spPr>
+          <a:xfrm>
+            <a:off x="914400" y="18493740"/>
+            <a:ext cx="11094720" cy="7645718"/>
           </a:xfrm>
           <a:prstGeom prst="rect">
             <a:avLst/>
@@ -1778,7 +4231,134 @@
       </p:sp>
       <p:sp>
         <p:nvSpPr>
-          <p:cNvPr id="18" name="Heading"/>
+          <p:cNvPr id="13" name="Heading"/>
+          <p:cNvSpPr txBox="1"/>
+          <p:nvPr/>
+        </p:nvSpPr>
+        <p:spPr>
+          <a:xfrm>
+            <a:off x="1234440" y="18813780"/>
+            <a:ext cx="10454640" cy="527685"/>
+          </a:xfrm>
+          <a:prstGeom prst="rect">
+            <a:avLst/>
+          </a:prstGeom>
+          <a:noFill/>
+          <a:ln/>
+        </p:spPr>
+        <p:txBody>
+          <a:bodyPr wrap="square" lIns="0" tIns="0" rIns="0" bIns="0" rtlCol="0" anchor="t"/>
+          <a:lstStyle/>
+          <a:p>
+            <a:pPr indent="0" marL="0">
+              <a:buNone/>
+            </a:pPr>
+            <a:r>
+              <a:rPr lang="en-US" sz="3300" b="1" dirty="0">
+                <a:solidFill>
+                  <a:srgbClr val="9E1B32"/>
+                </a:solidFill>
+                <a:latin typeface="Calibri" pitchFamily="34" charset="0"/>
+                <a:ea typeface="Calibri" pitchFamily="34" charset="-122"/>
+                <a:cs typeface="Calibri" pitchFamily="34" charset="-120"/>
+              </a:rPr>
+              <a:t>Deviation, noise type and interval at every τ</a:t>
+            </a:r>
+            <a:endParaRPr lang="en-US" sz="3300" dirty="0"/>
+          </a:p>
+        </p:txBody>
+      </p:sp>
+      <p:pic>
+        <p:nvPicPr>
+          <p:cNvPr id="14" name="F1_suite" descr="/home/user/SigmaTau.jl/poster/figures/F1_suite.png">    </p:cNvPr>
+          <p:cNvPicPr>
+            <a:picLocks noChangeAspect="1"/>
+          </p:cNvPicPr>
+          <p:nvPr/>
+        </p:nvPicPr>
+        <p:blipFill>
+          <a:blip r:embed="rId1"/>
+          <a:stretch>
+            <a:fillRect/>
+          </a:stretch>
+        </p:blipFill>
+        <p:spPr>
+          <a:xfrm>
+            <a:off x="2890605" y="19506057"/>
+            <a:ext cx="7142310" cy="5303520"/>
+          </a:xfrm>
+          <a:prstGeom prst="rect">
+            <a:avLst/>
+          </a:prstGeom>
+        </p:spPr>
+      </p:pic>
+      <p:sp>
+        <p:nvSpPr>
+          <p:cNvPr id="15" name="Caption"/>
+          <p:cNvSpPr txBox="1"/>
+          <p:nvPr/>
+        </p:nvSpPr>
+        <p:spPr>
+          <a:xfrm>
+            <a:off x="1234440" y="24919305"/>
+            <a:ext cx="10454640" cy="900112"/>
+          </a:xfrm>
+          <a:prstGeom prst="rect">
+            <a:avLst/>
+          </a:prstGeom>
+          <a:noFill/>
+          <a:ln/>
+        </p:spPr>
+        <p:txBody>
+          <a:bodyPr wrap="square" lIns="0" tIns="0" rIns="0" bIns="0" rtlCol="0" anchor="t"/>
+          <a:lstStyle/>
+          <a:p>
+            <a:pPr indent="0" marL="0">
+              <a:buNone/>
+            </a:pPr>
+            <a:r>
+              <a:rPr lang="en-US" sz="1950" dirty="0">
+                <a:solidFill>
+                  <a:srgbClr val="52514E"/>
+                </a:solidFill>
+                <a:latin typeface="Calibri" pitchFamily="34" charset="0"/>
+                <a:ea typeface="Calibri" pitchFamily="34" charset="-122"/>
+                <a:cs typeface="Calibri" pitchFamily="34" charset="-120"/>
+              </a:rPr>
+              <a:t>Fig. 1. One call on the shipped 8192-point validation record (τ₀ = 1 s): five estimators with 68.3 % χ² intervals from the per-τ identified noise type. The totals reach further (TOTDEV to τ = T/2, HTOTDEV to T/3) with tighter long-τ bounds; MDEV separates white from flicker PM.</a:t>
+            </a:r>
+            <a:endParaRPr lang="en-US" sz="1950" dirty="0"/>
+          </a:p>
+        </p:txBody>
+      </p:sp>
+      <p:sp>
+        <p:nvSpPr>
+          <p:cNvPr id="16" name="Shape 12"/>
+          <p:cNvSpPr/>
+          <p:nvPr/>
+        </p:nvSpPr>
+        <p:spPr>
+          <a:xfrm>
+            <a:off x="12740640" y="4206240"/>
+            <a:ext cx="11094720" cy="10701528"/>
+          </a:xfrm>
+          <a:prstGeom prst="rect">
+            <a:avLst/>
+          </a:prstGeom>
+          <a:solidFill>
+            <a:srgbClr val="FFFFFF"/>
+          </a:solidFill>
+          <a:ln w="12700">
+            <a:solidFill>
+              <a:srgbClr val="D9D4D0"/>
+            </a:solidFill>
+            <a:prstDash val="solid"/>
+          </a:ln>
+        </p:spPr>
+      </p:sp>
+      <p:sp>
+        <p:nvSpPr>
+          <p:cNvPr id="17" name="Heading"/>
           <p:cNvSpPr txBox="1"/>
           <p:nvPr/>
         </p:nvSpPr>
@@ -1809,7 +4389,7 @@
                 <a:ea typeface="Calibri" pitchFamily="34" charset="-122"/>
                 <a:cs typeface="Calibri" pitchFamily="34" charset="-120"/>
               </a:rPr>
-              <a:t>MHTOTDEV: a modified-Hadamard total deviation with no published coefficients</a:t>
+              <a:t>Matches Stable32 to its printed precision and allantools to machine precision</a:t>
             </a:r>
             <a:endParaRPr lang="en-US" sz="3300" dirty="0"/>
           </a:p>
@@ -1817,14 +4397,14 @@
       </p:sp>
       <p:sp>
         <p:nvSpPr>
-          <p:cNvPr id="19" name="Body"/>
+          <p:cNvPr id="18" name="Body"/>
           <p:cNvSpPr txBox="1"/>
           <p:nvPr/>
         </p:nvSpPr>
         <p:spPr>
           <a:xfrm>
             <a:off x="13060680" y="5700522"/>
-            <a:ext cx="10454640" cy="1844040"/>
+            <a:ext cx="10454640" cy="2545080"/>
           </a:xfrm>
           <a:prstGeom prst="rect">
             <a:avLst/>
@@ -1851,7 +4431,7 @@
                 <a:ea typeface="Calibri" pitchFamily="34" charset="-122"/>
                 <a:cs typeface="Calibri" pitchFamily="34" charset="-120"/>
               </a:rPr>
-              <a:t>The Hadamard (third-difference) family rejects linear frequency drift; the modified form separates white from flicker PM; the total form extends each window by reflection to recover confidence at long τ. MHTOTDEV combines all three. Every other total estimator inherits a published bias and EDF table; this one had none, so both were measured.</a:t>
+              <a:t>Shipped fixture: an 8192-point phase record with Stable32 and allantools outputs beside it. ADEV, MDEV, TDEV and HDEV agree with Stable32 to ≤ 0.005 % (its five significant figures) and with allantools to ≤ 1 × 10⁻¹³; the raw total kernels agree with allantools to ≤ 4.4 × 10⁻¹⁵; confidence bounds agree with Stable32 to ≤ 0.05 % at 11 of 12 τ. Where a default differs from a reference (MTOTDEV bias policy, noise-ID detrending), the per-τ tables name the keyword that reproduces the reference.</a:t>
             </a:r>
             <a:endParaRPr lang="en-US" sz="2400" dirty="0"/>
           </a:p>
@@ -1859,7 +4439,7 @@
       </p:sp>
       <p:pic>
         <p:nvPicPr>
-          <p:cNvPr id="20" name="F6_mhtot_construction" descr="/home/user/SigmaTau.jl/poster/figures/F6_mhtot_construction.png">    </p:cNvPr>
+          <p:cNvPr id="19" name="F2_validation" descr="/home/user/SigmaTau.jl/poster/figures/F2_validation.png">    </p:cNvPr>
           <p:cNvPicPr>
             <a:picLocks noChangeAspect="1"/>
           </p:cNvPicPr>
@@ -1873,8 +4453,8 @@
         </p:blipFill>
         <p:spPr>
           <a:xfrm>
-            <a:off x="15733979" y="7654290"/>
-            <a:ext cx="5108042" cy="3749040"/>
+            <a:off x="13902693" y="8355330"/>
+            <a:ext cx="8770615" cy="4937760"/>
           </a:xfrm>
           <a:prstGeom prst="rect">
             <a:avLst/>
@@ -1883,14 +4463,14 @@
       </p:pic>
       <p:sp>
         <p:nvSpPr>
-          <p:cNvPr id="21" name="Caption"/>
+          <p:cNvPr id="20" name="Caption"/>
           <p:cNvSpPr txBox="1"/>
           <p:nvPr/>
         </p:nvSpPr>
         <p:spPr>
           <a:xfrm>
-            <a:off x="13060680" y="11513058"/>
-            <a:ext cx="10454640" cy="1469708"/>
+            <a:off x="13060680" y="13402818"/>
+            <a:ext cx="10454640" cy="1184910"/>
           </a:xfrm>
           <a:prstGeom prst="rect">
             <a:avLst/>
@@ -1914,7 +4494,7 @@
                 <a:ea typeface="Calibri" pitchFamily="34" charset="-122"/>
                 <a:cs typeface="Calibri" pitchFamily="34" charset="-120"/>
               </a:rPr>
-              <a:t>Fig. 2. Construction (Greenhall scheme, as for MTOTDEV and HTOTDEV): each of the N − 4m + 1 windows of length L = 4m has its half-mean slope removed and is extended by two time-reversed copies; the third difference at lag m is averaged over m positions, squared, normalised by 6m²τ² and averaged over all windows. The public call first removes the record's least-squares frequency drift.</a:t>
+              <a:t>Fig. 2. Relative difference to Stable32 at every τ for seven estimators. Filled points lie at or below the 5 × 10⁻⁵ floor set by Stable32's printed precision; open points are the τ = 256 s noise-ID convention (Stable32 α = +2, detrended identifier α = 0). MTOTDEV compared raw, as Stable32 reports the uncorrected statistic.</a:t>
             </a:r>
             <a:endParaRPr lang="en-US" sz="1950" dirty="0"/>
           </a:p>
@@ -1922,14 +4502,14 @@
       </p:sp>
       <p:sp>
         <p:nvSpPr>
-          <p:cNvPr id="22" name="Shape 18"/>
+          <p:cNvPr id="21" name="Shape 16"/>
           <p:cNvSpPr/>
           <p:nvPr/>
         </p:nvSpPr>
         <p:spPr>
           <a:xfrm>
-            <a:off x="12740640" y="13714285"/>
-            <a:ext cx="11094720" cy="13236956"/>
+            <a:off x="12740640" y="15319248"/>
+            <a:ext cx="11094720" cy="9700451"/>
           </a:xfrm>
           <a:prstGeom prst="rect">
             <a:avLst/>
@@ -1947,13 +4527,13 @@
       </p:sp>
       <p:sp>
         <p:nvSpPr>
-          <p:cNvPr id="23" name="Heading"/>
+          <p:cNvPr id="22" name="Heading"/>
           <p:cNvSpPr txBox="1"/>
           <p:nvPr/>
         </p:nvSpPr>
         <p:spPr>
           <a:xfrm>
-            <a:off x="13060680" y="14034325"/>
+            <a:off x="13060680" y="15639288"/>
             <a:ext cx="10454640" cy="1009650"/>
           </a:xfrm>
           <a:prstGeom prst="rect">
@@ -1978,7 +4558,7 @@
                 <a:ea typeface="Calibri" pitchFamily="34" charset="-122"/>
                 <a:cs typeface="Calibri" pitchFamily="34" charset="-120"/>
               </a:rPr>
-              <a:t>Monte Carlo against synthesized noise measures both the bias and the EDF</a:t>
+              <a:t>Modified totals on a 4 × 10⁵-sample record: 0.47 s instead of 30 min</a:t>
             </a:r>
             <a:endParaRPr lang="en-US" sz="3300" dirty="0"/>
           </a:p>
@@ -1986,14 +4566,14 @@
       </p:sp>
       <p:sp>
         <p:nvSpPr>
-          <p:cNvPr id="24" name="Bullets"/>
+          <p:cNvPr id="23" name="Body"/>
           <p:cNvSpPr txBox="1"/>
           <p:nvPr/>
         </p:nvSpPr>
         <p:spPr>
           <a:xfrm>
-            <a:off x="13060680" y="15208567"/>
-            <a:ext cx="10454640" cy="4124960"/>
+            <a:off x="13060680" y="16813530"/>
+            <a:ext cx="10454640" cy="2194560"/>
           </a:xfrm>
           <a:prstGeom prst="rect">
             <a:avLst/>
@@ -2005,25 +4585,10 @@
           <a:bodyPr wrap="square" lIns="0" tIns="0" rIns="0" bIns="0" rtlCol="0" anchor="t"/>
           <a:lstStyle/>
           <a:p>
-            <a:pPr marL="279400" indent="-279400">
+            <a:pPr indent="0" marL="0">
               <a:spcAft>
-                <a:spcPts val="700"/>
+                <a:spcPts val="800"/>
               </a:spcAft>
-              <a:buSzPct val="100000"/>
-              <a:buChar char="•"/>
-            </a:pPr>
-            <a:r>
-              <a:rPr lang="en-US" sz="2400" b="1" dirty="0">
-                <a:solidFill>
-                  <a:srgbClr val="0B0B0B"/>
-                </a:solidFill>
-                <a:latin typeface="Calibri" pitchFamily="34" charset="0"/>
-                <a:ea typeface="Calibri" pitchFamily="34" charset="-122"/>
-                <a:cs typeface="Calibri" pitchFamily="34" charset="-120"/>
-              </a:rPr>
-              <a:t>Design: </a:t>
-            </a:r>
-            <a:pPr indent="0" marL="0">
               <a:buNone/>
             </a:pPr>
             <a:r>
@@ -2035,105 +4600,7 @@
                 <a:ea typeface="Calibri" pitchFamily="34" charset="-122"/>
                 <a:cs typeface="Calibri" pitchFamily="34" charset="-120"/>
               </a:rPr>
-              <a:t>α ∈ {+2, +1, 0, −1, −2}; N ∈ {1024, …, 32768}; octave m grid; R = 3000 realizations per cell; one independent random stream per (seed, α, N, r). The statistic calibrated is the shipped pipeline, including its default drift removal.</a:t>
-            </a:r>
-            <a:endParaRPr lang="en-US" sz="2400" dirty="0"/>
-          </a:p>
-          <a:p>
-            <a:pPr marL="279400" indent="-279400">
-              <a:spcAft>
-                <a:spcPts val="700"/>
-              </a:spcAft>
-              <a:buSzPct val="100000"/>
-              <a:buChar char="•"/>
-            </a:pPr>
-            <a:r>
-              <a:rPr lang="en-US" sz="2400" b="1" dirty="0">
-                <a:solidFill>
-                  <a:srgbClr val="0B0B0B"/>
-                </a:solidFill>
-                <a:latin typeface="Calibri" pitchFamily="34" charset="0"/>
-                <a:ea typeface="Calibri" pitchFamily="34" charset="-122"/>
-                <a:cs typeface="Calibri" pitchFamily="34" charset="-120"/>
-              </a:rPr>
-              <a:t>Reference: </a:t>
-            </a:r>
-            <a:pPr indent="0" marL="0">
-              <a:buNone/>
-            </a:pPr>
-            <a:r>
-              <a:rPr lang="en-US" sz="2400" dirty="0">
-                <a:solidFill>
-                  <a:srgbClr val="0B0B0B"/>
-                </a:solidFill>
-                <a:latin typeface="Calibri" pitchFamily="34" charset="0"/>
-                <a:ea typeface="Calibri" pitchFamily="34" charset="-122"/>
-                <a:cs typeface="Calibri" pitchFamily="34" charset="-120"/>
-              </a:rPr>
-              <a:t>MHDEV on the same realization (its EDF follows from the Greenhall–Riley spectral sum). Bias B = E[MHTOTVAR] / E[MHVAR]; EDF = 2 mean(V)</a:t>
-            </a:r>
-            <a:pPr indent="0" marL="0">
-              <a:buNone/>
-            </a:pPr>
-            <a:r>
-              <a:rPr lang="en-US" sz="2400" baseline="30000" dirty="0">
-                <a:solidFill>
-                  <a:srgbClr val="0B0B0B"/>
-                </a:solidFill>
-                <a:latin typeface="Calibri" pitchFamily="34" charset="0"/>
-                <a:ea typeface="Calibri" pitchFamily="34" charset="-122"/>
-                <a:cs typeface="Calibri" pitchFamily="34" charset="-120"/>
-              </a:rPr>
-              <a:t>2</a:t>
-            </a:r>
-            <a:pPr indent="0" marL="0">
-              <a:buNone/>
-            </a:pPr>
-            <a:r>
-              <a:rPr lang="en-US" sz="2400" dirty="0">
-                <a:solidFill>
-                  <a:srgbClr val="0B0B0B"/>
-                </a:solidFill>
-                <a:latin typeface="Calibri" pitchFamily="34" charset="0"/>
-                <a:ea typeface="Calibri" pitchFamily="34" charset="-122"/>
-                <a:cs typeface="Calibri" pitchFamily="34" charset="-120"/>
-              </a:rPr>
-              <a:t> / var(V), bootstrap standard error ≈ √(2/R) = 2.6 %.</a:t>
-            </a:r>
-            <a:endParaRPr lang="en-US" sz="2400" dirty="0"/>
-          </a:p>
-          <a:p>
-            <a:pPr marL="279400" indent="-279400">
-              <a:spcAft>
-                <a:spcPts val="700"/>
-              </a:spcAft>
-              <a:buSzPct val="100000"/>
-              <a:buChar char="•"/>
-            </a:pPr>
-            <a:r>
-              <a:rPr lang="en-US" sz="2400" b="1" dirty="0">
-                <a:solidFill>
-                  <a:srgbClr val="0B0B0B"/>
-                </a:solidFill>
-                <a:latin typeface="Calibri" pitchFamily="34" charset="0"/>
-                <a:ea typeface="Calibri" pitchFamily="34" charset="-122"/>
-                <a:cs typeface="Calibri" pitchFamily="34" charset="-120"/>
-              </a:rPr>
-              <a:t>Fits: </a:t>
-            </a:r>
-            <a:pPr indent="0" marL="0">
-              <a:buNone/>
-            </a:pPr>
-            <a:r>
-              <a:rPr lang="en-US" sz="2400" dirty="0">
-                <a:solidFill>
-                  <a:srgbClr val="0B0B0B"/>
-                </a:solidFill>
-                <a:latin typeface="Calibri" pitchFamily="34" charset="0"/>
-                <a:ea typeface="Calibri" pitchFamily="34" charset="-122"/>
-                <a:cs typeface="Calibri" pitchFamily="34" charset="-120"/>
-              </a:rPr>
-              <a:t>over τ/τ₀ ≥ 16, the validity window of the total-variance literature. EDF ν = b T/τ − c (Mod-Totvar; the TotHvar form is better by at most ΔR² = 8 × 10⁻⁴, at α = ±2) and bias B = b₀ + b₁ τ/T, both by weighted least squares.</a:t>
+              <a:t>Same samples, same τ grid, same statistic, kernel-only timing; allantools is single-threaded as it has no parallel path. On a measured 406 763-sample phase record MTOTDEV takes 0.469 s against 1 803.6 s and HTOTDEV 0.455 s against 1 928.0 s (3,842× and 4,233×). The gap is algorithmic as well as compiled-versus-interpreted: the reflected extension is streamed through a per-thread buffer and the window sum is split across threads.</a:t>
             </a:r>
             <a:endParaRPr lang="en-US" sz="2400" dirty="0"/>
           </a:p>
@@ -2141,7 +4608,7 @@
       </p:sp>
       <p:pic>
         <p:nvPicPr>
-          <p:cNvPr id="25" name="F4_mhtot_bias" descr="/home/user/SigmaTau.jl/poster/figures/F4_mhtot_bias.png">    </p:cNvPr>
+          <p:cNvPr id="24" name="F3_speed" descr="/home/user/SigmaTau.jl/poster/figures/F3_speed.png">    </p:cNvPr>
           <p:cNvPicPr>
             <a:picLocks noChangeAspect="1"/>
           </p:cNvPicPr>
@@ -2155,17 +4622,162 @@
         </p:blipFill>
         <p:spPr>
           <a:xfrm>
-            <a:off x="13577222" y="19443255"/>
-            <a:ext cx="4057075" cy="3520440"/>
+            <a:off x="14208763" y="19117818"/>
+            <a:ext cx="8158473" cy="4572000"/>
           </a:xfrm>
           <a:prstGeom prst="rect">
             <a:avLst/>
           </a:prstGeom>
         </p:spPr>
       </p:pic>
+      <p:sp>
+        <p:nvSpPr>
+          <p:cNvPr id="25" name="Caption"/>
+          <p:cNvSpPr txBox="1"/>
+          <p:nvPr/>
+        </p:nvSpPr>
+        <p:spPr>
+          <a:xfrm>
+            <a:off x="13060680" y="23799546"/>
+            <a:ext cx="10454640" cy="900112"/>
+          </a:xfrm>
+          <a:prstGeom prst="rect">
+            <a:avLst/>
+          </a:prstGeom>
+          <a:noFill/>
+          <a:ln/>
+        </p:spPr>
+        <p:txBody>
+          <a:bodyPr wrap="square" lIns="0" tIns="0" rIns="0" bIns="0" rtlCol="0" anchor="t"/>
+          <a:lstStyle/>
+          <a:p>
+            <a:pPr indent="0" marL="0">
+              <a:buNone/>
+            </a:pPr>
+            <a:r>
+              <a:rPr lang="en-US" sz="1950" dirty="0">
+                <a:solidFill>
+                  <a:srgbClr val="52514E"/>
+                </a:solidFill>
+                <a:latin typeface="Calibri" pitchFamily="34" charset="0"/>
+                <a:ea typeface="Calibri" pitchFamily="34" charset="-122"/>
+                <a:cs typeface="Calibri" pitchFamily="34" charset="-120"/>
+              </a:rPr>
+              <a:t>Fig. 3. Speed-up per kernel on an N = 25 000 white-PM record (bench/, 12-core workstation; diamonds: independent 4-core re-run). Ratios are the portable result; absolute times depend on the machine.</a:t>
+            </a:r>
+            <a:endParaRPr lang="en-US" sz="1950" dirty="0"/>
+          </a:p>
+        </p:txBody>
+      </p:sp>
+      <p:sp>
+        <p:nvSpPr>
+          <p:cNvPr id="26" name="Shape 20"/>
+          <p:cNvSpPr/>
+          <p:nvPr/>
+        </p:nvSpPr>
+        <p:spPr>
+          <a:xfrm>
+            <a:off x="24566880" y="4206240"/>
+            <a:ext cx="11094720" cy="9329928"/>
+          </a:xfrm>
+          <a:prstGeom prst="rect">
+            <a:avLst/>
+          </a:prstGeom>
+          <a:solidFill>
+            <a:srgbClr val="FFFFFF"/>
+          </a:solidFill>
+          <a:ln w="12700">
+            <a:solidFill>
+              <a:srgbClr val="D9D4D0"/>
+            </a:solidFill>
+            <a:prstDash val="solid"/>
+          </a:ln>
+        </p:spPr>
+      </p:sp>
+      <p:sp>
+        <p:nvSpPr>
+          <p:cNvPr id="27" name="Heading"/>
+          <p:cNvSpPr txBox="1"/>
+          <p:nvPr/>
+        </p:nvSpPr>
+        <p:spPr>
+          <a:xfrm>
+            <a:off x="24886920" y="4526280"/>
+            <a:ext cx="10454640" cy="1009650"/>
+          </a:xfrm>
+          <a:prstGeom prst="rect">
+            <a:avLst/>
+          </a:prstGeom>
+          <a:noFill/>
+          <a:ln/>
+        </p:spPr>
+        <p:txBody>
+          <a:bodyPr wrap="square" lIns="0" tIns="0" rIns="0" bIns="0" rtlCol="0" anchor="t"/>
+          <a:lstStyle/>
+          <a:p>
+            <a:pPr indent="0" marL="0">
+              <a:buNone/>
+            </a:pPr>
+            <a:r>
+              <a:rPr lang="en-US" sz="3300" b="1" dirty="0">
+                <a:solidFill>
+                  <a:srgbClr val="9E1B32"/>
+                </a:solidFill>
+                <a:latin typeface="Calibri" pitchFamily="34" charset="0"/>
+                <a:ea typeface="Calibri" pitchFamily="34" charset="-122"/>
+                <a:cs typeface="Calibri" pitchFamily="34" charset="-120"/>
+              </a:rPr>
+              <a:t>MHTOTDEV: a new total estimator, calibrated by Monte Carlo</a:t>
+            </a:r>
+            <a:endParaRPr lang="en-US" sz="3300" dirty="0"/>
+          </a:p>
+        </p:txBody>
+      </p:sp>
+      <p:sp>
+        <p:nvSpPr>
+          <p:cNvPr id="28" name="Body"/>
+          <p:cNvSpPr txBox="1"/>
+          <p:nvPr/>
+        </p:nvSpPr>
+        <p:spPr>
+          <a:xfrm>
+            <a:off x="24886920" y="5700522"/>
+            <a:ext cx="10454640" cy="2545080"/>
+          </a:xfrm>
+          <a:prstGeom prst="rect">
+            <a:avLst/>
+          </a:prstGeom>
+          <a:noFill/>
+          <a:ln/>
+        </p:spPr>
+        <p:txBody>
+          <a:bodyPr wrap="square" lIns="0" tIns="0" rIns="0" bIns="0" rtlCol="0" anchor="t"/>
+          <a:lstStyle/>
+          <a:p>
+            <a:pPr indent="0" marL="0">
+              <a:spcAft>
+                <a:spcPts val="800"/>
+              </a:spcAft>
+              <a:buNone/>
+            </a:pPr>
+            <a:r>
+              <a:rPr lang="en-US" sz="2400" dirty="0">
+                <a:solidFill>
+                  <a:srgbClr val="0B0B0B"/>
+                </a:solidFill>
+                <a:latin typeface="Calibri" pitchFamily="34" charset="0"/>
+                <a:ea typeface="Calibri" pitchFamily="34" charset="-122"/>
+                <a:cs typeface="Calibri" pitchFamily="34" charset="-120"/>
+              </a:rPr>
+              <a:t>Modified Hadamard total deviation combines drift rejection (third differences), white-from-flicker PM separation (modified form) and long-τ confidence (reflected extension). No published bias or EDF existed, so both were measured against synthesized noise: α ∈ {+2 … −2}, N ∈ {1024 … 32768}, R = 3000 realizations per cell, one seeded stream per (α, N, r), fits over τ/τ₀ ≥ 16. Bias B = E[MHTOTVAR]/E[MHVAR] against MHDEV on the same realization; EDF from the χ² variance relation; bootstrap standard error 2.6 %.</a:t>
+            </a:r>
+            <a:endParaRPr lang="en-US" sz="2400" dirty="0"/>
+          </a:p>
+        </p:txBody>
+      </p:sp>
       <p:pic>
         <p:nvPicPr>
-          <p:cNvPr id="26" name="F5_mhtot_edf" descr="/home/user/SigmaTau.jl/poster/figures/F5_mhtot_edf.png">    </p:cNvPr>
+          <p:cNvPr id="29" name="F6_mhtot_construction" descr="/home/user/SigmaTau.jl/poster/figures/F6_mhtot_construction.png">    </p:cNvPr>
           <p:cNvPicPr>
             <a:picLocks noChangeAspect="1"/>
           </p:cNvPicPr>
@@ -2179,8 +4791,8 @@
         </p:blipFill>
         <p:spPr>
           <a:xfrm>
-            <a:off x="18943827" y="19443255"/>
-            <a:ext cx="4052826" cy="3520440"/>
+            <a:off x="27684805" y="8355330"/>
+            <a:ext cx="4858870" cy="3566160"/>
           </a:xfrm>
           <a:prstGeom prst="rect">
             <a:avLst/>
@@ -2189,13 +4801,13 @@
       </p:pic>
       <p:sp>
         <p:nvSpPr>
-          <p:cNvPr id="27" name="Caption"/>
+          <p:cNvPr id="30" name="Caption"/>
           <p:cNvSpPr txBox="1"/>
           <p:nvPr/>
         </p:nvSpPr>
         <p:spPr>
           <a:xfrm>
-            <a:off x="13060680" y="23073423"/>
+            <a:off x="24886920" y="12031218"/>
             <a:ext cx="10454640" cy="1184910"/>
           </a:xfrm>
           <a:prstGeom prst="rect">
@@ -2220,7 +4832,158 @@
                 <a:ea typeface="Calibri" pitchFamily="34" charset="-122"/>
                 <a:cs typeface="Calibri" pitchFamily="34" charset="-120"/>
               </a:rPr>
-              <a:t>Fig. 3. Shipped models. Left: ≈ unbiased for the PM noises, reads high for red FM (B ≈ 2.2 for random-walk FM at small τ/T). Right: EDF, R² ≥ 0.9982 for every α; below T/τ ≈ 5–6 the interval is indicative only, while σ itself is valid to the reach limit τ = T/4. Table: shipped coefficients (seed 20260531, R = 3000, N ≤ 32768).</a:t>
+              <a:t>Fig. 4. Kernel (Greenhall scheme): each of the N − 4m + 1 windows of length 4m has its half-mean slope removed and is extended by two time-reversed copies; the third difference at lag m is averaged over m, squared, normalised by 6m²τ² and averaged over all windows. The public call removes the least-squares frequency drift first.</a:t>
+            </a:r>
+            <a:endParaRPr lang="en-US" sz="1950" dirty="0"/>
+          </a:p>
+        </p:txBody>
+      </p:sp>
+      <p:sp>
+        <p:nvSpPr>
+          <p:cNvPr id="31" name="Shape 24"/>
+          <p:cNvSpPr/>
+          <p:nvPr/>
+        </p:nvSpPr>
+        <p:spPr>
+          <a:xfrm>
+            <a:off x="24566880" y="13947648"/>
+            <a:ext cx="11094720" cy="8455533"/>
+          </a:xfrm>
+          <a:prstGeom prst="rect">
+            <a:avLst/>
+          </a:prstGeom>
+          <a:solidFill>
+            <a:srgbClr val="FFFFFF"/>
+          </a:solidFill>
+          <a:ln w="12700">
+            <a:solidFill>
+              <a:srgbClr val="D9D4D0"/>
+            </a:solidFill>
+            <a:prstDash val="solid"/>
+          </a:ln>
+        </p:spPr>
+      </p:sp>
+      <p:sp>
+        <p:nvSpPr>
+          <p:cNvPr id="32" name="Heading"/>
+          <p:cNvSpPr txBox="1"/>
+          <p:nvPr/>
+        </p:nvSpPr>
+        <p:spPr>
+          <a:xfrm>
+            <a:off x="24886920" y="14267688"/>
+            <a:ext cx="10454640" cy="1009650"/>
+          </a:xfrm>
+          <a:prstGeom prst="rect">
+            <a:avLst/>
+          </a:prstGeom>
+          <a:noFill/>
+          <a:ln/>
+        </p:spPr>
+        <p:txBody>
+          <a:bodyPr wrap="square" lIns="0" tIns="0" rIns="0" bIns="0" rtlCol="0" anchor="t"/>
+          <a:lstStyle/>
+          <a:p>
+            <a:pPr indent="0" marL="0">
+              <a:buNone/>
+            </a:pPr>
+            <a:r>
+              <a:rPr lang="en-US" sz="3300" b="1" dirty="0">
+                <a:solidFill>
+                  <a:srgbClr val="9E1B32"/>
+                </a:solidFill>
+                <a:latin typeface="Calibri" pitchFamily="34" charset="0"/>
+                <a:ea typeface="Calibri" pitchFamily="34" charset="-122"/>
+                <a:cs typeface="Calibri" pitchFamily="34" charset="-120"/>
+              </a:rPr>
+              <a:t>Unbiased for PM noise, reads high for red FM; EDF fits with R² ≥ 0.9982</a:t>
+            </a:r>
+            <a:endParaRPr lang="en-US" sz="3300" dirty="0"/>
+          </a:p>
+        </p:txBody>
+      </p:sp>
+      <p:pic>
+        <p:nvPicPr>
+          <p:cNvPr id="33" name="F4_mhtot_bias" descr="/home/user/SigmaTau.jl/poster/figures/F4_mhtot_bias.png">    </p:cNvPr>
+          <p:cNvPicPr>
+            <a:picLocks noChangeAspect="1"/>
+          </p:cNvPicPr>
+          <p:nvPr/>
+        </p:nvPicPr>
+        <p:blipFill>
+          <a:blip r:embed="rId5"/>
+          <a:stretch>
+            <a:fillRect/>
+          </a:stretch>
+        </p:blipFill>
+        <p:spPr>
+          <a:xfrm>
+            <a:off x="25429807" y="15441930"/>
+            <a:ext cx="4004386" cy="3474720"/>
+          </a:xfrm>
+          <a:prstGeom prst="rect">
+            <a:avLst/>
+          </a:prstGeom>
+        </p:spPr>
+      </p:pic>
+      <p:pic>
+        <p:nvPicPr>
+          <p:cNvPr id="34" name="F5_mhtot_edf" descr="/home/user/SigmaTau.jl/poster/figures/F5_mhtot_edf.png">    </p:cNvPr>
+          <p:cNvPicPr>
+            <a:picLocks noChangeAspect="1"/>
+          </p:cNvPicPr>
+          <p:nvPr/>
+        </p:nvPicPr>
+        <p:blipFill>
+          <a:blip r:embed="rId6"/>
+          <a:stretch>
+            <a:fillRect/>
+          </a:stretch>
+        </p:blipFill>
+        <p:spPr>
+          <a:xfrm>
+            <a:off x="30796384" y="15441930"/>
+            <a:ext cx="4000192" cy="3474720"/>
+          </a:xfrm>
+          <a:prstGeom prst="rect">
+            <a:avLst/>
+          </a:prstGeom>
+        </p:spPr>
+      </p:pic>
+      <p:sp>
+        <p:nvSpPr>
+          <p:cNvPr id="35" name="Caption"/>
+          <p:cNvSpPr txBox="1"/>
+          <p:nvPr/>
+        </p:nvSpPr>
+        <p:spPr>
+          <a:xfrm>
+            <a:off x="24886920" y="19026378"/>
+            <a:ext cx="10454640" cy="615315"/>
+          </a:xfrm>
+          <a:prstGeom prst="rect">
+            <a:avLst/>
+          </a:prstGeom>
+          <a:noFill/>
+          <a:ln/>
+        </p:spPr>
+        <p:txBody>
+          <a:bodyPr wrap="square" lIns="0" tIns="0" rIns="0" bIns="0" rtlCol="0" anchor="t"/>
+          <a:lstStyle/>
+          <a:p>
+            <a:pPr indent="0" marL="0">
+              <a:buNone/>
+            </a:pPr>
+            <a:r>
+              <a:rPr lang="en-US" sz="1950" dirty="0">
+                <a:solidFill>
+                  <a:srgbClr val="52514E"/>
+                </a:solidFill>
+                <a:latin typeface="Calibri" pitchFamily="34" charset="0"/>
+                <a:ea typeface="Calibri" pitchFamily="34" charset="-122"/>
+                <a:cs typeface="Calibri" pitchFamily="34" charset="-120"/>
+              </a:rPr>
+              <a:t>Fig. 5. Shipped models B = b₀ + b₁ τ/T and ν = b T/τ − c (seed 20260531). Below T/τ ≈ 5–6 the interval is indicative only; σ itself is valid to the reach limit τ = T/4.</a:t>
             </a:r>
             <a:endParaRPr lang="en-US" sz="1950" dirty="0"/>
           </a:p>
@@ -2228,7 +4991,7 @@
       </p:sp>
       <p:graphicFrame>
         <p:nvGraphicFramePr>
-          <p:cNvPr id="2" name="Coefficient table"/>
+          <p:cNvPr id="3" name="MHTOTDEV coefficients"/>
           <p:cNvGraphicFramePr>
             <a:graphicFrameLocks noGrp="1"/>
           </p:cNvGraphicFramePr>
@@ -2241,7 +5004,7 @@
           </p:nvPr>
         </p:nvGraphicFramePr>
         <p:xfrm>
-          <a:off x="13060680" y="24349773"/>
+          <a:off x="24886920" y="19733133"/>
           <a:ext cx="10454640" cy="914400"/>
         </p:xfrm>
         <a:graphic>
@@ -2257,7 +5020,7 @@
                 <a:gridCol w="1355231"/>
                 <a:gridCol w="1355231"/>
               </a:tblGrid>
-              <a:tr h="377190">
+              <a:tr h="384048">
                 <a:tc>
                   <a:txBody>
                     <a:bodyPr/>
@@ -2683,7 +5446,7 @@
                           <a:ea typeface="Calibri" pitchFamily="34" charset="-122"/>
                           <a:cs typeface="Calibri" pitchFamily="34" charset="-120"/>
                         </a:rPr>
-                        <a:t>EDF R²</a:t>
+                        <a:t>R²</a:t>
                       </a:r>
                       <a:endParaRPr lang="en-US" sz="1800" dirty="0">
                         <a:latin typeface="Calibri" charset="0"/>
@@ -2735,7 +5498,7 @@
                   </a:tcPr>
                 </a:tc>
               </a:tr>
-              <a:tr h="377190">
+              <a:tr h="384048">
                 <a:tc>
                   <a:txBody>
                     <a:bodyPr/>
@@ -3213,7 +5976,7 @@
                   </a:tcPr>
                 </a:tc>
               </a:tr>
-              <a:tr h="377190">
+              <a:tr h="384048">
                 <a:tc>
                   <a:txBody>
                     <a:bodyPr/>
@@ -3691,7 +6454,7 @@
                   </a:tcPr>
                 </a:tc>
               </a:tr>
-              <a:tr h="377190">
+              <a:tr h="384048">
                 <a:tc>
                   <a:txBody>
                     <a:bodyPr/>
@@ -4169,7 +6932,7 @@
                   </a:tcPr>
                 </a:tc>
               </a:tr>
-              <a:tr h="377190">
+              <a:tr h="384048">
                 <a:tc>
                   <a:txBody>
                     <a:bodyPr/>
@@ -4647,7 +7410,7 @@
                   </a:tcPr>
                 </a:tc>
               </a:tr>
-              <a:tr h="377190">
+              <a:tr h="384048">
                 <a:tc>
                   <a:txBody>
                     <a:bodyPr/>
@@ -5131,14 +7894,14 @@
       </p:graphicFrame>
       <p:sp>
         <p:nvSpPr>
-          <p:cNvPr id="29" name="Shape 22"/>
+          <p:cNvPr id="37" name="Shape 27"/>
           <p:cNvSpPr/>
           <p:nvPr/>
         </p:nvSpPr>
         <p:spPr>
           <a:xfrm>
-            <a:off x="24566880" y="4206240"/>
-            <a:ext cx="11094720" cy="10477690"/>
+            <a:off x="24566880" y="22814661"/>
+            <a:ext cx="11094720" cy="3634105"/>
           </a:xfrm>
           <a:prstGeom prst="rect">
             <a:avLst/>
@@ -5156,351 +7919,13 @@
       </p:sp>
       <p:sp>
         <p:nvSpPr>
-          <p:cNvPr id="30" name="Heading"/>
+          <p:cNvPr id="38" name="Heading"/>
           <p:cNvSpPr txBox="1"/>
           <p:nvPr/>
         </p:nvSpPr>
         <p:spPr>
           <a:xfrm>
-            <a:off x="24886920" y="4526280"/>
-            <a:ext cx="10454640" cy="1009650"/>
-          </a:xfrm>
-          <a:prstGeom prst="rect">
-            <a:avLst/>
-          </a:prstGeom>
-          <a:noFill/>
-          <a:ln/>
-        </p:spPr>
-        <p:txBody>
-          <a:bodyPr wrap="square" lIns="0" tIns="0" rIns="0" bIns="0" rtlCol="0" anchor="t"/>
-          <a:lstStyle/>
-          <a:p>
-            <a:pPr indent="0" marL="0">
-              <a:buNone/>
-            </a:pPr>
-            <a:r>
-              <a:rPr lang="en-US" sz="3300" b="1" dirty="0">
-                <a:solidFill>
-                  <a:srgbClr val="9E1B32"/>
-                </a:solidFill>
-                <a:latin typeface="Calibri" pitchFamily="34" charset="0"/>
-                <a:ea typeface="Calibri" pitchFamily="34" charset="-122"/>
-                <a:cs typeface="Calibri" pitchFamily="34" charset="-120"/>
-              </a:rPr>
-              <a:t>Agreement with Stable32 to its printed precision and with allantools to 10⁻¹³</a:t>
-            </a:r>
-            <a:endParaRPr lang="en-US" sz="3300" dirty="0"/>
-          </a:p>
-        </p:txBody>
-      </p:sp>
-      <p:sp>
-        <p:nvSpPr>
-          <p:cNvPr id="31" name="Body"/>
-          <p:cNvSpPr txBox="1"/>
-          <p:nvPr/>
-        </p:nvSpPr>
-        <p:spPr>
-          <a:xfrm>
-            <a:off x="24886920" y="5700522"/>
-            <a:ext cx="10454640" cy="3246120"/>
-          </a:xfrm>
-          <a:prstGeom prst="rect">
-            <a:avLst/>
-          </a:prstGeom>
-          <a:noFill/>
-          <a:ln/>
-        </p:spPr>
-        <p:txBody>
-          <a:bodyPr wrap="square" lIns="0" tIns="0" rIns="0" bIns="0" rtlCol="0" anchor="t"/>
-          <a:lstStyle/>
-          <a:p>
-            <a:pPr indent="0" marL="0">
-              <a:spcAft>
-                <a:spcPts val="800"/>
-              </a:spcAft>
-              <a:buNone/>
-            </a:pPr>
-            <a:r>
-              <a:rPr lang="en-US" sz="2400" dirty="0">
-                <a:solidFill>
-                  <a:srgbClr val="0B0B0B"/>
-                </a:solidFill>
-                <a:latin typeface="Calibri" pitchFamily="34" charset="0"/>
-                <a:ea typeface="Calibri" pitchFamily="34" charset="-122"/>
-                <a:cs typeface="Calibri" pitchFamily="34" charset="-120"/>
-              </a:rPr>
-              <a:t>On the shipped 8192-point record, ADEV, MDEV, TDEV and HDEV match Stable32 to ≤ 0.005 % (its five-significant-figure output) and allantools to ≤ 1 × 10⁻¹³; the raw total kernels match allantools to ≤ 4.4 × 10⁻¹⁵. Confidence bounds agree with Stable32 to ≤ 0.05 % at 11 of 12 τ. The one recurring residual is a convention: at τ = 256 s Stable32 assigns α = +2 where the detrended identifier assigns α = 0; one keyword reproduces Stable32 at every τ. Estimators neither reference implements (MHDEV, HTDEV, MHTOTDEV, ThêoH, nch, dynamic, streaming) are checked against inlined textbook kernels and algebraic identities.</a:t>
-            </a:r>
-            <a:endParaRPr lang="en-US" sz="2400" dirty="0"/>
-          </a:p>
-        </p:txBody>
-      </p:sp>
-      <p:pic>
-        <p:nvPicPr>
-          <p:cNvPr id="32" name="F2_validation" descr="/home/user/SigmaTau.jl/poster/figures/F2_validation.png">    </p:cNvPr>
-          <p:cNvPicPr>
-            <a:picLocks noChangeAspect="1"/>
-          </p:cNvPicPr>
-          <p:nvPr/>
-        </p:nvPicPr>
-        <p:blipFill>
-          <a:blip r:embed="rId5"/>
-          <a:stretch>
-            <a:fillRect/>
-          </a:stretch>
-        </p:blipFill>
-        <p:spPr>
-          <a:xfrm>
-            <a:off x="26297398" y="9056370"/>
-            <a:ext cx="7633683" cy="4297680"/>
-          </a:xfrm>
-          <a:prstGeom prst="rect">
-            <a:avLst/>
-          </a:prstGeom>
-        </p:spPr>
-      </p:pic>
-      <p:sp>
-        <p:nvSpPr>
-          <p:cNvPr id="33" name="Caption"/>
-          <p:cNvSpPr txBox="1"/>
-          <p:nvPr/>
-        </p:nvSpPr>
-        <p:spPr>
-          <a:xfrm>
-            <a:off x="24886920" y="13463778"/>
-            <a:ext cx="10454640" cy="900112"/>
-          </a:xfrm>
-          <a:prstGeom prst="rect">
-            <a:avLst/>
-          </a:prstGeom>
-          <a:noFill/>
-          <a:ln/>
-        </p:spPr>
-        <p:txBody>
-          <a:bodyPr wrap="square" lIns="0" tIns="0" rIns="0" bIns="0" rtlCol="0" anchor="t"/>
-          <a:lstStyle/>
-          <a:p>
-            <a:pPr indent="0" marL="0">
-              <a:buNone/>
-            </a:pPr>
-            <a:r>
-              <a:rPr lang="en-US" sz="1950" dirty="0">
-                <a:solidFill>
-                  <a:srgbClr val="52514E"/>
-                </a:solidFill>
-                <a:latin typeface="Calibri" pitchFamily="34" charset="0"/>
-                <a:ea typeface="Calibri" pitchFamily="34" charset="-122"/>
-                <a:cs typeface="Calibri" pitchFamily="34" charset="-120"/>
-              </a:rPr>
-              <a:t>Fig. 4. Relative difference to Stable32 at every τ for seven estimators. Filled points lie at or below the 5 × 10⁻⁵ floor set by Stable32's printed precision; open points are the τ = 256 s convention. MTOTDEV is compared raw, as Stable32 reports the uncorrected statistic.</a:t>
-            </a:r>
-            <a:endParaRPr lang="en-US" sz="1950" dirty="0"/>
-          </a:p>
-        </p:txBody>
-      </p:sp>
-      <p:sp>
-        <p:nvSpPr>
-          <p:cNvPr id="34" name="Shape 26"/>
-          <p:cNvSpPr/>
-          <p:nvPr/>
-        </p:nvSpPr>
-        <p:spPr>
-          <a:xfrm>
-            <a:off x="24566880" y="15095410"/>
-            <a:ext cx="11094720" cy="8618411"/>
-          </a:xfrm>
-          <a:prstGeom prst="rect">
-            <a:avLst/>
-          </a:prstGeom>
-          <a:solidFill>
-            <a:srgbClr val="FFFFFF"/>
-          </a:solidFill>
-          <a:ln w="12700">
-            <a:solidFill>
-              <a:srgbClr val="D9D4D0"/>
-            </a:solidFill>
-            <a:prstDash val="solid"/>
-          </a:ln>
-        </p:spPr>
-      </p:sp>
-      <p:sp>
-        <p:nvSpPr>
-          <p:cNvPr id="35" name="Heading"/>
-          <p:cNvSpPr txBox="1"/>
-          <p:nvPr/>
-        </p:nvSpPr>
-        <p:spPr>
-          <a:xfrm>
-            <a:off x="24886920" y="15415450"/>
-            <a:ext cx="10454640" cy="1009650"/>
-          </a:xfrm>
-          <a:prstGeom prst="rect">
-            <a:avLst/>
-          </a:prstGeom>
-          <a:noFill/>
-          <a:ln/>
-        </p:spPr>
-        <p:txBody>
-          <a:bodyPr wrap="square" lIns="0" tIns="0" rIns="0" bIns="0" rtlCol="0" anchor="t"/>
-          <a:lstStyle/>
-          <a:p>
-            <a:pPr indent="0" marL="0">
-              <a:buNone/>
-            </a:pPr>
-            <a:r>
-              <a:rPr lang="en-US" sz="3300" b="1" dirty="0">
-                <a:solidFill>
-                  <a:srgbClr val="9E1B32"/>
-                </a:solidFill>
-                <a:latin typeface="Calibri" pitchFamily="34" charset="0"/>
-                <a:ea typeface="Calibri" pitchFamily="34" charset="-122"/>
-                <a:cs typeface="Calibri" pitchFamily="34" charset="-120"/>
-              </a:rPr>
-              <a:t>Modified-total analysis of a day-long record takes seconds, not half an hour</a:t>
-            </a:r>
-            <a:endParaRPr lang="en-US" sz="3300" dirty="0"/>
-          </a:p>
-        </p:txBody>
-      </p:sp>
-      <p:sp>
-        <p:nvSpPr>
-          <p:cNvPr id="36" name="Body"/>
-          <p:cNvSpPr txBox="1"/>
-          <p:nvPr/>
-        </p:nvSpPr>
-        <p:spPr>
-          <a:xfrm>
-            <a:off x="24886920" y="16589692"/>
-            <a:ext cx="10454640" cy="1844040"/>
-          </a:xfrm>
-          <a:prstGeom prst="rect">
-            <a:avLst/>
-          </a:prstGeom>
-          <a:noFill/>
-          <a:ln/>
-        </p:spPr>
-        <p:txBody>
-          <a:bodyPr wrap="square" lIns="0" tIns="0" rIns="0" bIns="0" rtlCol="0" anchor="t"/>
-          <a:lstStyle/>
-          <a:p>
-            <a:pPr indent="0" marL="0">
-              <a:spcAft>
-                <a:spcPts val="800"/>
-              </a:spcAft>
-              <a:buNone/>
-            </a:pPr>
-            <a:r>
-              <a:rPr lang="en-US" sz="2400" dirty="0">
-                <a:solidFill>
-                  <a:srgbClr val="0B0B0B"/>
-                </a:solidFill>
-                <a:latin typeface="Calibri" pitchFamily="34" charset="0"/>
-                <a:ea typeface="Calibri" pitchFamily="34" charset="-122"/>
-                <a:cs typeface="Calibri" pitchFamily="34" charset="-120"/>
-              </a:rPr>
-              <a:t>Same samples, same τ grid, same statistic; allantools is single-threaded as it has no parallel path. On a measured 406 763-sample phase record MTOTDEV takes 0.469 s against 1 803.6 s. The gap is algorithmic as well as compiled-versus-interpreted: the reflected extension is streamed through a per-thread buffer and the window sum is split across threads.</a:t>
-            </a:r>
-            <a:endParaRPr lang="en-US" sz="2400" dirty="0"/>
-          </a:p>
-        </p:txBody>
-      </p:sp>
-      <p:pic>
-        <p:nvPicPr>
-          <p:cNvPr id="37" name="F3_speed" descr="/home/user/SigmaTau.jl/poster/figures/F3_speed.png">    </p:cNvPr>
-          <p:cNvPicPr>
-            <a:picLocks noChangeAspect="1"/>
-          </p:cNvPicPr>
-          <p:nvPr/>
-        </p:nvPicPr>
-        <p:blipFill>
-          <a:blip r:embed="rId6"/>
-          <a:stretch>
-            <a:fillRect/>
-          </a:stretch>
-        </p:blipFill>
-        <p:spPr>
-          <a:xfrm>
-            <a:off x="26687681" y="18543461"/>
-            <a:ext cx="6853118" cy="3840480"/>
-          </a:xfrm>
-          <a:prstGeom prst="rect">
-            <a:avLst/>
-          </a:prstGeom>
-        </p:spPr>
-      </p:pic>
-      <p:sp>
-        <p:nvSpPr>
-          <p:cNvPr id="38" name="Caption"/>
-          <p:cNvSpPr txBox="1"/>
-          <p:nvPr/>
-        </p:nvSpPr>
-        <p:spPr>
-          <a:xfrm>
-            <a:off x="24886920" y="22493669"/>
-            <a:ext cx="10454640" cy="900112"/>
-          </a:xfrm>
-          <a:prstGeom prst="rect">
-            <a:avLst/>
-          </a:prstGeom>
-          <a:noFill/>
-          <a:ln/>
-        </p:spPr>
-        <p:txBody>
-          <a:bodyPr wrap="square" lIns="0" tIns="0" rIns="0" bIns="0" rtlCol="0" anchor="t"/>
-          <a:lstStyle/>
-          <a:p>
-            <a:pPr indent="0" marL="0">
-              <a:buNone/>
-            </a:pPr>
-            <a:r>
-              <a:rPr lang="en-US" sz="1950" dirty="0">
-                <a:solidFill>
-                  <a:srgbClr val="52514E"/>
-                </a:solidFill>
-                <a:latin typeface="Calibri" pitchFamily="34" charset="0"/>
-                <a:ea typeface="Calibri" pitchFamily="34" charset="-122"/>
-                <a:cs typeface="Calibri" pitchFamily="34" charset="-120"/>
-              </a:rPr>
-              <a:t>Fig. 5. Kernel-only speed-up (no intervals, raw totals) on an N = 25 000 white-PM record (bench/, mean of 30 realizations, 12 cores; diamonds: independent 4-core re-run). Ratios are the portable result; absolute times depend on the machine.</a:t>
-            </a:r>
-            <a:endParaRPr lang="en-US" sz="1950" dirty="0"/>
-          </a:p>
-        </p:txBody>
-      </p:sp>
-      <p:sp>
-        <p:nvSpPr>
-          <p:cNvPr id="39" name="Shape 30"/>
-          <p:cNvSpPr/>
-          <p:nvPr/>
-        </p:nvSpPr>
-        <p:spPr>
-          <a:xfrm>
-            <a:off x="24566880" y="24125301"/>
-            <a:ext cx="11094720" cy="2933065"/>
-          </a:xfrm>
-          <a:prstGeom prst="rect">
-            <a:avLst/>
-          </a:prstGeom>
-          <a:solidFill>
-            <a:srgbClr val="FFFFFF"/>
-          </a:solidFill>
-          <a:ln w="12700">
-            <a:solidFill>
-              <a:srgbClr val="D9D4D0"/>
-            </a:solidFill>
-            <a:prstDash val="solid"/>
-          </a:ln>
-        </p:spPr>
-      </p:sp>
-      <p:sp>
-        <p:nvSpPr>
-          <p:cNvPr id="40" name="Heading"/>
-          <p:cNvSpPr txBox="1"/>
-          <p:nvPr/>
-        </p:nvSpPr>
-        <p:spPr>
-          <a:xfrm>
-            <a:off x="24886920" y="24445341"/>
+            <a:off x="24886920" y="23134701"/>
             <a:ext cx="10454640" cy="527685"/>
           </a:xfrm>
           <a:prstGeom prst="rect">
@@ -5525,7 +7950,7 @@
                 <a:ea typeface="Calibri" pitchFamily="34" charset="-122"/>
                 <a:cs typeface="Calibri" pitchFamily="34" charset="-120"/>
               </a:rPr>
-              <a:t>Next steps</a:t>
+              <a:t>Reproducible by construction</a:t>
             </a:r>
             <a:endParaRPr lang="en-US" sz="3300" dirty="0"/>
           </a:p>
@@ -5533,14 +7958,14 @@
       </p:sp>
       <p:sp>
         <p:nvSpPr>
-          <p:cNvPr id="41" name="Bullets"/>
+          <p:cNvPr id="39" name="Bullets"/>
           <p:cNvSpPr txBox="1"/>
           <p:nvPr/>
         </p:nvSpPr>
         <p:spPr>
           <a:xfrm>
-            <a:off x="24886920" y="25137618"/>
-            <a:ext cx="10454640" cy="1582420"/>
+            <a:off x="24886920" y="23826978"/>
+            <a:ext cx="10454640" cy="2283460"/>
           </a:xfrm>
           <a:prstGeom prst="rect">
             <a:avLst/>
@@ -5568,7 +7993,7 @@
                 <a:ea typeface="Calibri" pitchFamily="34" charset="-122"/>
                 <a:cs typeface="Calibri" pitchFamily="34" charset="-120"/>
               </a:rPr>
-              <a:t>Laboratory records: </a:t>
+              <a:t>Shipped with the code: </a:t>
             </a:r>
             <a:pPr indent="0" marL="0">
               <a:buNone/>
@@ -5582,7 +8007,7 @@
                 <a:ea typeface="Calibri" pitchFamily="34" charset="-122"/>
                 <a:cs typeface="Calibri" pitchFamily="34" charset="-120"/>
               </a:rPr>
-              <a:t>apply the drift-tolerant Hadamard family and the real-time accumulators to the Rb-87 clock comparisons.</a:t>
+              <a:t>the validation fixture with Stable32 and allantools outputs, the per-τ comparison tables, the benchmark scripts for both libraries, and the Monte Carlo harness with its seed and tracked fit artifact.</a:t>
             </a:r>
             <a:endParaRPr lang="en-US" sz="2400" dirty="0"/>
           </a:p>
@@ -5603,7 +8028,7 @@
                 <a:ea typeface="Calibri" pitchFamily="34" charset="-122"/>
                 <a:cs typeface="Calibri" pitchFamily="34" charset="-120"/>
               </a:rPr>
-              <a:t>Calibration: </a:t>
+              <a:t>Next: </a:t>
             </a:r>
             <a:pPr indent="0" marL="0">
               <a:buNone/>
@@ -5617,7 +8042,7 @@
                 <a:ea typeface="Calibri" pitchFamily="34" charset="-122"/>
                 <a:cs typeface="Calibri" pitchFamily="34" charset="-120"/>
               </a:rPr>
-              <a:t>extend the Monte Carlo method to the Thêo family and gapped records.</a:t>
+              <a:t>real-time monitoring of the laboratory Rb-87 clock comparisons with the Hadamard family; Monte Carlo calibration of the Thêo family and of gapped records.</a:t>
             </a:r>
             <a:endParaRPr lang="en-US" sz="2400" dirty="0"/>
           </a:p>
@@ -5625,7 +8050,7 @@
       </p:sp>
       <p:sp>
         <p:nvSpPr>
-          <p:cNvPr id="42" name="Shape 33"/>
+          <p:cNvPr id="40" name="Shape 30"/>
           <p:cNvSpPr/>
           <p:nvPr/>
         </p:nvSpPr>
@@ -5648,7 +8073,7 @@
       </p:sp>
       <p:sp>
         <p:nvSpPr>
-          <p:cNvPr id="43" name="References A"/>
+          <p:cNvPr id="41" name="References A"/>
           <p:cNvSpPr txBox="1"/>
           <p:nvPr/>
         </p:nvSpPr>
@@ -5767,7 +8192,7 @@
       </p:sp>
       <p:sp>
         <p:nvSpPr>
-          <p:cNvPr id="44" name="References B"/>
+          <p:cNvPr id="42" name="References B"/>
           <p:cNvSpPr txBox="1"/>
           <p:nvPr/>
         </p:nvSpPr>
@@ -5818,7 +8243,7 @@
                 <a:ea typeface="Calibri" pitchFamily="34" charset="-122"/>
                 <a:cs typeface="Calibri" pitchFamily="34" charset="-120"/>
               </a:rPr>
-              <a:t>5. F. Vernotte and D. A. Howe, Generalization of the total variance approach to the different classes of structure functions, Proc. EFTF (2000).</a:t>
+              <a:t>5. F. Vernotte and D. A. Howe, Generalization of the total variance approach to the different classes of structure functions, Proc. 14th EFTF (2000).</a:t>
             </a:r>
             <a:endParaRPr lang="en-US" sz="1500" dirty="0"/>
           </a:p>
@@ -5866,7 +8291,7 @@
       </p:sp>
       <p:sp>
         <p:nvSpPr>
-          <p:cNvPr id="45" name="Acknowledgments"/>
+          <p:cNvPr id="43" name="Acknowledgments"/>
           <p:cNvSpPr txBox="1"/>
           <p:nvPr/>
         </p:nvSpPr>
@@ -5897,7 +8322,7 @@
                 <a:ea typeface="Calibri" pitchFamily="34" charset="-122"/>
                 <a:cs typeface="Calibri" pitchFamily="34" charset="-120"/>
               </a:rPr>
-              <a:t>Acknowledgments: [funding / program / advisor placeholder]. Validation fixtures, benchmark scripts and the Monte Carlo harness are in the repository.</a:t>
+              <a:t>Acknowledgments: [funding / program / advisor placeholder]. Documentation: ianlap.github.io/SigmaTau.jl</a:t>
             </a:r>
             <a:endParaRPr lang="en-US" sz="1500" dirty="0"/>
           </a:p>

</xml_diff>

<commit_message>
Poster: dynamic map as an offset waterfall instead of a heat map
Co-Authored-By: Claude Fable 5.1 <noreply@anthropic.com>
Claude-Session: https://claude.ai/code/session_012uJVDqousov9TiLyrGUADf
</commit_message>
<xml_diff>
--- a/poster/SigmaTau_poster_draft.pptx
+++ b/poster/SigmaTau_poster_draft.pptx
@@ -8014,7 +8014,7 @@
         <p:spPr>
           <a:xfrm>
             <a:off x="24566880" y="19198463"/>
-            <a:ext cx="11094720" cy="7680960"/>
+            <a:ext cx="11094720" cy="7772400"/>
           </a:xfrm>
           <a:prstGeom prst="rect">
             <a:avLst/>
@@ -8085,8 +8085,8 @@
         </p:blipFill>
         <p:spPr>
           <a:xfrm>
-            <a:off x="26911773" y="20692745"/>
-            <a:ext cx="6404934" cy="4572000"/>
+            <a:off x="27133415" y="20692745"/>
+            <a:ext cx="5961650" cy="4663440"/>
           </a:xfrm>
           <a:prstGeom prst="rect">
             <a:avLst/>
@@ -8101,7 +8101,7 @@
         </p:nvSpPr>
         <p:spPr>
           <a:xfrm>
-            <a:off x="24886920" y="25374473"/>
+            <a:off x="24886920" y="25465913"/>
             <a:ext cx="10454640" cy="1184910"/>
           </a:xfrm>
           <a:prstGeom prst="rect">
@@ -8126,7 +8126,7 @@
                 <a:ea typeface="Calibri" pitchFamily="34" charset="-122"/>
                 <a:cs typeface="Calibri" pitchFamily="34" charset="-120"/>
               </a:rPr>
-              <a:t>Fig. 5. DADEV on a synthesized 8191-sample record (τ₀ = 1 s): white FM at σ</a:t>
+              <a:t>Fig. 5. DADEV waterfall on a synthesized 8191-sample record (τ₀ = 1 s): white FM at σ</a:t>
             </a:r>
             <a:pPr indent="0" marL="0">
               <a:buNone/>
@@ -8154,7 +8154,7 @@
                 <a:ea typeface="Calibri" pitchFamily="34" charset="-122"/>
                 <a:cs typeface="Calibri" pitchFamily="34" charset="-120"/>
               </a:rPr>
-              <a:t>(1 s) = 1 × 10⁻¹² for the first half, then 3 × 10⁻¹² plus flicker FM at 1 × 10⁻¹²; window 1024 samples, step 128. Each cell is an ordinary overlapping ADEV of its window, so the change is located to within one window length; a 3-D view is in the desktop explorer.</a:t>
+              <a:t>(1 s) = 1 × 10⁻¹² for the first half, then 3 × 10⁻¹² plus flicker FM at 1 × 10⁻¹²; window 1024 samples, step 128. Each curve is the overlapping ADEV of one window, so the change is located to within one window length.</a:t>
             </a:r>
             <a:endParaRPr lang="en-US" sz="1950" dirty="0"/>
           </a:p>

</xml_diff>

<commit_message>
Poster: copy cut to statements, explorer screenshot panel
Two independent editors and a judge reduced the body copy from 544 to
365 words (every number and its condition kept, verified against the
sources); captions are under 35 words each. The desktop explorer's
Deviations page, captured by the headless smoke run, is a new panel in
column 2; reproducibility moved to column 3. Figures renumbered in
reading order.

Co-Authored-By: Claude Fable 5.1 <noreply@anthropic.com>
Claude-Session: https://claude.ai/code/session_012uJVDqousov9TiLyrGUADf
</commit_message>
<xml_diff>
--- a/poster/SigmaTau_poster_draft.pptx
+++ b/poster/SigmaTau_poster_draft.pptx
@@ -935,7 +935,7 @@
                 <a:ea typeface="Calibri" pitchFamily="34" charset="-122"/>
                 <a:cs typeface="Calibri" pitchFamily="34" charset="-120"/>
               </a:rPr>
-              <a:t>SigmaTau.jl: unified, validated and fast time-and-frequency stability analysis in Julia</a:t>
+              <a:t>SigmaTau.jl: time-and-frequency stability analysis in Julia</a:t>
             </a:r>
             <a:endParaRPr lang="en-US" sz="6000" dirty="0"/>
           </a:p>
@@ -974,7 +974,7 @@
                 <a:ea typeface="Calibri" pitchFamily="34" charset="-122"/>
                 <a:cs typeface="Calibri" pitchFamily="34" charset="-120"/>
               </a:rPr>
-              <a:t>Every estimator family with per-τ noise identification, EDF and χ² intervals in one call · matches Stable32 and allantools · modified-total kernels 1,600 to 4,200× faster · a new Monte-Carlo-calibrated MHTOTDEV</a:t>
+              <a:t>Every estimator family, per-τ noise ID, EDF and χ² intervals in one call · matches Stable32 and allantools · modified-total kernels 1,600 to 4,200× faster · new Monte-Carlo-calibrated MHTOTDEV</a:t>
             </a:r>
             <a:endParaRPr lang="en-US" sz="2800" dirty="0"/>
           </a:p>
@@ -1042,7 +1042,7 @@
         <p:spPr>
           <a:xfrm>
             <a:off x="914400" y="4206240"/>
-            <a:ext cx="11094720" cy="13876020"/>
+            <a:ext cx="11094720" cy="12342495"/>
           </a:xfrm>
           <a:prstGeom prst="rect">
             <a:avLst/>
@@ -1067,7 +1067,7 @@
         <p:spPr>
           <a:xfrm>
             <a:off x="1234440" y="4526280"/>
-            <a:ext cx="10454640" cy="1009650"/>
+            <a:ext cx="10454640" cy="527685"/>
           </a:xfrm>
           <a:prstGeom prst="rect">
             <a:avLst/>
@@ -1091,7 +1091,7 @@
                 <a:ea typeface="Calibri" pitchFamily="34" charset="-122"/>
                 <a:cs typeface="Calibri" pitchFamily="34" charset="-120"/>
               </a:rPr>
-              <a:t>One API, every estimator, a χ² interval with every point</a:t>
+              <a:t>One API: every estimator, noise ID, EDF, χ² bounds</a:t>
             </a:r>
             <a:endParaRPr lang="en-US" sz="3300" dirty="0"/>
           </a:p>
@@ -1105,8 +1105,8 @@
         </p:nvSpPr>
         <p:spPr>
           <a:xfrm>
-            <a:off x="1234440" y="5700522"/>
-            <a:ext cx="10454640" cy="5615940"/>
+            <a:off x="1234440" y="5218557"/>
+            <a:ext cx="10454640" cy="4564380"/>
           </a:xfrm>
           <a:prstGeom prst="rect">
             <a:avLst/>
@@ -1134,7 +1134,7 @@
                 <a:ea typeface="Calibri" pitchFamily="34" charset="-122"/>
                 <a:cs typeface="Calibri" pitchFamily="34" charset="-120"/>
               </a:rPr>
-              <a:t>Allan: </a:t>
+              <a:t>Estimators: </a:t>
             </a:r>
             <a:pPr indent="0" marL="0">
               <a:buNone/>
@@ -1148,7 +1148,7 @@
                 <a:ea typeface="Calibri" pitchFamily="34" charset="-122"/>
                 <a:cs typeface="Calibri" pitchFamily="34" charset="-120"/>
               </a:rPr>
-              <a:t>ADEV, MDEV, TDEV.  Hadamard: HDEV, MHDEV, HTDEV.  Total: TOTDEV, MTOTDEV, TTOTDEV, HTOTDEV, MHTOTDEV.  Thêo1 / ThêoBR / ThêoH.  MTIE, TIE rms, PDEV.  Time-resolved DADEV / DHDEV.  Real-time ADEV / MDEV / HDEV / MHDEV.  N-cornered hat.  S</a:t>
+              <a:t>ADEV/MDEV/TDEV; HDEV/MHDEV/HTDEV; TOTDEV, MTOTDEV, TTOTDEV, HTOTDEV, MHTOTDEV; Thêo1/ThêoBR/ThêoH; MTIE, TIE rms, PDEV; DADEV/DHDEV; S</a:t>
             </a:r>
             <a:pPr indent="0" marL="0">
               <a:buNone/>
@@ -1204,7 +1204,7 @@
                 <a:ea typeface="Calibri" pitchFamily="34" charset="-122"/>
                 <a:cs typeface="Calibri" pitchFamily="34" charset="-120"/>
               </a:rPr>
-              <a:t>, ℒ(f), calibrated power-law synthesis.</a:t>
+              <a:t>, ℒ(f); calibrated power-law synthesis.</a:t>
             </a:r>
             <a:endParaRPr lang="en-US" sz="2400" dirty="0"/>
           </a:p>
@@ -1225,7 +1225,7 @@
                 <a:ea typeface="Calibri" pitchFamily="34" charset="-122"/>
                 <a:cs typeface="Calibri" pitchFamily="34" charset="-120"/>
               </a:rPr>
-              <a:t>Per τ, in the same call: </a:t>
+              <a:t>Per τ: </a:t>
             </a:r>
             <a:pPr indent="0" marL="0">
               <a:buNone/>
@@ -1239,7 +1239,7 @@
                 <a:ea typeface="Calibri" pitchFamily="34" charset="-122"/>
                 <a:cs typeface="Calibri" pitchFamily="34" charset="-120"/>
               </a:rPr>
-              <a:t>the deviation, the noise type (lag-1 autocorrelation with B1 / R(n) fallback), the Greenhall–Riley EDF, and the χ² bounds at 68.3 % (switchable). Total-family bias corrections are on by default and switchable.</a:t>
+              <a:t>σ, noise type (lag-1; B1/R(n) fallback), Greenhall–Riley EDF, 68.3 % χ² bounds (switchable). Total-family bias correction default on, switchable.</a:t>
             </a:r>
             <a:endParaRPr lang="en-US" sz="2400" dirty="0"/>
           </a:p>
@@ -1274,7 +1274,7 @@
                 <a:ea typeface="Calibri" pitchFamily="34" charset="-122"/>
                 <a:cs typeface="Calibri" pitchFamily="34" charset="-120"/>
               </a:rPr>
-              <a:t>phase or frequency, any τ grid; read, detrend, gap-fill and outlier tools; plain-text round-trip of results.</a:t>
+              <a:t>phase or frequency, any τ grid; read/detrend/gap-fill/outlier tools; plain-text round-trip.</a:t>
             </a:r>
             <a:endParaRPr lang="en-US" sz="2400" dirty="0"/>
           </a:p>
@@ -1295,7 +1295,7 @@
                 <a:ea typeface="Calibri" pitchFamily="34" charset="-122"/>
                 <a:cs typeface="Calibri" pitchFamily="34" charset="-120"/>
               </a:rPr>
-              <a:t>Real-time and multi-clock: </a:t>
+              <a:t>Real-time, multi-clock: </a:t>
             </a:r>
             <a:pPr indent="0" marL="0">
               <a:buNone/>
@@ -1309,7 +1309,7 @@
                 <a:ea typeface="Calibri" pitchFamily="34" charset="-122"/>
                 <a:cs typeface="Calibri" pitchFamily="34" charset="-120"/>
               </a:rPr>
-              <a:t>ADEV, MDEV, HDEV and MHDEV accumulate in O(1) per sample per τ from a ring buffer of at most 4·m</a:t>
+              <a:t>ADEV/MDEV/HDEV/MHDEV in O(1) per sample per τ; ring buffer ≤ 4·m</a:t>
             </a:r>
             <a:pPr indent="0" marL="0">
               <a:buNone/>
@@ -1337,7 +1337,7 @@
                 <a:ea typeface="Calibri" pitchFamily="34" charset="-122"/>
                 <a:cs typeface="Calibri" pitchFamily="34" charset="-120"/>
               </a:rPr>
-              <a:t> + 1 samples and reproduce the batch kernels on the samples seen so far to ≤ 2 × 10⁻¹¹ relative (Dobrogowski–Kasznia 2007, extended to third differences); dynamic σ(t, τ) maps; N-cornered hat for N ≥ 3 clocks.</a:t>
+              <a:t> + 1 samples; ≤ 2 × 10⁻¹¹ relative to batch kernels on samples seen so far (Dobrogowski–Kasznia 2007, extended to third differences). N-cornered hat, N ≥ 3.</a:t>
             </a:r>
             <a:endParaRPr lang="en-US" sz="2400" dirty="0"/>
           </a:p>
@@ -1351,7 +1351,7 @@
         </p:nvSpPr>
         <p:spPr>
           <a:xfrm>
-            <a:off x="1234440" y="11426190"/>
+            <a:off x="1234440" y="9892665"/>
             <a:ext cx="10454640" cy="1215390"/>
           </a:xfrm>
           <a:prstGeom prst="roundRect">
@@ -1378,7 +1378,7 @@
         </p:nvSpPr>
         <p:spPr>
           <a:xfrm>
-            <a:off x="1417320" y="11535918"/>
+            <a:off x="1417320" y="10002393"/>
             <a:ext cx="10088880" cy="995934"/>
           </a:xfrm>
           <a:prstGeom prst="rect">
@@ -1458,7 +1458,7 @@
           </p:nvPr>
         </p:nvGraphicFramePr>
         <p:xfrm>
-          <a:off x="1234440" y="12778740"/>
+          <a:off x="1234440" y="11245215"/>
           <a:ext cx="10454640" cy="914400"/>
         </p:xfrm>
         <a:graphic>
@@ -4212,8 +4212,8 @@
         </p:nvSpPr>
         <p:spPr>
           <a:xfrm>
-            <a:off x="914400" y="18493740"/>
-            <a:ext cx="11094720" cy="8113395"/>
+            <a:off x="914400" y="16960215"/>
+            <a:ext cx="11094720" cy="8823960"/>
           </a:xfrm>
           <a:prstGeom prst="rect">
             <a:avLst/>
@@ -4237,7 +4237,7 @@
         </p:nvSpPr>
         <p:spPr>
           <a:xfrm>
-            <a:off x="1234440" y="18813780"/>
+            <a:off x="1234440" y="17280255"/>
             <a:ext cx="10454640" cy="527685"/>
           </a:xfrm>
           <a:prstGeom prst="rect">
@@ -4262,7 +4262,7 @@
                 <a:ea typeface="Calibri" pitchFamily="34" charset="-122"/>
                 <a:cs typeface="Calibri" pitchFamily="34" charset="-120"/>
               </a:rPr>
-              <a:t>Deviation, noise type and interval at every τ</a:t>
+              <a:t>Deviation, noise type and χ² interval at every τ</a:t>
             </a:r>
             <a:endParaRPr lang="en-US" sz="3300" dirty="0"/>
           </a:p>
@@ -4284,8 +4284,8 @@
         </p:blipFill>
         <p:spPr>
           <a:xfrm>
-            <a:off x="2670243" y="19506057"/>
-            <a:ext cx="7583033" cy="5486400"/>
+            <a:off x="1785556" y="17972532"/>
+            <a:ext cx="9352408" cy="6766560"/>
           </a:xfrm>
           <a:prstGeom prst="rect">
             <a:avLst/>
@@ -4300,8 +4300,8 @@
         </p:nvSpPr>
         <p:spPr>
           <a:xfrm>
-            <a:off x="1234440" y="25102185"/>
-            <a:ext cx="10454640" cy="1184910"/>
+            <a:off x="1234440" y="24848820"/>
+            <a:ext cx="10454640" cy="615315"/>
           </a:xfrm>
           <a:prstGeom prst="rect">
             <a:avLst/>
@@ -4325,7 +4325,7 @@
                 <a:ea typeface="Calibri" pitchFamily="34" charset="-122"/>
                 <a:cs typeface="Calibri" pitchFamily="34" charset="-120"/>
               </a:rPr>
-              <a:t>Fig. 1. One call on the shipped 8192-point validation record (τ₀ = 1 s): five estimators with 68.3 % χ² intervals from the noise type identified at each τ (top strip). The totals reach further (TOTDEV to τ = T/2, MHTOTDEV to T/4) with tighter long-τ bounds; MDEV separates white from flicker PM.</a:t>
+              <a:t>Fig. 1. Shipped 8192-point record, τ₀ = 1 s, one call: five estimators, per-τ noise type (top strip), 68.3 % χ² intervals. TOTDEV reaches T/2, MHTOTDEV T/4, tighter long-τ bounds.</a:t>
             </a:r>
             <a:endParaRPr lang="en-US" sz="1950" dirty="0"/>
           </a:p>
@@ -4340,7 +4340,7 @@
         <p:spPr>
           <a:xfrm>
             <a:off x="12740640" y="4206240"/>
-            <a:ext cx="11094720" cy="9695688"/>
+            <a:ext cx="11094720" cy="8074533"/>
           </a:xfrm>
           <a:prstGeom prst="rect">
             <a:avLst/>
@@ -4389,7 +4389,7 @@
                 <a:ea typeface="Calibri" pitchFamily="34" charset="-122"/>
                 <a:cs typeface="Calibri" pitchFamily="34" charset="-120"/>
               </a:rPr>
-              <a:t>Matches Stable32 to its printed precision and allantools to machine precision</a:t>
+              <a:t>Matches Stable32 to printed precision, allantools to machine precision</a:t>
             </a:r>
             <a:endParaRPr lang="en-US" sz="3300" dirty="0"/>
           </a:p>
@@ -4404,7 +4404,7 @@
         <p:spPr>
           <a:xfrm>
             <a:off x="13060680" y="5700522"/>
-            <a:ext cx="10454640" cy="2545080"/>
+            <a:ext cx="10454640" cy="1493520"/>
           </a:xfrm>
           <a:prstGeom prst="rect">
             <a:avLst/>
@@ -4431,7 +4431,7 @@
                 <a:ea typeface="Calibri" pitchFamily="34" charset="-122"/>
                 <a:cs typeface="Calibri" pitchFamily="34" charset="-120"/>
               </a:rPr>
-              <a:t>Shipped fixture: an 8192-point phase record with the Stable32 and allantools outputs beside it. ADEV, MDEV, TDEV and HDEV agree with Stable32 to ≤ 0.005 % (its five significant figures) and with allantools to ≤ 1 × 10⁻¹³; raw total kernels agree with allantools to ≤ 4.4 × 10⁻¹⁵; confidence bounds agree with Stable32 to ≤ 0.05 % at 11 of 12 τ. Where a default differs from a reference (MTOTDEV bias policy, noise-ID detrending), the per-τ tables name the keyword that reproduces it.</a:t>
+              <a:t>Shipped fixture: 8192-point phase record, Stable32 and allantools outputs. ADEV/MDEV/TDEV/HDEV: ≤ 0.005 % vs Stable32 (five significant figures); ≤ 1 × 10⁻¹³ vs allantools. Raw total kernels: ≤ 4.4 × 10⁻¹⁵ vs allantools. Confidence bounds: ≤ 0.05 % vs Stable32 at 11 of 12 τ.</a:t>
             </a:r>
             <a:endParaRPr lang="en-US" sz="2400" dirty="0"/>
           </a:p>
@@ -4453,7 +4453,7 @@
         </p:blipFill>
         <p:spPr>
           <a:xfrm>
-            <a:off x="14795996" y="8355330"/>
+            <a:off x="14795996" y="7303770"/>
             <a:ext cx="6984008" cy="3931920"/>
           </a:xfrm>
           <a:prstGeom prst="rect">
@@ -4469,8 +4469,8 @@
         </p:nvSpPr>
         <p:spPr>
           <a:xfrm>
-            <a:off x="13060680" y="12396978"/>
-            <a:ext cx="10454640" cy="1184910"/>
+            <a:off x="13060680" y="11345418"/>
+            <a:ext cx="10454640" cy="615315"/>
           </a:xfrm>
           <a:prstGeom prst="rect">
             <a:avLst/>
@@ -4494,7 +4494,7 @@
                 <a:ea typeface="Calibri" pitchFamily="34" charset="-122"/>
                 <a:cs typeface="Calibri" pitchFamily="34" charset="-120"/>
               </a:rPr>
-              <a:t>Fig. 2. Relative difference to Stable32 at every τ for seven estimators. Filled points lie at or below the 5 × 10⁻⁵ floor set by Stable32's printed precision; open points are the τ = 256 s noise-ID convention (Stable32 α = +2, detrended identifier α = 0). MTOTDEV compared raw, as Stable32 reports the uncorrected statistic.</a:t>
+              <a:t>Fig. 2. Seven estimators vs Stable32, every τ. Filled: ≤ 5 × 10⁻⁵ printed-precision floor. Open: τ = 256 s, Stable32 α = +2, detrended α = 0. MTOTDEV raw.</a:t>
             </a:r>
             <a:endParaRPr lang="en-US" sz="1950" dirty="0"/>
           </a:p>
@@ -4508,8 +4508,8 @@
         </p:nvSpPr>
         <p:spPr>
           <a:xfrm>
-            <a:off x="12740640" y="14313408"/>
-            <a:ext cx="11094720" cy="8968931"/>
+            <a:off x="12740640" y="12692253"/>
+            <a:ext cx="11094720" cy="7409688"/>
           </a:xfrm>
           <a:prstGeom prst="rect">
             <a:avLst/>
@@ -4533,8 +4533,8 @@
         </p:nvSpPr>
         <p:spPr>
           <a:xfrm>
-            <a:off x="13060680" y="14633448"/>
-            <a:ext cx="10454640" cy="1009650"/>
+            <a:off x="13060680" y="13012293"/>
+            <a:ext cx="10454640" cy="527685"/>
           </a:xfrm>
           <a:prstGeom prst="rect">
             <a:avLst/>
@@ -4558,7 +4558,7 @@
                 <a:ea typeface="Calibri" pitchFamily="34" charset="-122"/>
                 <a:cs typeface="Calibri" pitchFamily="34" charset="-120"/>
               </a:rPr>
-              <a:t>Modified totals on a 4 × 10⁵-sample record: 0.47 s instead of 30 min</a:t>
+              <a:t>4 × 10⁵-sample modified totals: 0.47 s vs 30 min</a:t>
             </a:r>
             <a:endParaRPr lang="en-US" sz="3300" dirty="0"/>
           </a:p>
@@ -4572,8 +4572,8 @@
         </p:nvSpPr>
         <p:spPr>
           <a:xfrm>
-            <a:off x="13060680" y="15807690"/>
-            <a:ext cx="10454640" cy="2194560"/>
+            <a:off x="13060680" y="13704570"/>
+            <a:ext cx="10454640" cy="1493520"/>
           </a:xfrm>
           <a:prstGeom prst="rect">
             <a:avLst/>
@@ -4600,7 +4600,7 @@
                 <a:ea typeface="Calibri" pitchFamily="34" charset="-122"/>
                 <a:cs typeface="Calibri" pitchFamily="34" charset="-120"/>
               </a:rPr>
-              <a:t>Same samples, same τ grid, same statistic, kernel-only timing; allantools is single-threaded as it has no parallel path. On a measured 406 763-sample phase record MTOTDEV takes 0.469 s against 1 803.6 s and HTOTDEV 0.455 s against 1 928.0 s (3,842× and 4,233×). The gap is algorithmic as well as compiled-versus-interpreted: the reflected extension is streamed through a per-thread buffer and the window sum is split across threads.</a:t>
+              <a:t>Measured 406 763-sample phase record, kernel-only timing, same samples, τ grid and statistic; allantools single-threaded (no parallel path). MTOTDEV 0.469 s vs 1 803.6 s (3,842×); HTOTDEV 0.455 s vs 1 928.0 s (4,233×). Reflected extension streamed per thread; window sum split across threads.</a:t>
             </a:r>
             <a:endParaRPr lang="en-US" sz="2400" dirty="0"/>
           </a:p>
@@ -4622,8 +4622,8 @@
         </p:blipFill>
         <p:spPr>
           <a:xfrm>
-            <a:off x="14861441" y="18111978"/>
-            <a:ext cx="6853118" cy="3840480"/>
+            <a:off x="14943026" y="15307818"/>
+            <a:ext cx="6689948" cy="3749040"/>
           </a:xfrm>
           <a:prstGeom prst="rect">
             <a:avLst/>
@@ -4638,7 +4638,134 @@
         </p:nvSpPr>
         <p:spPr>
           <a:xfrm>
-            <a:off x="13060680" y="22062186"/>
+            <a:off x="13060680" y="19166586"/>
+            <a:ext cx="10454640" cy="615315"/>
+          </a:xfrm>
+          <a:prstGeom prst="rect">
+            <a:avLst/>
+          </a:prstGeom>
+          <a:noFill/>
+          <a:ln/>
+        </p:spPr>
+        <p:txBody>
+          <a:bodyPr wrap="square" lIns="0" tIns="0" rIns="0" bIns="0" rtlCol="0" anchor="t"/>
+          <a:lstStyle/>
+          <a:p>
+            <a:pPr indent="0" marL="0">
+              <a:buNone/>
+            </a:pPr>
+            <a:r>
+              <a:rPr lang="en-US" sz="1950" dirty="0">
+                <a:solidFill>
+                  <a:srgbClr val="52514E"/>
+                </a:solidFill>
+                <a:latin typeface="Calibri" pitchFamily="34" charset="0"/>
+                <a:ea typeface="Calibri" pitchFamily="34" charset="-122"/>
+                <a:cs typeface="Calibri" pitchFamily="34" charset="-120"/>
+              </a:rPr>
+              <a:t>Fig. 3. Speed-up per kernel, N = 25 000 white-PM record (bench/), 12-core workstation; diamonds: independent 4-core re-run. Ratios portable; absolute times machine-dependent.</a:t>
+            </a:r>
+            <a:endParaRPr lang="en-US" sz="1950" dirty="0"/>
+          </a:p>
+        </p:txBody>
+      </p:sp>
+      <p:sp>
+        <p:nvSpPr>
+          <p:cNvPr id="26" name="Shape 20"/>
+          <p:cNvSpPr/>
+          <p:nvPr/>
+        </p:nvSpPr>
+        <p:spPr>
+          <a:xfrm>
+            <a:off x="12740640" y="20513421"/>
+            <a:ext cx="11094720" cy="6365558"/>
+          </a:xfrm>
+          <a:prstGeom prst="rect">
+            <a:avLst/>
+          </a:prstGeom>
+          <a:solidFill>
+            <a:srgbClr val="FFFFFF"/>
+          </a:solidFill>
+          <a:ln w="12700">
+            <a:solidFill>
+              <a:srgbClr val="D9D4D0"/>
+            </a:solidFill>
+            <a:prstDash val="solid"/>
+          </a:ln>
+        </p:spPr>
+      </p:sp>
+      <p:sp>
+        <p:nvSpPr>
+          <p:cNvPr id="27" name="Heading"/>
+          <p:cNvSpPr txBox="1"/>
+          <p:nvPr/>
+        </p:nvSpPr>
+        <p:spPr>
+          <a:xfrm>
+            <a:off x="13060680" y="20833461"/>
+            <a:ext cx="10454640" cy="527685"/>
+          </a:xfrm>
+          <a:prstGeom prst="rect">
+            <a:avLst/>
+          </a:prstGeom>
+          <a:noFill/>
+          <a:ln/>
+        </p:spPr>
+        <p:txBody>
+          <a:bodyPr wrap="square" lIns="0" tIns="0" rIns="0" bIns="0" rtlCol="0" anchor="t"/>
+          <a:lstStyle/>
+          <a:p>
+            <a:pPr indent="0" marL="0">
+              <a:buNone/>
+            </a:pPr>
+            <a:r>
+              <a:rPr lang="en-US" sz="3300" b="1" dirty="0">
+                <a:solidFill>
+                  <a:srgbClr val="9E1B32"/>
+                </a:solidFill>
+                <a:latin typeface="Calibri" pitchFamily="34" charset="0"/>
+                <a:ea typeface="Calibri" pitchFamily="34" charset="-122"/>
+                <a:cs typeface="Calibri" pitchFamily="34" charset="-120"/>
+              </a:rPr>
+              <a:t>Desktop explorer: the whole workflow without code</a:t>
+            </a:r>
+            <a:endParaRPr lang="en-US" sz="3300" dirty="0"/>
+          </a:p>
+        </p:txBody>
+      </p:sp>
+      <p:pic>
+        <p:nvPicPr>
+          <p:cNvPr id="28" name="F8_explorer" descr="/home/user/SigmaTau.jl/poster/figures/F8_explorer.png">    </p:cNvPr>
+          <p:cNvPicPr>
+            <a:picLocks noChangeAspect="1"/>
+          </p:cNvPicPr>
+          <p:nvPr/>
+        </p:nvPicPr>
+        <p:blipFill>
+          <a:blip r:embed="rId4"/>
+          <a:stretch>
+            <a:fillRect/>
+          </a:stretch>
+        </p:blipFill>
+        <p:spPr>
+          <a:xfrm>
+            <a:off x="15077872" y="21525738"/>
+            <a:ext cx="6420255" cy="4023360"/>
+          </a:xfrm>
+          <a:prstGeom prst="rect">
+            <a:avLst/>
+          </a:prstGeom>
+        </p:spPr>
+      </p:pic>
+      <p:sp>
+        <p:nvSpPr>
+          <p:cNvPr id="29" name="Caption"/>
+          <p:cNvSpPr txBox="1"/>
+          <p:nvPr/>
+        </p:nvSpPr>
+        <p:spPr>
+          <a:xfrm>
+            <a:off x="13060680" y="25658826"/>
             <a:ext cx="10454640" cy="900112"/>
           </a:xfrm>
           <a:prstGeom prst="rect">
@@ -4663,7 +4790,63 @@
                 <a:ea typeface="Calibri" pitchFamily="34" charset="-122"/>
                 <a:cs typeface="Calibri" pitchFamily="34" charset="-120"/>
               </a:rPr>
-              <a:t>Fig. 3. Speed-up per kernel on an N = 25 000 white-PM record (bench/, 12-core workstation; diamonds: independent 4-core re-run). Ratios are the portable result; absolute times depend on the machine.</a:t>
+              <a:t>Fig. 4. GLMakie desktop app: load or synthesize a record; preprocessing, estimators, τ grid, confidence level; σ</a:t>
+            </a:r>
+            <a:pPr indent="0" marL="0">
+              <a:buNone/>
+            </a:pPr>
+            <a:r>
+              <a:rPr lang="en-US" sz="1950" baseline="-40000" dirty="0">
+                <a:solidFill>
+                  <a:srgbClr val="52514E"/>
+                </a:solidFill>
+                <a:latin typeface="Calibri" pitchFamily="34" charset="0"/>
+                <a:ea typeface="Calibri" pitchFamily="34" charset="-122"/>
+                <a:cs typeface="Calibri" pitchFamily="34" charset="-120"/>
+              </a:rPr>
+              <a:t>y</a:t>
+            </a:r>
+            <a:pPr indent="0" marL="0">
+              <a:buNone/>
+            </a:pPr>
+            <a:r>
+              <a:rPr lang="en-US" sz="1950" dirty="0">
+                <a:solidFill>
+                  <a:srgbClr val="52514E"/>
+                </a:solidFill>
+                <a:latin typeface="Calibri" pitchFamily="34" charset="0"/>
+                <a:ea typeface="Calibri" pitchFamily="34" charset="-122"/>
+                <a:cs typeface="Calibri" pitchFamily="34" charset="-120"/>
+              </a:rPr>
+              <a:t> and σ</a:t>
+            </a:r>
+            <a:pPr indent="0" marL="0">
+              <a:buNone/>
+            </a:pPr>
+            <a:r>
+              <a:rPr lang="en-US" sz="1950" baseline="-40000" dirty="0">
+                <a:solidFill>
+                  <a:srgbClr val="52514E"/>
+                </a:solidFill>
+                <a:latin typeface="Calibri" pitchFamily="34" charset="0"/>
+                <a:ea typeface="Calibri" pitchFamily="34" charset="-122"/>
+                <a:cs typeface="Calibri" pitchFamily="34" charset="-120"/>
+              </a:rPr>
+              <a:t>x</a:t>
+            </a:r>
+            <a:pPr indent="0" marL="0">
+              <a:buNone/>
+            </a:pPr>
+            <a:r>
+              <a:rPr lang="en-US" sz="1950" dirty="0">
+                <a:solidFill>
+                  <a:srgbClr val="52514E"/>
+                </a:solidFill>
+                <a:latin typeface="Calibri" pitchFamily="34" charset="0"/>
+                <a:ea typeface="Calibri" pitchFamily="34" charset="-122"/>
+                <a:cs typeface="Calibri" pitchFamily="34" charset="-120"/>
+              </a:rPr>
+              <a:t> curves with χ² intervals, per-τ table, spectra, dynamic map; PNG/PDF/SVG and TSV export.</a:t>
             </a:r>
             <a:endParaRPr lang="en-US" sz="1950" dirty="0"/>
           </a:p>
@@ -4671,14 +4854,14 @@
       </p:sp>
       <p:sp>
         <p:nvSpPr>
-          <p:cNvPr id="26" name="Shape 20"/>
+          <p:cNvPr id="30" name="Shape 23"/>
           <p:cNvSpPr/>
           <p:nvPr/>
         </p:nvSpPr>
         <p:spPr>
           <a:xfrm>
-            <a:off x="12740640" y="23693819"/>
-            <a:ext cx="11094720" cy="3283585"/>
+            <a:off x="24566880" y="4206240"/>
+            <a:ext cx="11094720" cy="3997325"/>
           </a:xfrm>
           <a:prstGeom prst="rect">
             <a:avLst/>
@@ -4696,13 +4879,13 @@
       </p:sp>
       <p:sp>
         <p:nvSpPr>
-          <p:cNvPr id="27" name="Heading"/>
+          <p:cNvPr id="31" name="Heading"/>
           <p:cNvSpPr txBox="1"/>
           <p:nvPr/>
         </p:nvSpPr>
         <p:spPr>
           <a:xfrm>
-            <a:off x="13060680" y="24013859"/>
+            <a:off x="24886920" y="4526280"/>
             <a:ext cx="10454640" cy="527685"/>
           </a:xfrm>
           <a:prstGeom prst="rect">
@@ -4727,7 +4910,7 @@
                 <a:ea typeface="Calibri" pitchFamily="34" charset="-122"/>
                 <a:cs typeface="Calibri" pitchFamily="34" charset="-120"/>
               </a:rPr>
-              <a:t>Reproducible by construction</a:t>
+              <a:t>MHTOTDEV: new total estimator, calibrated by Monte Carlo</a:t>
             </a:r>
             <a:endParaRPr lang="en-US" sz="3300" dirty="0"/>
           </a:p>
@@ -4735,170 +4918,14 @@
       </p:sp>
       <p:sp>
         <p:nvSpPr>
-          <p:cNvPr id="28" name="Bullets"/>
+          <p:cNvPr id="32" name="Body"/>
           <p:cNvSpPr txBox="1"/>
           <p:nvPr/>
         </p:nvSpPr>
         <p:spPr>
           <a:xfrm>
-            <a:off x="13060680" y="24706136"/>
-            <a:ext cx="10454640" cy="1932940"/>
-          </a:xfrm>
-          <a:prstGeom prst="rect">
-            <a:avLst/>
-          </a:prstGeom>
-          <a:noFill/>
-          <a:ln/>
-        </p:spPr>
-        <p:txBody>
-          <a:bodyPr wrap="square" lIns="0" tIns="0" rIns="0" bIns="0" rtlCol="0" anchor="t"/>
-          <a:lstStyle/>
-          <a:p>
-            <a:pPr marL="279400" indent="-279400">
-              <a:spcAft>
-                <a:spcPts val="700"/>
-              </a:spcAft>
-              <a:buSzPct val="100000"/>
-              <a:buChar char="•"/>
-            </a:pPr>
-            <a:r>
-              <a:rPr lang="en-US" sz="2400" b="1" dirty="0">
-                <a:solidFill>
-                  <a:srgbClr val="0B0B0B"/>
-                </a:solidFill>
-                <a:latin typeface="Calibri" pitchFamily="34" charset="0"/>
-                <a:ea typeface="Calibri" pitchFamily="34" charset="-122"/>
-                <a:cs typeface="Calibri" pitchFamily="34" charset="-120"/>
-              </a:rPr>
-              <a:t>Shipped with the code: </a:t>
-            </a:r>
-            <a:pPr indent="0" marL="0">
-              <a:buNone/>
-            </a:pPr>
-            <a:r>
-              <a:rPr lang="en-US" sz="2400" dirty="0">
-                <a:solidFill>
-                  <a:srgbClr val="0B0B0B"/>
-                </a:solidFill>
-                <a:latin typeface="Calibri" pitchFamily="34" charset="0"/>
-                <a:ea typeface="Calibri" pitchFamily="34" charset="-122"/>
-                <a:cs typeface="Calibri" pitchFamily="34" charset="-120"/>
-              </a:rPr>
-              <a:t>the validation fixture with Stable32 and allantools outputs, the per-τ comparison tables, the benchmark scripts for both libraries, and the Monte Carlo harness with its seed and tracked fit artifact.</a:t>
-            </a:r>
-            <a:endParaRPr lang="en-US" sz="2400" dirty="0"/>
-          </a:p>
-          <a:p>
-            <a:pPr marL="279400" indent="-279400">
-              <a:spcAft>
-                <a:spcPts val="700"/>
-              </a:spcAft>
-              <a:buSzPct val="100000"/>
-              <a:buChar char="•"/>
-            </a:pPr>
-            <a:r>
-              <a:rPr lang="en-US" sz="2400" b="1" dirty="0">
-                <a:solidFill>
-                  <a:srgbClr val="0B0B0B"/>
-                </a:solidFill>
-                <a:latin typeface="Calibri" pitchFamily="34" charset="0"/>
-                <a:ea typeface="Calibri" pitchFamily="34" charset="-122"/>
-                <a:cs typeface="Calibri" pitchFamily="34" charset="-120"/>
-              </a:rPr>
-              <a:t>Next: </a:t>
-            </a:r>
-            <a:pPr indent="0" marL="0">
-              <a:buNone/>
-            </a:pPr>
-            <a:r>
-              <a:rPr lang="en-US" sz="2400" dirty="0">
-                <a:solidFill>
-                  <a:srgbClr val="0B0B0B"/>
-                </a:solidFill>
-                <a:latin typeface="Calibri" pitchFamily="34" charset="0"/>
-                <a:ea typeface="Calibri" pitchFamily="34" charset="-122"/>
-                <a:cs typeface="Calibri" pitchFamily="34" charset="-120"/>
-              </a:rPr>
-              <a:t>real-time monitoring of the laboratory Rb-87 clock comparisons; Monte Carlo calibration of the Thêo family and of gapped records.</a:t>
-            </a:r>
-            <a:endParaRPr lang="en-US" sz="2400" dirty="0"/>
-          </a:p>
-        </p:txBody>
-      </p:sp>
-      <p:sp>
-        <p:nvSpPr>
-          <p:cNvPr id="29" name="Shape 23"/>
-          <p:cNvSpPr/>
-          <p:nvPr/>
-        </p:nvSpPr>
-        <p:spPr>
-          <a:xfrm>
-            <a:off x="24566880" y="4206240"/>
-            <a:ext cx="11094720" cy="5530850"/>
-          </a:xfrm>
-          <a:prstGeom prst="rect">
-            <a:avLst/>
-          </a:prstGeom>
-          <a:solidFill>
-            <a:srgbClr val="FFFFFF"/>
-          </a:solidFill>
-          <a:ln w="12700">
-            <a:solidFill>
-              <a:srgbClr val="D9D4D0"/>
-            </a:solidFill>
-            <a:prstDash val="solid"/>
-          </a:ln>
-        </p:spPr>
-      </p:sp>
-      <p:sp>
-        <p:nvSpPr>
-          <p:cNvPr id="30" name="Heading"/>
-          <p:cNvSpPr txBox="1"/>
-          <p:nvPr/>
-        </p:nvSpPr>
-        <p:spPr>
-          <a:xfrm>
-            <a:off x="24886920" y="4526280"/>
-            <a:ext cx="10454640" cy="1009650"/>
-          </a:xfrm>
-          <a:prstGeom prst="rect">
-            <a:avLst/>
-          </a:prstGeom>
-          <a:noFill/>
-          <a:ln/>
-        </p:spPr>
-        <p:txBody>
-          <a:bodyPr wrap="square" lIns="0" tIns="0" rIns="0" bIns="0" rtlCol="0" anchor="t"/>
-          <a:lstStyle/>
-          <a:p>
-            <a:pPr indent="0" marL="0">
-              <a:buNone/>
-            </a:pPr>
-            <a:r>
-              <a:rPr lang="en-US" sz="3300" b="1" dirty="0">
-                <a:solidFill>
-                  <a:srgbClr val="9E1B32"/>
-                </a:solidFill>
-                <a:latin typeface="Calibri" pitchFamily="34" charset="0"/>
-                <a:ea typeface="Calibri" pitchFamily="34" charset="-122"/>
-                <a:cs typeface="Calibri" pitchFamily="34" charset="-120"/>
-              </a:rPr>
-              <a:t>MHTOTDEV: a new total estimator, calibrated by Monte Carlo</a:t>
-            </a:r>
-            <a:endParaRPr lang="en-US" sz="3300" dirty="0"/>
-          </a:p>
-        </p:txBody>
-      </p:sp>
-      <p:sp>
-        <p:nvSpPr>
-          <p:cNvPr id="31" name="Body"/>
-          <p:cNvSpPr txBox="1"/>
-          <p:nvPr/>
-        </p:nvSpPr>
-        <p:spPr>
-          <a:xfrm>
-            <a:off x="24886920" y="5700522"/>
-            <a:ext cx="10454640" cy="3698240"/>
+            <a:off x="24886920" y="5218557"/>
+            <a:ext cx="10454640" cy="2646680"/>
           </a:xfrm>
           <a:prstGeom prst="rect">
             <a:avLst/>
@@ -4925,7 +4952,7 @@
                 <a:ea typeface="Calibri" pitchFamily="34" charset="-122"/>
                 <a:cs typeface="Calibri" pitchFamily="34" charset="-120"/>
               </a:rPr>
-              <a:t>Modified Hadamard total deviation combines drift rejection (third differences), white-from-flicker PM separation (modified form) and long-τ confidence (reflected extension). No published bias or EDF existed, so both were measured against synthesized noise: α ∈ {+2 … −2}, N ∈ {1024 … 32768}, R = 3000 realizations per cell, one seeded stream per (α, N, r), fits over τ/τ₀ ≥ 16. Bias B = E[MHTOTVAR]/E[MHVAR] against MHDEV on the same realization; EDF from the χ² variance relation, bootstrap standard error 2.6 %.</a:t>
+              <a:t>Monte Carlo: α ∈ {+2 … −2}, N ∈ {1024 … 32768}, R = 3000 per cell, one seeded stream per (α, N, r), fit window τ/τ₀ ≥ 16. Bias B = E[MHTOTVAR]/E[MHVAR] vs MHDEV, same realization; EDF from χ² variance relation; bootstrap SE 2.6 %.</a:t>
             </a:r>
             <a:endParaRPr lang="en-US" sz="2400" dirty="0"/>
           </a:p>
@@ -4945,7 +4972,7 @@
                 <a:ea typeface="Calibri" pitchFamily="34" charset="-122"/>
                 <a:cs typeface="Calibri" pitchFamily="34" charset="-120"/>
               </a:rPr>
-              <a:t>Kernel: the Greenhall scheme of MTOTDEV and HTOTDEV on windows of length 4m (half-mean slope removal, 3× time-reverse extension, modified third difference), after global least-squares drift removal.</a:t>
+              <a:t>Kernel: Greenhall MTOTDEV/HTOTDEV scheme on 4m windows (half-mean slope removal, 3× time-reverse extension, modified third difference) after global least-squares drift removal.</a:t>
             </a:r>
             <a:endParaRPr lang="en-US" sz="2400" dirty="0"/>
           </a:p>
@@ -4953,14 +4980,14 @@
       </p:sp>
       <p:sp>
         <p:nvSpPr>
-          <p:cNvPr id="32" name="Shape 26"/>
+          <p:cNvPr id="33" name="Shape 26"/>
           <p:cNvSpPr/>
           <p:nvPr/>
         </p:nvSpPr>
         <p:spPr>
           <a:xfrm>
-            <a:off x="24566880" y="10148570"/>
-            <a:ext cx="11094720" cy="8638413"/>
+            <a:off x="24566880" y="8615045"/>
+            <a:ext cx="11094720" cy="8065008"/>
           </a:xfrm>
           <a:prstGeom prst="rect">
             <a:avLst/>
@@ -4978,14 +5005,14 @@
       </p:sp>
       <p:sp>
         <p:nvSpPr>
-          <p:cNvPr id="33" name="Heading"/>
+          <p:cNvPr id="34" name="Heading"/>
           <p:cNvSpPr txBox="1"/>
           <p:nvPr/>
         </p:nvSpPr>
         <p:spPr>
           <a:xfrm>
-            <a:off x="24886920" y="10468610"/>
-            <a:ext cx="10454640" cy="1009650"/>
+            <a:off x="24886920" y="8935085"/>
+            <a:ext cx="10454640" cy="527685"/>
           </a:xfrm>
           <a:prstGeom prst="rect">
             <a:avLst/>
@@ -5009,7 +5036,7 @@
                 <a:ea typeface="Calibri" pitchFamily="34" charset="-122"/>
                 <a:cs typeface="Calibri" pitchFamily="34" charset="-120"/>
               </a:rPr>
-              <a:t>Unbiased for PM noise, reads high for red FM; EDF fits with R² ≥ 0.9982</a:t>
+              <a:t>PM unbiased, red FM reads high; EDF R² ≥ 0.9982</a:t>
             </a:r>
             <a:endParaRPr lang="en-US" sz="3300" dirty="0"/>
           </a:p>
@@ -5017,31 +5044,7 @@
       </p:sp>
       <p:pic>
         <p:nvPicPr>
-          <p:cNvPr id="34" name="F4_mhtot_bias" descr="/home/user/SigmaTau.jl/poster/figures/F4_mhtot_bias.png">    </p:cNvPr>
-          <p:cNvPicPr>
-            <a:picLocks noChangeAspect="1"/>
-          </p:cNvPicPr>
-          <p:nvPr/>
-        </p:nvPicPr>
-        <p:blipFill>
-          <a:blip r:embed="rId4"/>
-          <a:stretch>
-            <a:fillRect/>
-          </a:stretch>
-        </p:blipFill>
-        <p:spPr>
-          <a:xfrm>
-            <a:off x="25324428" y="11642852"/>
-            <a:ext cx="4215143" cy="3657600"/>
-          </a:xfrm>
-          <a:prstGeom prst="rect">
-            <a:avLst/>
-          </a:prstGeom>
-        </p:spPr>
-      </p:pic>
-      <p:pic>
-        <p:nvPicPr>
-          <p:cNvPr id="35" name="F5_mhtot_edf" descr="/home/user/SigmaTau.jl/poster/figures/F5_mhtot_edf.png">    </p:cNvPr>
+          <p:cNvPr id="35" name="F4_mhtot_bias" descr="/home/user/SigmaTau.jl/poster/figures/F4_mhtot_bias.png">    </p:cNvPr>
           <p:cNvPicPr>
             <a:picLocks noChangeAspect="1"/>
           </p:cNvPicPr>
@@ -5055,8 +5058,32 @@
         </p:blipFill>
         <p:spPr>
           <a:xfrm>
-            <a:off x="30691116" y="11642852"/>
-            <a:ext cx="4210729" cy="3657600"/>
+            <a:off x="25377118" y="9627362"/>
+            <a:ext cx="4109765" cy="3566160"/>
+          </a:xfrm>
+          <a:prstGeom prst="rect">
+            <a:avLst/>
+          </a:prstGeom>
+        </p:spPr>
+      </p:pic>
+      <p:pic>
+        <p:nvPicPr>
+          <p:cNvPr id="36" name="F5_mhtot_edf" descr="/home/user/SigmaTau.jl/poster/figures/F5_mhtot_edf.png">    </p:cNvPr>
+          <p:cNvPicPr>
+            <a:picLocks noChangeAspect="1"/>
+          </p:cNvPicPr>
+          <p:nvPr/>
+        </p:nvPicPr>
+        <p:blipFill>
+          <a:blip r:embed="rId6"/>
+          <a:stretch>
+            <a:fillRect/>
+          </a:stretch>
+        </p:blipFill>
+        <p:spPr>
+          <a:xfrm>
+            <a:off x="30743750" y="9627362"/>
+            <a:ext cx="4105461" cy="3566160"/>
           </a:xfrm>
           <a:prstGeom prst="rect">
             <a:avLst/>
@@ -5065,13 +5092,13 @@
       </p:pic>
       <p:sp>
         <p:nvSpPr>
-          <p:cNvPr id="36" name="Caption"/>
+          <p:cNvPr id="37" name="Caption"/>
           <p:cNvSpPr txBox="1"/>
           <p:nvPr/>
         </p:nvSpPr>
         <p:spPr>
           <a:xfrm>
-            <a:off x="24886920" y="15410180"/>
+            <a:off x="24886920" y="13303250"/>
             <a:ext cx="10454640" cy="615315"/>
           </a:xfrm>
           <a:prstGeom prst="rect">
@@ -5096,7 +5123,7 @@
                 <a:ea typeface="Calibri" pitchFamily="34" charset="-122"/>
                 <a:cs typeface="Calibri" pitchFamily="34" charset="-120"/>
               </a:rPr>
-              <a:t>Fig. 4. Shipped models B = b₀ + b₁ τ/T and ν = b T/τ − c (seed 20260531). Below T/τ ≈ 5–6 the interval is indicative only; σ itself is valid to the reach limit τ = T/4.</a:t>
+              <a:t>Fig. 5. Models B = b₀ + b₁ τ/T, ν = b T/τ − c (seed 20260531). Interval indicative only below T/τ ≈ 5–6; σ valid to τ = T/4.</a:t>
             </a:r>
             <a:endParaRPr lang="en-US" sz="1950" dirty="0"/>
           </a:p>
@@ -5117,7 +5144,7 @@
           </p:nvPr>
         </p:nvGraphicFramePr>
         <p:xfrm>
-          <a:off x="24886920" y="16116935"/>
+          <a:off x="24886920" y="14010005"/>
           <a:ext cx="10454640" cy="914400"/>
         </p:xfrm>
         <a:graphic>
@@ -8007,14 +8034,14 @@
       </p:graphicFrame>
       <p:sp>
         <p:nvSpPr>
-          <p:cNvPr id="38" name="Shape 29"/>
+          <p:cNvPr id="39" name="Shape 29"/>
           <p:cNvSpPr/>
           <p:nvPr/>
         </p:nvSpPr>
         <p:spPr>
           <a:xfrm>
-            <a:off x="24566880" y="19198463"/>
-            <a:ext cx="11094720" cy="7772400"/>
+            <a:off x="24566880" y="17091533"/>
+            <a:ext cx="11094720" cy="5715000"/>
           </a:xfrm>
           <a:prstGeom prst="rect">
             <a:avLst/>
@@ -8032,14 +8059,14 @@
       </p:sp>
       <p:sp>
         <p:nvSpPr>
-          <p:cNvPr id="39" name="Heading"/>
+          <p:cNvPr id="40" name="Heading"/>
           <p:cNvSpPr txBox="1"/>
           <p:nvPr/>
         </p:nvSpPr>
         <p:spPr>
           <a:xfrm>
-            <a:off x="24886920" y="19518503"/>
-            <a:ext cx="10454640" cy="1009650"/>
+            <a:off x="24886920" y="17411573"/>
+            <a:ext cx="10454640" cy="527685"/>
           </a:xfrm>
           <a:prstGeom prst="rect">
             <a:avLst/>
@@ -8063,7 +8090,7 @@
                 <a:ea typeface="Calibri" pitchFamily="34" charset="-122"/>
                 <a:cs typeface="Calibri" pitchFamily="34" charset="-120"/>
               </a:rPr>
-              <a:t>Time-resolved stability: σ(t, τ) maps for non-stationary records</a:t>
+              <a:t>DADEV σ(t, τ) map: change located to within one window</a:t>
             </a:r>
             <a:endParaRPr lang="en-US" sz="3300" dirty="0"/>
           </a:p>
@@ -8071,22 +8098,22 @@
       </p:sp>
       <p:pic>
         <p:nvPicPr>
-          <p:cNvPr id="40" name="F7_dynamic" descr="/home/user/SigmaTau.jl/poster/figures/F7_dynamic.png">    </p:cNvPr>
+          <p:cNvPr id="41" name="F7_dynamic" descr="/home/user/SigmaTau.jl/poster/figures/F7_dynamic.png">    </p:cNvPr>
           <p:cNvPicPr>
             <a:picLocks noChangeAspect="1"/>
           </p:cNvPicPr>
           <p:nvPr/>
         </p:nvPicPr>
         <p:blipFill>
-          <a:blip r:embed="rId6"/>
+          <a:blip r:embed="rId7"/>
           <a:stretch>
             <a:fillRect/>
           </a:stretch>
         </p:blipFill>
         <p:spPr>
           <a:xfrm>
-            <a:off x="27133415" y="20692745"/>
-            <a:ext cx="5961650" cy="4663440"/>
+            <a:off x="27776338" y="18103850"/>
+            <a:ext cx="4675804" cy="3657600"/>
           </a:xfrm>
           <a:prstGeom prst="rect">
             <a:avLst/>
@@ -8095,14 +8122,14 @@
       </p:pic>
       <p:sp>
         <p:nvSpPr>
-          <p:cNvPr id="41" name="Caption"/>
+          <p:cNvPr id="42" name="Caption"/>
           <p:cNvSpPr txBox="1"/>
           <p:nvPr/>
         </p:nvSpPr>
         <p:spPr>
           <a:xfrm>
-            <a:off x="24886920" y="25465913"/>
-            <a:ext cx="10454640" cy="1184910"/>
+            <a:off x="24886920" y="21871178"/>
+            <a:ext cx="10454640" cy="615315"/>
           </a:xfrm>
           <a:prstGeom prst="rect">
             <a:avLst/>
@@ -8126,7 +8153,7 @@
                 <a:ea typeface="Calibri" pitchFamily="34" charset="-122"/>
                 <a:cs typeface="Calibri" pitchFamily="34" charset="-120"/>
               </a:rPr>
-              <a:t>Fig. 5. DADEV waterfall on a synthesized 8191-sample record (τ₀ = 1 s): white FM at σ</a:t>
+              <a:t>Fig. 6. Synthetic 8191-sample record, τ₀ = 1 s: white FM σ</a:t>
             </a:r>
             <a:pPr indent="0" marL="0">
               <a:buNone/>
@@ -8154,7 +8181,7 @@
                 <a:ea typeface="Calibri" pitchFamily="34" charset="-122"/>
                 <a:cs typeface="Calibri" pitchFamily="34" charset="-120"/>
               </a:rPr>
-              <a:t>(1 s) = 1 × 10⁻¹² for the first half, then 3 × 10⁻¹² plus flicker FM at 1 × 10⁻¹²; window 1024 samples, step 128. Each curve is the overlapping ADEV of one window, so the change is located to within one window length.</a:t>
+              <a:t>(1 s) = 1 × 10⁻¹² first half, then 3 × 10⁻¹² plus flicker FM 1 × 10⁻¹²; window 1024, step 128.</a:t>
             </a:r>
             <a:endParaRPr lang="en-US" sz="1950" dirty="0"/>
           </a:p>
@@ -8162,7 +8189,163 @@
       </p:sp>
       <p:sp>
         <p:nvSpPr>
-          <p:cNvPr id="42" name="Shape 32"/>
+          <p:cNvPr id="43" name="Shape 32"/>
+          <p:cNvSpPr/>
+          <p:nvPr/>
+        </p:nvSpPr>
+        <p:spPr>
+          <a:xfrm>
+            <a:off x="24566880" y="23218013"/>
+            <a:ext cx="11094720" cy="3283585"/>
+          </a:xfrm>
+          <a:prstGeom prst="rect">
+            <a:avLst/>
+          </a:prstGeom>
+          <a:solidFill>
+            <a:srgbClr val="FFFFFF"/>
+          </a:solidFill>
+          <a:ln w="12700">
+            <a:solidFill>
+              <a:srgbClr val="D9D4D0"/>
+            </a:solidFill>
+            <a:prstDash val="solid"/>
+          </a:ln>
+        </p:spPr>
+      </p:sp>
+      <p:sp>
+        <p:nvSpPr>
+          <p:cNvPr id="44" name="Heading"/>
+          <p:cNvSpPr txBox="1"/>
+          <p:nvPr/>
+        </p:nvSpPr>
+        <p:spPr>
+          <a:xfrm>
+            <a:off x="24886920" y="23538053"/>
+            <a:ext cx="10454640" cy="527685"/>
+          </a:xfrm>
+          <a:prstGeom prst="rect">
+            <a:avLst/>
+          </a:prstGeom>
+          <a:noFill/>
+          <a:ln/>
+        </p:spPr>
+        <p:txBody>
+          <a:bodyPr wrap="square" lIns="0" tIns="0" rIns="0" bIns="0" rtlCol="0" anchor="t"/>
+          <a:lstStyle/>
+          <a:p>
+            <a:pPr indent="0" marL="0">
+              <a:buNone/>
+            </a:pPr>
+            <a:r>
+              <a:rPr lang="en-US" sz="3300" b="1" dirty="0">
+                <a:solidFill>
+                  <a:srgbClr val="9E1B32"/>
+                </a:solidFill>
+                <a:latin typeface="Calibri" pitchFamily="34" charset="0"/>
+                <a:ea typeface="Calibri" pitchFamily="34" charset="-122"/>
+                <a:cs typeface="Calibri" pitchFamily="34" charset="-120"/>
+              </a:rPr>
+              <a:t>Every result reproducible from the repository</a:t>
+            </a:r>
+            <a:endParaRPr lang="en-US" sz="3300" dirty="0"/>
+          </a:p>
+        </p:txBody>
+      </p:sp>
+      <p:sp>
+        <p:nvSpPr>
+          <p:cNvPr id="45" name="Bullets"/>
+          <p:cNvSpPr txBox="1"/>
+          <p:nvPr/>
+        </p:nvSpPr>
+        <p:spPr>
+          <a:xfrm>
+            <a:off x="24886920" y="24230330"/>
+            <a:ext cx="10454640" cy="1932940"/>
+          </a:xfrm>
+          <a:prstGeom prst="rect">
+            <a:avLst/>
+          </a:prstGeom>
+          <a:noFill/>
+          <a:ln/>
+        </p:spPr>
+        <p:txBody>
+          <a:bodyPr wrap="square" lIns="0" tIns="0" rIns="0" bIns="0" rtlCol="0" anchor="t"/>
+          <a:lstStyle/>
+          <a:p>
+            <a:pPr marL="279400" indent="-279400">
+              <a:spcAft>
+                <a:spcPts val="700"/>
+              </a:spcAft>
+              <a:buSzPct val="100000"/>
+              <a:buChar char="•"/>
+            </a:pPr>
+            <a:r>
+              <a:rPr lang="en-US" sz="2400" b="1" dirty="0">
+                <a:solidFill>
+                  <a:srgbClr val="0B0B0B"/>
+                </a:solidFill>
+                <a:latin typeface="Calibri" pitchFamily="34" charset="0"/>
+                <a:ea typeface="Calibri" pitchFamily="34" charset="-122"/>
+                <a:cs typeface="Calibri" pitchFamily="34" charset="-120"/>
+              </a:rPr>
+              <a:t>Shipped: </a:t>
+            </a:r>
+            <a:pPr indent="0" marL="0">
+              <a:buNone/>
+            </a:pPr>
+            <a:r>
+              <a:rPr lang="en-US" sz="2400" dirty="0">
+                <a:solidFill>
+                  <a:srgbClr val="0B0B0B"/>
+                </a:solidFill>
+                <a:latin typeface="Calibri" pitchFamily="34" charset="0"/>
+                <a:ea typeface="Calibri" pitchFamily="34" charset="-122"/>
+                <a:cs typeface="Calibri" pitchFamily="34" charset="-120"/>
+              </a:rPr>
+              <a:t>validation fixture with Stable32/allantools outputs; per-τ comparison tables; benchmark scripts for both libraries; Monte Carlo harness, seed, tracked fit artifact.</a:t>
+            </a:r>
+            <a:endParaRPr lang="en-US" sz="2400" dirty="0"/>
+          </a:p>
+          <a:p>
+            <a:pPr marL="279400" indent="-279400">
+              <a:spcAft>
+                <a:spcPts val="700"/>
+              </a:spcAft>
+              <a:buSzPct val="100000"/>
+              <a:buChar char="•"/>
+            </a:pPr>
+            <a:r>
+              <a:rPr lang="en-US" sz="2400" b="1" dirty="0">
+                <a:solidFill>
+                  <a:srgbClr val="0B0B0B"/>
+                </a:solidFill>
+                <a:latin typeface="Calibri" pitchFamily="34" charset="0"/>
+                <a:ea typeface="Calibri" pitchFamily="34" charset="-122"/>
+                <a:cs typeface="Calibri" pitchFamily="34" charset="-120"/>
+              </a:rPr>
+              <a:t>Next: </a:t>
+            </a:r>
+            <a:pPr indent="0" marL="0">
+              <a:buNone/>
+            </a:pPr>
+            <a:r>
+              <a:rPr lang="en-US" sz="2400" dirty="0">
+                <a:solidFill>
+                  <a:srgbClr val="0B0B0B"/>
+                </a:solidFill>
+                <a:latin typeface="Calibri" pitchFamily="34" charset="0"/>
+                <a:ea typeface="Calibri" pitchFamily="34" charset="-122"/>
+                <a:cs typeface="Calibri" pitchFamily="34" charset="-120"/>
+              </a:rPr>
+              <a:t>real-time monitoring of laboratory Rb-87 clock comparisons; Monte Carlo calibration of the Thêo family and gapped records.</a:t>
+            </a:r>
+            <a:endParaRPr lang="en-US" sz="2400" dirty="0"/>
+          </a:p>
+        </p:txBody>
+      </p:sp>
+      <p:sp>
+        <p:nvSpPr>
+          <p:cNvPr id="46" name="Shape 35"/>
           <p:cNvSpPr/>
           <p:nvPr/>
         </p:nvSpPr>
@@ -8185,7 +8368,7 @@
       </p:sp>
       <p:sp>
         <p:nvSpPr>
-          <p:cNvPr id="43" name="References A"/>
+          <p:cNvPr id="47" name="References A"/>
           <p:cNvSpPr txBox="1"/>
           <p:nvPr/>
         </p:nvSpPr>
@@ -8304,7 +8487,7 @@
       </p:sp>
       <p:sp>
         <p:nvSpPr>
-          <p:cNvPr id="44" name="References B"/>
+          <p:cNvPr id="48" name="References B"/>
           <p:cNvSpPr txBox="1"/>
           <p:nvPr/>
         </p:nvSpPr>
@@ -8403,7 +8586,7 @@
       </p:sp>
       <p:sp>
         <p:nvSpPr>
-          <p:cNvPr id="45" name="Acknowledgments"/>
+          <p:cNvPr id="49" name="Acknowledgments"/>
           <p:cNvSpPr txBox="1"/>
           <p:nvPr/>
         </p:nvSpPr>

</xml_diff>

<commit_message>
Poster: re-timed benchmark and recalibrated MHTOTDEV numbers
- Fig. 3 and the speed panel from bench/README.md Table 1 and Table 2
  (re-timed on main with #57); 4-core diamonds use the recomputed
  speed-ups; legend and caption name the 12-thread workstation.
- MHTOTDEV table, R² floor and Figs. 4-5 (F4/F5) from the Kasdin-Walter
  recalibration (src/edf.jl, tools/artifacts/mhtotdev_mc_full.json).
- Comparison-table row renamed 'Modified Hadamard Class', as in README.md.
- Fig. 3 x label shortened to fit the figure width; value labels placed
  past the 4-core diamond.
</commit_message>
<xml_diff>
--- a/poster/SigmaTau_poster_draft.pptx
+++ b/poster/SigmaTau_poster_draft.pptx
@@ -2574,7 +2574,7 @@
                           <a:ea typeface="Calibri" pitchFamily="34" charset="-122"/>
                           <a:cs typeface="Calibri" pitchFamily="34" charset="-120"/>
                         </a:rPr>
-                        <a:t>MDEV-class Hadamard (MHDEV, HTDEV, MHTOTDEV)</a:t>
+                        <a:t>Modified Hadamard Class (MHDEV, HTDEV, MHTOTDEV)</a:t>
                       </a:r>
                       <a:endParaRPr lang="en-US" sz="1800" dirty="0">
                         <a:latin typeface="Calibri" charset="0"/>
@@ -4270,7 +4270,7 @@
       </p:sp>
       <p:pic>
         <p:nvPicPr>
-          <p:cNvPr id="14" name="F1_suite" descr="/home/user/SigmaTau.jl/poster/figures/F1_suite.png">    </p:cNvPr>
+          <p:cNvPr id="14" name="F1_suite" descr="/home/ian/SigmaTau.jl/poster/figures/F1_suite.png">    </p:cNvPr>
           <p:cNvPicPr>
             <a:picLocks noChangeAspect="1"/>
           </p:cNvPicPr>
@@ -4439,7 +4439,7 @@
       </p:sp>
       <p:pic>
         <p:nvPicPr>
-          <p:cNvPr id="19" name="F2_validation" descr="/home/user/SigmaTau.jl/poster/figures/F2_validation.png">    </p:cNvPr>
+          <p:cNvPr id="19" name="F2_validation" descr="/home/ian/SigmaTau.jl/poster/figures/F2_validation.png">    </p:cNvPr>
           <p:cNvPicPr>
             <a:picLocks noChangeAspect="1"/>
           </p:cNvPicPr>
@@ -4558,7 +4558,7 @@
                 <a:ea typeface="Calibri" pitchFamily="34" charset="-122"/>
                 <a:cs typeface="Calibri" pitchFamily="34" charset="-120"/>
               </a:rPr>
-              <a:t>4 × 10⁵-sample modified totals: 0.47 s vs 30 min</a:t>
+              <a:t>4 × 10⁵-sample modified totals: 0.46 s vs 30 min</a:t>
             </a:r>
             <a:endParaRPr lang="en-US" sz="3300" dirty="0"/>
           </a:p>
@@ -4600,7 +4600,7 @@
                 <a:ea typeface="Calibri" pitchFamily="34" charset="-122"/>
                 <a:cs typeface="Calibri" pitchFamily="34" charset="-120"/>
               </a:rPr>
-              <a:t>Measured 406 763-sample phase record, kernel-only timing, same samples, τ grid and statistic; allantools single-threaded (no parallel path). MTOTDEV 0.469 s vs 1 803.6 s (3,842×); HTOTDEV 0.455 s vs 1 928.0 s (4,233×). Reflected extension streamed per thread; window sum split across threads.</a:t>
+              <a:t>Measured 406 763-sample phase record, kernel-only timing, same samples, τ grid and statistic; allantools single-threaded (no parallel path). MTOTDEV 0.461 s vs 1 810 s (3,926×); HTOTDEV 0.461 s vs 1 926 s (4,178×). Reflected extension streamed per thread; window sum split across threads.</a:t>
             </a:r>
             <a:endParaRPr lang="en-US" sz="2400" dirty="0"/>
           </a:p>
@@ -4608,7 +4608,7 @@
       </p:sp>
       <p:pic>
         <p:nvPicPr>
-          <p:cNvPr id="24" name="F3_speed" descr="/home/user/SigmaTau.jl/poster/figures/F3_speed.png">    </p:cNvPr>
+          <p:cNvPr id="24" name="F3_speed" descr="/home/ian/SigmaTau.jl/poster/figures/F3_speed.png">    </p:cNvPr>
           <p:cNvPicPr>
             <a:picLocks noChangeAspect="1"/>
           </p:cNvPicPr>
@@ -4622,8 +4622,8 @@
         </p:blipFill>
         <p:spPr>
           <a:xfrm>
-            <a:off x="14943026" y="15307818"/>
-            <a:ext cx="6689948" cy="3749040"/>
+            <a:off x="15170919" y="15307818"/>
+            <a:ext cx="6234161" cy="3749040"/>
           </a:xfrm>
           <a:prstGeom prst="rect">
             <a:avLst/>
@@ -4663,7 +4663,7 @@
                 <a:ea typeface="Calibri" pitchFamily="34" charset="-122"/>
                 <a:cs typeface="Calibri" pitchFamily="34" charset="-120"/>
               </a:rPr>
-              <a:t>Fig. 3. Speed-up per kernel, N = 25 000 white-PM record (bench/), 12-core workstation; diamonds: independent 4-core re-run. Ratios portable; absolute times machine-dependent.</a:t>
+              <a:t>Fig. 3. Speed-up per kernel, N = 25 000 white-PM record (bench/), 12-thread workstation; diamonds: 4-core container run. Ratios portable; absolute times machine-dependent.</a:t>
             </a:r>
             <a:endParaRPr lang="en-US" sz="1950" dirty="0"/>
           </a:p>
@@ -4735,7 +4735,7 @@
       </p:sp>
       <p:pic>
         <p:nvPicPr>
-          <p:cNvPr id="28" name="F8_explorer" descr="/home/user/SigmaTau.jl/poster/figures/F8_explorer.png">    </p:cNvPr>
+          <p:cNvPr id="28" name="F8_explorer" descr="/home/ian/SigmaTau.jl/poster/figures/F8_explorer.png">    </p:cNvPr>
           <p:cNvPicPr>
             <a:picLocks noChangeAspect="1"/>
           </p:cNvPicPr>
@@ -5036,7 +5036,7 @@
                 <a:ea typeface="Calibri" pitchFamily="34" charset="-122"/>
                 <a:cs typeface="Calibri" pitchFamily="34" charset="-120"/>
               </a:rPr>
-              <a:t>PM unbiased, red FM reads high; EDF R² ≥ 0.9982</a:t>
+              <a:t>PM unbiased, red FM reads high; EDF R² ≥ 0.9988</a:t>
             </a:r>
             <a:endParaRPr lang="en-US" sz="3300" dirty="0"/>
           </a:p>
@@ -5044,7 +5044,7 @@
       </p:sp>
       <p:pic>
         <p:nvPicPr>
-          <p:cNvPr id="35" name="F4_mhtot_bias" descr="/home/user/SigmaTau.jl/poster/figures/F4_mhtot_bias.png">    </p:cNvPr>
+          <p:cNvPr id="35" name="F4_mhtot_bias" descr="/home/ian/SigmaTau.jl/poster/figures/F4_mhtot_bias.png">    </p:cNvPr>
           <p:cNvPicPr>
             <a:picLocks noChangeAspect="1"/>
           </p:cNvPicPr>
@@ -5058,8 +5058,8 @@
         </p:blipFill>
         <p:spPr>
           <a:xfrm>
-            <a:off x="25377118" y="9627362"/>
-            <a:ext cx="4109765" cy="3566160"/>
+            <a:off x="25350533" y="9627362"/>
+            <a:ext cx="4162934" cy="3566160"/>
           </a:xfrm>
           <a:prstGeom prst="rect">
             <a:avLst/>
@@ -5068,7 +5068,7 @@
       </p:pic>
       <p:pic>
         <p:nvPicPr>
-          <p:cNvPr id="36" name="F5_mhtot_edf" descr="/home/user/SigmaTau.jl/poster/figures/F5_mhtot_edf.png">    </p:cNvPr>
+          <p:cNvPr id="36" name="F5_mhtot_edf" descr="/home/ian/SigmaTau.jl/poster/figures/F5_mhtot_edf.png">    </p:cNvPr>
           <p:cNvPicPr>
             <a:picLocks noChangeAspect="1"/>
           </p:cNvPicPr>
@@ -5082,8 +5082,8 @@
         </p:blipFill>
         <p:spPr>
           <a:xfrm>
-            <a:off x="30743750" y="9627362"/>
-            <a:ext cx="4105461" cy="3566160"/>
+            <a:off x="30712116" y="9627362"/>
+            <a:ext cx="4168728" cy="3566160"/>
           </a:xfrm>
           <a:prstGeom prst="rect">
             <a:avLst/>
@@ -5792,7 +5792,7 @@
                           <a:ea typeface="Calibri" pitchFamily="34" charset="-122"/>
                           <a:cs typeface="Calibri" pitchFamily="34" charset="-120"/>
                         </a:rPr>
-                        <a:t>1.0308</a:t>
+                        <a:t>1.0249</a:t>
                       </a:r>
                       <a:endParaRPr lang="en-US" sz="1800" dirty="0">
                         <a:latin typeface="Calibri" charset="0"/>
@@ -5860,7 +5860,7 @@
                           <a:ea typeface="Calibri" pitchFamily="34" charset="-122"/>
                           <a:cs typeface="Calibri" pitchFamily="34" charset="-120"/>
                         </a:rPr>
-                        <a:t>−0.1197</a:t>
+                        <a:t>−0.0078</a:t>
                       </a:r>
                       <a:endParaRPr lang="en-US" sz="1800" dirty="0">
                         <a:latin typeface="Calibri" charset="0"/>
@@ -5928,7 +5928,7 @@
                           <a:ea typeface="Calibri" pitchFamily="34" charset="-122"/>
                           <a:cs typeface="Calibri" pitchFamily="34" charset="-120"/>
                         </a:rPr>
-                        <a:t>1.6869</a:t>
+                        <a:t>1.6342</a:t>
                       </a:r>
                       <a:endParaRPr lang="en-US" sz="1800" dirty="0">
                         <a:latin typeface="Calibri" charset="0"/>
@@ -5996,7 +5996,7 @@
                           <a:ea typeface="Calibri" pitchFamily="34" charset="-122"/>
                           <a:cs typeface="Calibri" pitchFamily="34" charset="-120"/>
                         </a:rPr>
-                        <a:t>4.3166</a:t>
+                        <a:t>3.8334</a:t>
                       </a:r>
                       <a:endParaRPr lang="en-US" sz="1800" dirty="0">
                         <a:latin typeface="Calibri" charset="0"/>
@@ -6064,7 +6064,7 @@
                           <a:ea typeface="Calibri" pitchFamily="34" charset="-122"/>
                           <a:cs typeface="Calibri" pitchFamily="34" charset="-120"/>
                         </a:rPr>
-                        <a:t>0.9982</a:t>
+                        <a:t>0.9989</a:t>
                       </a:r>
                       <a:endParaRPr lang="en-US" sz="1800" dirty="0">
                         <a:latin typeface="Calibri" charset="0"/>
@@ -6270,7 +6270,7 @@
                           <a:ea typeface="Calibri" pitchFamily="34" charset="-122"/>
                           <a:cs typeface="Calibri" pitchFamily="34" charset="-120"/>
                         </a:rPr>
-                        <a:t>0.9883</a:t>
+                        <a:t>0.9879</a:t>
                       </a:r>
                       <a:endParaRPr lang="en-US" sz="1800" dirty="0">
                         <a:latin typeface="Calibri" charset="0"/>
@@ -6338,7 +6338,7 @@
                           <a:ea typeface="Calibri" pitchFamily="34" charset="-122"/>
                           <a:cs typeface="Calibri" pitchFamily="34" charset="-120"/>
                         </a:rPr>
-                        <a:t>−0.0686</a:t>
+                        <a:t>−0.0630</a:t>
                       </a:r>
                       <a:endParaRPr lang="en-US" sz="1800" dirty="0">
                         <a:latin typeface="Calibri" charset="0"/>
@@ -6406,7 +6406,7 @@
                           <a:ea typeface="Calibri" pitchFamily="34" charset="-122"/>
                           <a:cs typeface="Calibri" pitchFamily="34" charset="-120"/>
                         </a:rPr>
-                        <a:t>1.1671</a:t>
+                        <a:t>1.1651</a:t>
                       </a:r>
                       <a:endParaRPr lang="en-US" sz="1800" dirty="0">
                         <a:latin typeface="Calibri" charset="0"/>
@@ -6474,7 +6474,7 @@
                           <a:ea typeface="Calibri" pitchFamily="34" charset="-122"/>
                           <a:cs typeface="Calibri" pitchFamily="34" charset="-120"/>
                         </a:rPr>
-                        <a:t>3.2107</a:t>
+                        <a:t>3.1934</a:t>
                       </a:r>
                       <a:endParaRPr lang="en-US" sz="1800" dirty="0">
                         <a:latin typeface="Calibri" charset="0"/>
@@ -7226,7 +7226,7 @@
                           <a:ea typeface="Calibri" pitchFamily="34" charset="-122"/>
                           <a:cs typeface="Calibri" pitchFamily="34" charset="-120"/>
                         </a:rPr>
-                        <a:t>1.2947</a:t>
+                        <a:t>1.2946</a:t>
                       </a:r>
                       <a:endParaRPr lang="en-US" sz="1800" dirty="0">
                         <a:latin typeface="Calibri" charset="0"/>
@@ -7294,7 +7294,7 @@
                           <a:ea typeface="Calibri" pitchFamily="34" charset="-122"/>
                           <a:cs typeface="Calibri" pitchFamily="34" charset="-120"/>
                         </a:rPr>
-                        <a:t>−0.7193</a:t>
+                        <a:t>−0.7752</a:t>
                       </a:r>
                       <a:endParaRPr lang="en-US" sz="1800" dirty="0">
                         <a:latin typeface="Calibri" charset="0"/>
@@ -7362,7 +7362,7 @@
                           <a:ea typeface="Calibri" pitchFamily="34" charset="-122"/>
                           <a:cs typeface="Calibri" pitchFamily="34" charset="-120"/>
                         </a:rPr>
-                        <a:t>1.0095</a:t>
+                        <a:t>1.0096</a:t>
                       </a:r>
                       <a:endParaRPr lang="en-US" sz="1800" dirty="0">
                         <a:latin typeface="Calibri" charset="0"/>
@@ -7430,7 +7430,7 @@
                           <a:ea typeface="Calibri" pitchFamily="34" charset="-122"/>
                           <a:cs typeface="Calibri" pitchFamily="34" charset="-120"/>
                         </a:rPr>
-                        <a:t>3.3254</a:t>
+                        <a:t>3.3662</a:t>
                       </a:r>
                       <a:endParaRPr lang="en-US" sz="1800" dirty="0">
                         <a:latin typeface="Calibri" charset="0"/>
@@ -7498,7 +7498,7 @@
                           <a:ea typeface="Calibri" pitchFamily="34" charset="-122"/>
                           <a:cs typeface="Calibri" pitchFamily="34" charset="-120"/>
                         </a:rPr>
-                        <a:t>0.9991</a:t>
+                        <a:t>0.9992</a:t>
                       </a:r>
                       <a:endParaRPr lang="en-US" sz="1800" dirty="0">
                         <a:latin typeface="Calibri" charset="0"/>
@@ -7704,7 +7704,7 @@
                           <a:ea typeface="Calibri" pitchFamily="34" charset="-122"/>
                           <a:cs typeface="Calibri" pitchFamily="34" charset="-120"/>
                         </a:rPr>
-                        <a:t>2.1686</a:t>
+                        <a:t>2.1678</a:t>
                       </a:r>
                       <a:endParaRPr lang="en-US" sz="1800" dirty="0">
                         <a:latin typeface="Calibri" charset="0"/>
@@ -7772,7 +7772,7 @@
                           <a:ea typeface="Calibri" pitchFamily="34" charset="-122"/>
                           <a:cs typeface="Calibri" pitchFamily="34" charset="-120"/>
                         </a:rPr>
-                        <a:t>−5.5884</a:t>
+                        <a:t>−5.6243</a:t>
                       </a:r>
                       <a:endParaRPr lang="en-US" sz="1800" dirty="0">
                         <a:latin typeface="Calibri" charset="0"/>
@@ -7840,7 +7840,7 @@
                           <a:ea typeface="Calibri" pitchFamily="34" charset="-122"/>
                           <a:cs typeface="Calibri" pitchFamily="34" charset="-120"/>
                         </a:rPr>
-                        <a:t>0.7631</a:t>
+                        <a:t>0.7641</a:t>
                       </a:r>
                       <a:endParaRPr lang="en-US" sz="1800" dirty="0">
                         <a:latin typeface="Calibri" charset="0"/>
@@ -7908,7 +7908,7 @@
                           <a:ea typeface="Calibri" pitchFamily="34" charset="-122"/>
                           <a:cs typeface="Calibri" pitchFamily="34" charset="-120"/>
                         </a:rPr>
-                        <a:t>2.4490</a:t>
+                        <a:t>2.4152</a:t>
                       </a:r>
                       <a:endParaRPr lang="en-US" sz="1800" dirty="0">
                         <a:latin typeface="Calibri" charset="0"/>
@@ -7976,7 +7976,7 @@
                           <a:ea typeface="Calibri" pitchFamily="34" charset="-122"/>
                           <a:cs typeface="Calibri" pitchFamily="34" charset="-120"/>
                         </a:rPr>
-                        <a:t>0.9985</a:t>
+                        <a:t>0.9988</a:t>
                       </a:r>
                       <a:endParaRPr lang="en-US" sz="1800" dirty="0">
                         <a:latin typeface="Calibri" charset="0"/>
@@ -8098,7 +8098,7 @@
       </p:sp>
       <p:pic>
         <p:nvPicPr>
-          <p:cNvPr id="41" name="F7_dynamic" descr="/home/user/SigmaTau.jl/poster/figures/F7_dynamic.png">    </p:cNvPr>
+          <p:cNvPr id="41" name="F7_dynamic" descr="/home/ian/SigmaTau.jl/poster/figures/F7_dynamic.png">    </p:cNvPr>
           <p:cNvPicPr>
             <a:picLocks noChangeAspect="1"/>
           </p:cNvPicPr>

</xml_diff>